<commit_message>
Add 10 scenario-based practice questions and answers for Vertex AI Feature Store to both HTML slides and compiled PPTX deck
</commit_message>
<xml_diff>
--- a/featurestore-presentation/Vertex_AI_Feature_Store.pptx
+++ b/featurestore-presentation/Vertex_AI_Feature_Store.pptx
@@ -17,6 +17,16 @@
     <p:sldId id="265" r:id="rId16"/>
     <p:sldId id="266" r:id="rId17"/>
     <p:sldId id="267" r:id="rId18"/>
+    <p:sldId id="268" r:id="rId19"/>
+    <p:sldId id="269" r:id="rId20"/>
+    <p:sldId id="270" r:id="rId21"/>
+    <p:sldId id="271" r:id="rId22"/>
+    <p:sldId id="272" r:id="rId23"/>
+    <p:sldId id="273" r:id="rId24"/>
+    <p:sldId id="274" r:id="rId25"/>
+    <p:sldId id="275" r:id="rId26"/>
+    <p:sldId id="276" r:id="rId27"/>
+    <p:sldId id="277" r:id="rId28"/>
   </p:sldIdLst>
   <p:sldSz cx="12191695" cy="6858000" type="screen4x3"/>
   <p:notesSz cx="6858000" cy="9144000"/>
@@ -4325,6 +4335,2344 @@
 </p:sld>
 </file>
 
+<file path=ppt/slides/slide13.xml><?xml version="1.0" encoding="utf-8"?>
+<p:sld xmlns:a="http://schemas.openxmlformats.org/drawingml/2006/main" xmlns:p="http://schemas.openxmlformats.org/presentationml/2006/main" xmlns:r="http://schemas.openxmlformats.org/officeDocument/2006/relationships">
+  <p:cSld>
+    <p:bg>
+      <p:bgPr>
+        <a:solidFill>
+          <a:srgbClr val="E4E4E6"/>
+        </a:solidFill>
+        <a:effectLst/>
+      </p:bgPr>
+    </p:bg>
+    <p:spTree>
+      <p:nvGrpSpPr>
+        <p:cNvPr id="1" name=""/>
+        <p:cNvGrpSpPr/>
+        <p:nvPr/>
+      </p:nvGrpSpPr>
+      <p:grpSpPr/>
+      <p:sp>
+        <p:nvSpPr>
+          <p:cNvPr id="2" name="TextBox 1"/>
+          <p:cNvSpPr txBox="1"/>
+          <p:nvPr/>
+        </p:nvSpPr>
+        <p:spPr>
+          <a:xfrm>
+            <a:off x="731520" y="365760"/>
+            <a:ext cx="10698480" cy="274320"/>
+          </a:xfrm>
+          <a:prstGeom prst="rect">
+            <a:avLst/>
+          </a:prstGeom>
+          <a:noFill/>
+        </p:spPr>
+        <p:txBody>
+          <a:bodyPr wrap="square" lIns="0" rIns="0" tIns="0" bIns="0">
+            <a:spAutoFit/>
+          </a:bodyPr>
+          <a:lstStyle/>
+          <a:p>
+            <a:r>
+              <a:rPr sz="1000" b="1" i="0">
+                <a:solidFill>
+                  <a:srgbClr val="1D4ED8"/>
+                </a:solidFill>
+                <a:latin typeface="Segoe UI"/>
+              </a:rPr>
+              <a:t>PRACTICE SCENARIO 1 OF 10</a:t>
+            </a:r>
+          </a:p>
+        </p:txBody>
+      </p:sp>
+      <p:sp>
+        <p:nvSpPr>
+          <p:cNvPr id="3" name="TextBox 2"/>
+          <p:cNvSpPr txBox="1"/>
+          <p:nvPr/>
+        </p:nvSpPr>
+        <p:spPr>
+          <a:xfrm>
+            <a:off x="731520" y="640080"/>
+            <a:ext cx="10698480" cy="548640"/>
+          </a:xfrm>
+          <a:prstGeom prst="rect">
+            <a:avLst/>
+          </a:prstGeom>
+          <a:noFill/>
+        </p:spPr>
+        <p:txBody>
+          <a:bodyPr wrap="square" lIns="0" rIns="0" tIns="0" bIns="0">
+            <a:spAutoFit/>
+          </a:bodyPr>
+          <a:lstStyle/>
+          <a:p>
+            <a:r>
+              <a:rPr sz="2800" b="1" i="0">
+                <a:solidFill>
+                  <a:srgbClr val="18181B"/>
+                </a:solidFill>
+                <a:latin typeface="Segoe UI"/>
+              </a:rPr>
+              <a:t>Minimizing Online Serving Latency</a:t>
+            </a:r>
+          </a:p>
+        </p:txBody>
+      </p:sp>
+      <p:sp>
+        <p:nvSpPr>
+          <p:cNvPr id="4" name="TextBox 3"/>
+          <p:cNvSpPr txBox="1"/>
+          <p:nvPr/>
+        </p:nvSpPr>
+        <p:spPr>
+          <a:xfrm>
+            <a:off x="731520" y="1371600"/>
+            <a:ext cx="6217920" cy="4754880"/>
+          </a:xfrm>
+          <a:prstGeom prst="rect">
+            <a:avLst/>
+          </a:prstGeom>
+          <a:noFill/>
+        </p:spPr>
+        <p:txBody>
+          <a:bodyPr wrap="square" lIns="0" rIns="0" tIns="0" bIns="0">
+            <a:spAutoFit/>
+          </a:bodyPr>
+          <a:lstStyle/>
+          <a:p>
+            <a:pPr>
+              <a:spcAft>
+                <a:spcPts val="1400"/>
+              </a:spcAft>
+            </a:pPr>
+            <a:r>
+              <a:rPr sz="1200" b="1" i="0">
+                <a:solidFill>
+                  <a:srgbClr val="18181B"/>
+                </a:solidFill>
+                <a:latin typeface="Segoe UI"/>
+              </a:rPr>
+              <a:t>A financial company is deploying an online transaction fraud detection model on Vertex AI. The model needs to retrieve customer feature values (e.g., transaction frequency in the last 10 minutes) with sub-10ms latency during prediction queries. How should the architecture be designed using Vertex AI Feature Store?</a:t>
+            </a:r>
+          </a:p>
+          <a:p>
+            <a:pPr>
+              <a:spcAft>
+                <a:spcPts val="800"/>
+              </a:spcAft>
+            </a:pPr>
+            <a:r>
+              <a:rPr sz="1100" b="1" i="0">
+                <a:solidFill>
+                  <a:srgbClr val="1D4ED8"/>
+                </a:solidFill>
+                <a:latin typeface="Segoe UI"/>
+              </a:rPr>
+              <a:t>A.  </a:t>
+            </a:r>
+            <a:r>
+              <a:rPr sz="1100" b="0" i="0">
+                <a:solidFill>
+                  <a:srgbClr val="3F3F46"/>
+                </a:solidFill>
+                <a:latin typeface="Segoe UI"/>
+              </a:rPr>
+              <a:t>Configure offline serving batch exports to sync historical data to Cloud Storage and serve them directly from custom GKE nodes.</a:t>
+            </a:r>
+          </a:p>
+          <a:p>
+            <a:pPr>
+              <a:spcAft>
+                <a:spcPts val="800"/>
+              </a:spcAft>
+            </a:pPr>
+            <a:r>
+              <a:rPr sz="1100" b="1" i="0">
+                <a:solidFill>
+                  <a:srgbClr val="1D4ED8"/>
+                </a:solidFill>
+                <a:latin typeface="Segoe UI"/>
+              </a:rPr>
+              <a:t>B.  </a:t>
+            </a:r>
+            <a:r>
+              <a:rPr sz="1100" b="0" i="0">
+                <a:solidFill>
+                  <a:srgbClr val="3F3F46"/>
+                </a:solidFill>
+                <a:latin typeface="Segoe UI"/>
+              </a:rPr>
+              <a:t>Set up a Feature Group pointing to BigQuery, register Feature Views, and enable Online Serving using Bigtable as the online store database.</a:t>
+            </a:r>
+          </a:p>
+          <a:p>
+            <a:pPr>
+              <a:spcAft>
+                <a:spcPts val="800"/>
+              </a:spcAft>
+            </a:pPr>
+            <a:r>
+              <a:rPr sz="1100" b="1" i="0">
+                <a:solidFill>
+                  <a:srgbClr val="1D4ED8"/>
+                </a:solidFill>
+                <a:latin typeface="Segoe UI"/>
+              </a:rPr>
+              <a:t>C.  </a:t>
+            </a:r>
+            <a:r>
+              <a:rPr sz="1100" b="0" i="0">
+                <a:solidFill>
+                  <a:srgbClr val="3F3F46"/>
+                </a:solidFill>
+                <a:latin typeface="Segoe UI"/>
+              </a:rPr>
+              <a:t>Query BigQuery ML models directly using standard SQL procedures from GCF functions.</a:t>
+            </a:r>
+          </a:p>
+          <a:p>
+            <a:pPr>
+              <a:spcAft>
+                <a:spcPts val="800"/>
+              </a:spcAft>
+            </a:pPr>
+            <a:r>
+              <a:rPr sz="1100" b="1" i="0">
+                <a:solidFill>
+                  <a:srgbClr val="1D4ED8"/>
+                </a:solidFill>
+                <a:latin typeface="Segoe UI"/>
+              </a:rPr>
+              <a:t>D.  </a:t>
+            </a:r>
+            <a:r>
+              <a:rPr sz="1100" b="0" i="0">
+                <a:solidFill>
+                  <a:srgbClr val="3F3F46"/>
+                </a:solidFill>
+                <a:latin typeface="Segoe UI"/>
+              </a:rPr>
+              <a:t>Use Memorystore for Redis manually and write Spark Streaming ETL scripts to populate user features from GCS.</a:t>
+            </a:r>
+          </a:p>
+        </p:txBody>
+      </p:sp>
+      <p:sp>
+        <p:nvSpPr>
+          <p:cNvPr id="5" name="Rounded Rectangle 4"/>
+          <p:cNvSpPr/>
+          <p:nvPr/>
+        </p:nvSpPr>
+        <p:spPr>
+          <a:xfrm>
+            <a:off x="7315200" y="1645920"/>
+            <a:ext cx="4114800" cy="4480560"/>
+          </a:xfrm>
+          <a:prstGeom prst="roundRect">
+            <a:avLst/>
+          </a:prstGeom>
+          <a:solidFill>
+            <a:srgbClr val="FFFFFF"/>
+          </a:solidFill>
+          <a:ln w="15240">
+            <a:solidFill>
+              <a:srgbClr val="D4D4D8"/>
+            </a:solidFill>
+          </a:ln>
+        </p:spPr>
+        <p:style>
+          <a:lnRef idx="1">
+            <a:schemeClr val="accent1"/>
+          </a:lnRef>
+          <a:fillRef idx="3">
+            <a:schemeClr val="accent1"/>
+          </a:fillRef>
+          <a:effectRef idx="2">
+            <a:schemeClr val="accent1"/>
+          </a:effectRef>
+          <a:fontRef idx="minor">
+            <a:schemeClr val="lt1"/>
+          </a:fontRef>
+        </p:style>
+        <p:txBody>
+          <a:bodyPr rtlCol="0" anchor="ctr" wrap="square" lIns="228600" rIns="228600" tIns="182880" bIns="182880"/>
+          <a:lstStyle/>
+          <a:p>
+            <a:pPr algn="ctr">
+              <a:spcAft>
+                <a:spcPts val="1200"/>
+              </a:spcAft>
+            </a:pPr>
+            <a:r>
+              <a:rPr sz="1600" b="1" i="0">
+                <a:solidFill>
+                  <a:srgbClr val="18181B"/>
+                </a:solidFill>
+                <a:latin typeface="Segoe UI"/>
+              </a:rPr>
+              <a:t>Validation Panel</a:t>
+            </a:r>
+          </a:p>
+          <a:p>
+            <a:pPr>
+              <a:spcAft>
+                <a:spcPts val="1000"/>
+              </a:spcAft>
+            </a:pPr>
+            <a:r>
+              <a:rPr sz="1400" b="1" i="0">
+                <a:solidFill>
+                  <a:srgbClr val="047857"/>
+                </a:solidFill>
+                <a:latin typeface="Segoe UI"/>
+              </a:rPr>
+              <a:t>Correct Answer: B</a:t>
+            </a:r>
+          </a:p>
+          <a:p>
+            <a:pPr>
+              <a:spcAft>
+                <a:spcPts val="1400"/>
+              </a:spcAft>
+            </a:pPr>
+            <a:r>
+              <a:rPr sz="1100" b="0" i="0">
+                <a:solidFill>
+                  <a:srgbClr val="3F3F46"/>
+                </a:solidFill>
+                <a:latin typeface="Segoe UI"/>
+              </a:rPr>
+              <a:t>Explanation: Under the latest BigQuery-centric Feature Store architecture, developers create a Feature Group mapping BigQuery views, then create a Feature View and provision an online store database instance (backed by optimized Cloud Bigtable or Redis) for sub-10ms gRPC read requests.</a:t>
+            </a:r>
+          </a:p>
+          <a:p>
+            <a:r>
+              <a:rPr sz="950" b="0" i="1">
+                <a:solidFill>
+                  <a:srgbClr val="71717A"/>
+                </a:solidFill>
+                <a:latin typeface="Segoe UI"/>
+              </a:rPr>
+              <a:t>GCP Reference: https://cloud.google.com/vertex-ai/docs/featurestore/latest/read-feature-values</a:t>
+            </a:r>
+          </a:p>
+        </p:txBody>
+      </p:sp>
+    </p:spTree>
+  </p:cSld>
+  <p:clrMapOvr>
+    <a:masterClrMapping/>
+  </p:clrMapOvr>
+</p:sld>
+</file>
+
+<file path=ppt/slides/slide14.xml><?xml version="1.0" encoding="utf-8"?>
+<p:sld xmlns:a="http://schemas.openxmlformats.org/drawingml/2006/main" xmlns:p="http://schemas.openxmlformats.org/presentationml/2006/main" xmlns:r="http://schemas.openxmlformats.org/officeDocument/2006/relationships">
+  <p:cSld>
+    <p:bg>
+      <p:bgPr>
+        <a:solidFill>
+          <a:srgbClr val="E4E4E6"/>
+        </a:solidFill>
+        <a:effectLst/>
+      </p:bgPr>
+    </p:bg>
+    <p:spTree>
+      <p:nvGrpSpPr>
+        <p:cNvPr id="1" name=""/>
+        <p:cNvGrpSpPr/>
+        <p:nvPr/>
+      </p:nvGrpSpPr>
+      <p:grpSpPr/>
+      <p:sp>
+        <p:nvSpPr>
+          <p:cNvPr id="2" name="TextBox 1"/>
+          <p:cNvSpPr txBox="1"/>
+          <p:nvPr/>
+        </p:nvSpPr>
+        <p:spPr>
+          <a:xfrm>
+            <a:off x="731520" y="365760"/>
+            <a:ext cx="10698480" cy="274320"/>
+          </a:xfrm>
+          <a:prstGeom prst="rect">
+            <a:avLst/>
+          </a:prstGeom>
+          <a:noFill/>
+        </p:spPr>
+        <p:txBody>
+          <a:bodyPr wrap="square" lIns="0" rIns="0" tIns="0" bIns="0">
+            <a:spAutoFit/>
+          </a:bodyPr>
+          <a:lstStyle/>
+          <a:p>
+            <a:r>
+              <a:rPr sz="1000" b="1" i="0">
+                <a:solidFill>
+                  <a:srgbClr val="1D4ED8"/>
+                </a:solidFill>
+                <a:latin typeface="Segoe UI"/>
+              </a:rPr>
+              <a:t>PRACTICE SCENARIO 2 OF 10</a:t>
+            </a:r>
+          </a:p>
+        </p:txBody>
+      </p:sp>
+      <p:sp>
+        <p:nvSpPr>
+          <p:cNvPr id="3" name="TextBox 2"/>
+          <p:cNvSpPr txBox="1"/>
+          <p:nvPr/>
+        </p:nvSpPr>
+        <p:spPr>
+          <a:xfrm>
+            <a:off x="731520" y="640080"/>
+            <a:ext cx="10698480" cy="548640"/>
+          </a:xfrm>
+          <a:prstGeom prst="rect">
+            <a:avLst/>
+          </a:prstGeom>
+          <a:noFill/>
+        </p:spPr>
+        <p:txBody>
+          <a:bodyPr wrap="square" lIns="0" rIns="0" tIns="0" bIns="0">
+            <a:spAutoFit/>
+          </a:bodyPr>
+          <a:lstStyle/>
+          <a:p>
+            <a:r>
+              <a:rPr sz="2800" b="1" i="0">
+                <a:solidFill>
+                  <a:srgbClr val="18181B"/>
+                </a:solidFill>
+                <a:latin typeface="Segoe UI"/>
+              </a:rPr>
+              <a:t>Data Leakage Prevention</a:t>
+            </a:r>
+          </a:p>
+        </p:txBody>
+      </p:sp>
+      <p:sp>
+        <p:nvSpPr>
+          <p:cNvPr id="4" name="TextBox 3"/>
+          <p:cNvSpPr txBox="1"/>
+          <p:nvPr/>
+        </p:nvSpPr>
+        <p:spPr>
+          <a:xfrm>
+            <a:off x="731520" y="1371600"/>
+            <a:ext cx="6217920" cy="4754880"/>
+          </a:xfrm>
+          <a:prstGeom prst="rect">
+            <a:avLst/>
+          </a:prstGeom>
+          <a:noFill/>
+        </p:spPr>
+        <p:txBody>
+          <a:bodyPr wrap="square" lIns="0" rIns="0" tIns="0" bIns="0">
+            <a:spAutoFit/>
+          </a:bodyPr>
+          <a:lstStyle/>
+          <a:p>
+            <a:pPr>
+              <a:spcAft>
+                <a:spcPts val="1400"/>
+              </a:spcAft>
+            </a:pPr>
+            <a:r>
+              <a:rPr sz="1200" b="1" i="0">
+                <a:solidFill>
+                  <a:srgbClr val="18181B"/>
+                </a:solidFill>
+                <a:latin typeface="Segoe UI"/>
+              </a:rPr>
+              <a:t>An ML engineer is building a pipeline to retrain a customer recommendation model. The training dataset combines user profile features from a feature store with historical purchase event logs. How can the engineer prevent data leakage during training set generation?</a:t>
+            </a:r>
+          </a:p>
+          <a:p>
+            <a:pPr>
+              <a:spcAft>
+                <a:spcPts val="800"/>
+              </a:spcAft>
+            </a:pPr>
+            <a:r>
+              <a:rPr sz="1100" b="1" i="0">
+                <a:solidFill>
+                  <a:srgbClr val="1D4ED8"/>
+                </a:solidFill>
+                <a:latin typeface="Segoe UI"/>
+              </a:rPr>
+              <a:t>A.  </a:t>
+            </a:r>
+            <a:r>
+              <a:rPr sz="1100" b="0" i="0">
+                <a:solidFill>
+                  <a:srgbClr val="3F3F46"/>
+                </a:solidFill>
+                <a:latin typeface="Segoe UI"/>
+              </a:rPr>
+              <a:t>Perform standard SQL inner joins in BigQuery without specifying event times, relying on manual date filters.</a:t>
+            </a:r>
+          </a:p>
+          <a:p>
+            <a:pPr>
+              <a:spcAft>
+                <a:spcPts val="800"/>
+              </a:spcAft>
+            </a:pPr>
+            <a:r>
+              <a:rPr sz="1100" b="1" i="0">
+                <a:solidFill>
+                  <a:srgbClr val="1D4ED8"/>
+                </a:solidFill>
+                <a:latin typeface="Segoe UI"/>
+              </a:rPr>
+              <a:t>B.  </a:t>
+            </a:r>
+            <a:r>
+              <a:rPr sz="1100" b="0" i="0">
+                <a:solidFill>
+                  <a:srgbClr val="3F3F46"/>
+                </a:solidFill>
+                <a:latin typeface="Segoe UI"/>
+              </a:rPr>
+              <a:t>Read the latest active feature states from the online database at the time of running the training job.</a:t>
+            </a:r>
+          </a:p>
+          <a:p>
+            <a:pPr>
+              <a:spcAft>
+                <a:spcPts val="800"/>
+              </a:spcAft>
+            </a:pPr>
+            <a:r>
+              <a:rPr sz="1100" b="1" i="0">
+                <a:solidFill>
+                  <a:srgbClr val="1D4ED8"/>
+                </a:solidFill>
+                <a:latin typeface="Segoe UI"/>
+              </a:rPr>
+              <a:t>C.  </a:t>
+            </a:r>
+            <a:r>
+              <a:rPr sz="1100" b="0" i="0">
+                <a:solidFill>
+                  <a:srgbClr val="3F3F46"/>
+                </a:solidFill>
+                <a:latin typeface="Segoe UI"/>
+              </a:rPr>
+              <a:t>Execute point-in-time joins using Feature Store offline serving, specifying the historical event timestamps to extract features as they existed at each event time.</a:t>
+            </a:r>
+          </a:p>
+          <a:p>
+            <a:pPr>
+              <a:spcAft>
+                <a:spcPts val="800"/>
+              </a:spcAft>
+            </a:pPr>
+            <a:r>
+              <a:rPr sz="1100" b="1" i="0">
+                <a:solidFill>
+                  <a:srgbClr val="1D4ED8"/>
+                </a:solidFill>
+                <a:latin typeface="Segoe UI"/>
+              </a:rPr>
+              <a:t>D.  </a:t>
+            </a:r>
+            <a:r>
+              <a:rPr sz="1100" b="0" i="0">
+                <a:solidFill>
+                  <a:srgbClr val="3F3F46"/>
+                </a:solidFill>
+                <a:latin typeface="Segoe UI"/>
+              </a:rPr>
+              <a:t>Set up a daily batch cron job that overwrites all user profile values inside a single GCS export bucket.</a:t>
+            </a:r>
+          </a:p>
+        </p:txBody>
+      </p:sp>
+      <p:sp>
+        <p:nvSpPr>
+          <p:cNvPr id="5" name="Rounded Rectangle 4"/>
+          <p:cNvSpPr/>
+          <p:nvPr/>
+        </p:nvSpPr>
+        <p:spPr>
+          <a:xfrm>
+            <a:off x="7315200" y="1645920"/>
+            <a:ext cx="4114800" cy="4480560"/>
+          </a:xfrm>
+          <a:prstGeom prst="roundRect">
+            <a:avLst/>
+          </a:prstGeom>
+          <a:solidFill>
+            <a:srgbClr val="FFFFFF"/>
+          </a:solidFill>
+          <a:ln w="15240">
+            <a:solidFill>
+              <a:srgbClr val="D4D4D8"/>
+            </a:solidFill>
+          </a:ln>
+        </p:spPr>
+        <p:style>
+          <a:lnRef idx="1">
+            <a:schemeClr val="accent1"/>
+          </a:lnRef>
+          <a:fillRef idx="3">
+            <a:schemeClr val="accent1"/>
+          </a:fillRef>
+          <a:effectRef idx="2">
+            <a:schemeClr val="accent1"/>
+          </a:effectRef>
+          <a:fontRef idx="minor">
+            <a:schemeClr val="lt1"/>
+          </a:fontRef>
+        </p:style>
+        <p:txBody>
+          <a:bodyPr rtlCol="0" anchor="ctr" wrap="square" lIns="228600" rIns="228600" tIns="182880" bIns="182880"/>
+          <a:lstStyle/>
+          <a:p>
+            <a:pPr algn="ctr">
+              <a:spcAft>
+                <a:spcPts val="1200"/>
+              </a:spcAft>
+            </a:pPr>
+            <a:r>
+              <a:rPr sz="1600" b="1" i="0">
+                <a:solidFill>
+                  <a:srgbClr val="18181B"/>
+                </a:solidFill>
+                <a:latin typeface="Segoe UI"/>
+              </a:rPr>
+              <a:t>Validation Panel</a:t>
+            </a:r>
+          </a:p>
+          <a:p>
+            <a:pPr>
+              <a:spcAft>
+                <a:spcPts val="1000"/>
+              </a:spcAft>
+            </a:pPr>
+            <a:r>
+              <a:rPr sz="1400" b="1" i="0">
+                <a:solidFill>
+                  <a:srgbClr val="047857"/>
+                </a:solidFill>
+                <a:latin typeface="Segoe UI"/>
+              </a:rPr>
+              <a:t>Correct Answer: C</a:t>
+            </a:r>
+          </a:p>
+          <a:p>
+            <a:pPr>
+              <a:spcAft>
+                <a:spcPts val="1400"/>
+              </a:spcAft>
+            </a:pPr>
+            <a:r>
+              <a:rPr sz="1100" b="0" i="0">
+                <a:solidFill>
+                  <a:srgbClr val="3F3F46"/>
+                </a:solidFill>
+                <a:latin typeface="Segoe UI"/>
+              </a:rPr>
+              <a:t>Explanation: Point-in-time joins (or historical joins) are the standard solution to prevent data leakage during training data export. By joining features at the exact historical timestamp of the target label event, the system ensures that no 'future data' is fed into the model.</a:t>
+            </a:r>
+          </a:p>
+          <a:p>
+            <a:r>
+              <a:rPr sz="950" b="0" i="1">
+                <a:solidFill>
+                  <a:srgbClr val="71717A"/>
+                </a:solidFill>
+                <a:latin typeface="Segoe UI"/>
+              </a:rPr>
+              <a:t>GCP Reference: https://cloud.google.com/vertex-ai/docs/featurestore/legacy/explain-pit-join</a:t>
+            </a:r>
+          </a:p>
+        </p:txBody>
+      </p:sp>
+    </p:spTree>
+  </p:cSld>
+  <p:clrMapOvr>
+    <a:masterClrMapping/>
+  </p:clrMapOvr>
+</p:sld>
+</file>
+
+<file path=ppt/slides/slide15.xml><?xml version="1.0" encoding="utf-8"?>
+<p:sld xmlns:a="http://schemas.openxmlformats.org/drawingml/2006/main" xmlns:p="http://schemas.openxmlformats.org/presentationml/2006/main" xmlns:r="http://schemas.openxmlformats.org/officeDocument/2006/relationships">
+  <p:cSld>
+    <p:bg>
+      <p:bgPr>
+        <a:solidFill>
+          <a:srgbClr val="E4E4E6"/>
+        </a:solidFill>
+        <a:effectLst/>
+      </p:bgPr>
+    </p:bg>
+    <p:spTree>
+      <p:nvGrpSpPr>
+        <p:cNvPr id="1" name=""/>
+        <p:cNvGrpSpPr/>
+        <p:nvPr/>
+      </p:nvGrpSpPr>
+      <p:grpSpPr/>
+      <p:sp>
+        <p:nvSpPr>
+          <p:cNvPr id="2" name="TextBox 1"/>
+          <p:cNvSpPr txBox="1"/>
+          <p:nvPr/>
+        </p:nvSpPr>
+        <p:spPr>
+          <a:xfrm>
+            <a:off x="731520" y="365760"/>
+            <a:ext cx="10698480" cy="274320"/>
+          </a:xfrm>
+          <a:prstGeom prst="rect">
+            <a:avLst/>
+          </a:prstGeom>
+          <a:noFill/>
+        </p:spPr>
+        <p:txBody>
+          <a:bodyPr wrap="square" lIns="0" rIns="0" tIns="0" bIns="0">
+            <a:spAutoFit/>
+          </a:bodyPr>
+          <a:lstStyle/>
+          <a:p>
+            <a:r>
+              <a:rPr sz="1000" b="1" i="0">
+                <a:solidFill>
+                  <a:srgbClr val="1D4ED8"/>
+                </a:solidFill>
+                <a:latin typeface="Segoe UI"/>
+              </a:rPr>
+              <a:t>PRACTICE SCENARIO 3 OF 10</a:t>
+            </a:r>
+          </a:p>
+        </p:txBody>
+      </p:sp>
+      <p:sp>
+        <p:nvSpPr>
+          <p:cNvPr id="3" name="TextBox 2"/>
+          <p:cNvSpPr txBox="1"/>
+          <p:nvPr/>
+        </p:nvSpPr>
+        <p:spPr>
+          <a:xfrm>
+            <a:off x="731520" y="640080"/>
+            <a:ext cx="10698480" cy="548640"/>
+          </a:xfrm>
+          <a:prstGeom prst="rect">
+            <a:avLst/>
+          </a:prstGeom>
+          <a:noFill/>
+        </p:spPr>
+        <p:txBody>
+          <a:bodyPr wrap="square" lIns="0" rIns="0" tIns="0" bIns="0">
+            <a:spAutoFit/>
+          </a:bodyPr>
+          <a:lstStyle/>
+          <a:p>
+            <a:r>
+              <a:rPr sz="2800" b="1" i="0">
+                <a:solidFill>
+                  <a:srgbClr val="18181B"/>
+                </a:solidFill>
+                <a:latin typeface="Segoe UI"/>
+              </a:rPr>
+              <a:t>Eliminating Train-Serve Skew</a:t>
+            </a:r>
+          </a:p>
+        </p:txBody>
+      </p:sp>
+      <p:sp>
+        <p:nvSpPr>
+          <p:cNvPr id="4" name="TextBox 3"/>
+          <p:cNvSpPr txBox="1"/>
+          <p:nvPr/>
+        </p:nvSpPr>
+        <p:spPr>
+          <a:xfrm>
+            <a:off x="731520" y="1371600"/>
+            <a:ext cx="6217920" cy="4754880"/>
+          </a:xfrm>
+          <a:prstGeom prst="rect">
+            <a:avLst/>
+          </a:prstGeom>
+          <a:noFill/>
+        </p:spPr>
+        <p:txBody>
+          <a:bodyPr wrap="square" lIns="0" rIns="0" tIns="0" bIns="0">
+            <a:spAutoFit/>
+          </a:bodyPr>
+          <a:lstStyle/>
+          <a:p>
+            <a:pPr>
+              <a:spcAft>
+                <a:spcPts val="1400"/>
+              </a:spcAft>
+            </a:pPr>
+            <a:r>
+              <a:rPr sz="1200" b="1" i="0">
+                <a:solidFill>
+                  <a:srgbClr val="18181B"/>
+                </a:solidFill>
+                <a:latin typeface="Segoe UI"/>
+              </a:rPr>
+              <a:t>A retail company runs a model to predict user conversion rates. The training features are preprocessed in batch using SQL in BigQuery, while the online serving application computes features using custom Python code. The model performs poorly in production due to train-serve skew. How can Vertex AI Feature Store resolve this?</a:t>
+            </a:r>
+          </a:p>
+          <a:p>
+            <a:pPr>
+              <a:spcAft>
+                <a:spcPts val="800"/>
+              </a:spcAft>
+            </a:pPr>
+            <a:r>
+              <a:rPr sz="1100" b="1" i="0">
+                <a:solidFill>
+                  <a:srgbClr val="1D4ED8"/>
+                </a:solidFill>
+                <a:latin typeface="Segoe UI"/>
+              </a:rPr>
+              <a:t>A.  </a:t>
+            </a:r>
+            <a:r>
+              <a:rPr sz="1100" b="0" i="0">
+                <a:solidFill>
+                  <a:srgbClr val="3F3F46"/>
+                </a:solidFill>
+                <a:latin typeface="Segoe UI"/>
+              </a:rPr>
+              <a:t>Define the preprocessing transformations in BigQuery views, register them as a Feature Group, and serve both training and prediction requests from the same Feature Store views.</a:t>
+            </a:r>
+          </a:p>
+          <a:p>
+            <a:pPr>
+              <a:spcAft>
+                <a:spcPts val="800"/>
+              </a:spcAft>
+            </a:pPr>
+            <a:r>
+              <a:rPr sz="1100" b="1" i="0">
+                <a:solidFill>
+                  <a:srgbClr val="1D4ED8"/>
+                </a:solidFill>
+                <a:latin typeface="Segoe UI"/>
+              </a:rPr>
+              <a:t>B.  </a:t>
+            </a:r>
+            <a:r>
+              <a:rPr sz="1100" b="0" i="0">
+                <a:solidFill>
+                  <a:srgbClr val="3F3F46"/>
+                </a:solidFill>
+                <a:latin typeface="Segoe UI"/>
+              </a:rPr>
+              <a:t>Standardize all preprocessing by rewriting the transformations directly inside the GKE API container.</a:t>
+            </a:r>
+          </a:p>
+          <a:p>
+            <a:pPr>
+              <a:spcAft>
+                <a:spcPts val="800"/>
+              </a:spcAft>
+            </a:pPr>
+            <a:r>
+              <a:rPr sz="1100" b="1" i="0">
+                <a:solidFill>
+                  <a:srgbClr val="1D4ED8"/>
+                </a:solidFill>
+                <a:latin typeface="Segoe UI"/>
+              </a:rPr>
+              <a:t>C.  </a:t>
+            </a:r>
+            <a:r>
+              <a:rPr sz="1100" b="0" i="0">
+                <a:solidFill>
+                  <a:srgbClr val="3F3F46"/>
+                </a:solidFill>
+                <a:latin typeface="Segoe UI"/>
+              </a:rPr>
+              <a:t>Deploy a second BigQuery instance dedicated to serving online queries in real-time.</a:t>
+            </a:r>
+          </a:p>
+          <a:p>
+            <a:pPr>
+              <a:spcAft>
+                <a:spcPts val="800"/>
+              </a:spcAft>
+            </a:pPr>
+            <a:r>
+              <a:rPr sz="1100" b="1" i="0">
+                <a:solidFill>
+                  <a:srgbClr val="1D4ED8"/>
+                </a:solidFill>
+                <a:latin typeface="Segoe UI"/>
+              </a:rPr>
+              <a:t>D.  </a:t>
+            </a:r>
+            <a:r>
+              <a:rPr sz="1100" b="0" i="0">
+                <a:solidFill>
+                  <a:srgbClr val="3F3F46"/>
+                </a:solidFill>
+                <a:latin typeface="Segoe UI"/>
+              </a:rPr>
+              <a:t>Use AutoML Tabular to automatically search for features during serving queries.</a:t>
+            </a:r>
+          </a:p>
+        </p:txBody>
+      </p:sp>
+      <p:sp>
+        <p:nvSpPr>
+          <p:cNvPr id="5" name="Rounded Rectangle 4"/>
+          <p:cNvSpPr/>
+          <p:nvPr/>
+        </p:nvSpPr>
+        <p:spPr>
+          <a:xfrm>
+            <a:off x="7315200" y="1645920"/>
+            <a:ext cx="4114800" cy="4480560"/>
+          </a:xfrm>
+          <a:prstGeom prst="roundRect">
+            <a:avLst/>
+          </a:prstGeom>
+          <a:solidFill>
+            <a:srgbClr val="FFFFFF"/>
+          </a:solidFill>
+          <a:ln w="15240">
+            <a:solidFill>
+              <a:srgbClr val="D4D4D8"/>
+            </a:solidFill>
+          </a:ln>
+        </p:spPr>
+        <p:style>
+          <a:lnRef idx="1">
+            <a:schemeClr val="accent1"/>
+          </a:lnRef>
+          <a:fillRef idx="3">
+            <a:schemeClr val="accent1"/>
+          </a:fillRef>
+          <a:effectRef idx="2">
+            <a:schemeClr val="accent1"/>
+          </a:effectRef>
+          <a:fontRef idx="minor">
+            <a:schemeClr val="lt1"/>
+          </a:fontRef>
+        </p:style>
+        <p:txBody>
+          <a:bodyPr rtlCol="0" anchor="ctr" wrap="square" lIns="228600" rIns="228600" tIns="182880" bIns="182880"/>
+          <a:lstStyle/>
+          <a:p>
+            <a:pPr algn="ctr">
+              <a:spcAft>
+                <a:spcPts val="1200"/>
+              </a:spcAft>
+            </a:pPr>
+            <a:r>
+              <a:rPr sz="1600" b="1" i="0">
+                <a:solidFill>
+                  <a:srgbClr val="18181B"/>
+                </a:solidFill>
+                <a:latin typeface="Segoe UI"/>
+              </a:rPr>
+              <a:t>Validation Panel</a:t>
+            </a:r>
+          </a:p>
+          <a:p>
+            <a:pPr>
+              <a:spcAft>
+                <a:spcPts val="1000"/>
+              </a:spcAft>
+            </a:pPr>
+            <a:r>
+              <a:rPr sz="1400" b="1" i="0">
+                <a:solidFill>
+                  <a:srgbClr val="047857"/>
+                </a:solidFill>
+                <a:latin typeface="Segoe UI"/>
+              </a:rPr>
+              <a:t>Correct Answer: A</a:t>
+            </a:r>
+          </a:p>
+          <a:p>
+            <a:pPr>
+              <a:spcAft>
+                <a:spcPts val="1400"/>
+              </a:spcAft>
+            </a:pPr>
+            <a:r>
+              <a:rPr sz="1100" b="0" i="0">
+                <a:solidFill>
+                  <a:srgbClr val="3F3F46"/>
+                </a:solidFill>
+                <a:latin typeface="Segoe UI"/>
+              </a:rPr>
+              <a:t>Explanation: To eliminate train-serve skew, both training pipelines (offline serving) and inference APIs (online serving) must fetch from a single source of feature definitions. Registering the preprocessing views in a centralized Feature Store accomplishes this.</a:t>
+            </a:r>
+          </a:p>
+          <a:p>
+            <a:r>
+              <a:rPr sz="950" b="0" i="1">
+                <a:solidFill>
+                  <a:srgbClr val="71717A"/>
+                </a:solidFill>
+                <a:latin typeface="Segoe UI"/>
+              </a:rPr>
+              <a:t>GCP Reference: https://cloud.google.com/vertex-ai/docs/featurestore/latest/overview</a:t>
+            </a:r>
+          </a:p>
+        </p:txBody>
+      </p:sp>
+    </p:spTree>
+  </p:cSld>
+  <p:clrMapOvr>
+    <a:masterClrMapping/>
+  </p:clrMapOvr>
+</p:sld>
+</file>
+
+<file path=ppt/slides/slide16.xml><?xml version="1.0" encoding="utf-8"?>
+<p:sld xmlns:a="http://schemas.openxmlformats.org/drawingml/2006/main" xmlns:p="http://schemas.openxmlformats.org/presentationml/2006/main" xmlns:r="http://schemas.openxmlformats.org/officeDocument/2006/relationships">
+  <p:cSld>
+    <p:bg>
+      <p:bgPr>
+        <a:solidFill>
+          <a:srgbClr val="E4E4E6"/>
+        </a:solidFill>
+        <a:effectLst/>
+      </p:bgPr>
+    </p:bg>
+    <p:spTree>
+      <p:nvGrpSpPr>
+        <p:cNvPr id="1" name=""/>
+        <p:cNvGrpSpPr/>
+        <p:nvPr/>
+      </p:nvGrpSpPr>
+      <p:grpSpPr/>
+      <p:sp>
+        <p:nvSpPr>
+          <p:cNvPr id="2" name="TextBox 1"/>
+          <p:cNvSpPr txBox="1"/>
+          <p:nvPr/>
+        </p:nvSpPr>
+        <p:spPr>
+          <a:xfrm>
+            <a:off x="731520" y="365760"/>
+            <a:ext cx="10698480" cy="274320"/>
+          </a:xfrm>
+          <a:prstGeom prst="rect">
+            <a:avLst/>
+          </a:prstGeom>
+          <a:noFill/>
+        </p:spPr>
+        <p:txBody>
+          <a:bodyPr wrap="square" lIns="0" rIns="0" tIns="0" bIns="0">
+            <a:spAutoFit/>
+          </a:bodyPr>
+          <a:lstStyle/>
+          <a:p>
+            <a:r>
+              <a:rPr sz="1000" b="1" i="0">
+                <a:solidFill>
+                  <a:srgbClr val="1D4ED8"/>
+                </a:solidFill>
+                <a:latin typeface="Segoe UI"/>
+              </a:rPr>
+              <a:t>PRACTICE SCENARIO 4 OF 10</a:t>
+            </a:r>
+          </a:p>
+        </p:txBody>
+      </p:sp>
+      <p:sp>
+        <p:nvSpPr>
+          <p:cNvPr id="3" name="TextBox 2"/>
+          <p:cNvSpPr txBox="1"/>
+          <p:nvPr/>
+        </p:nvSpPr>
+        <p:spPr>
+          <a:xfrm>
+            <a:off x="731520" y="640080"/>
+            <a:ext cx="10698480" cy="548640"/>
+          </a:xfrm>
+          <a:prstGeom prst="rect">
+            <a:avLst/>
+          </a:prstGeom>
+          <a:noFill/>
+        </p:spPr>
+        <p:txBody>
+          <a:bodyPr wrap="square" lIns="0" rIns="0" tIns="0" bIns="0">
+            <a:spAutoFit/>
+          </a:bodyPr>
+          <a:lstStyle/>
+          <a:p>
+            <a:r>
+              <a:rPr sz="2800" b="1" i="0">
+                <a:solidFill>
+                  <a:srgbClr val="18181B"/>
+                </a:solidFill>
+                <a:latin typeface="Segoe UI"/>
+              </a:rPr>
+              <a:t>Cost &amp; Storage Optimization</a:t>
+            </a:r>
+          </a:p>
+        </p:txBody>
+      </p:sp>
+      <p:sp>
+        <p:nvSpPr>
+          <p:cNvPr id="4" name="TextBox 3"/>
+          <p:cNvSpPr txBox="1"/>
+          <p:nvPr/>
+        </p:nvSpPr>
+        <p:spPr>
+          <a:xfrm>
+            <a:off x="731520" y="1371600"/>
+            <a:ext cx="6217920" cy="4754880"/>
+          </a:xfrm>
+          <a:prstGeom prst="rect">
+            <a:avLst/>
+          </a:prstGeom>
+          <a:noFill/>
+        </p:spPr>
+        <p:txBody>
+          <a:bodyPr wrap="square" lIns="0" rIns="0" tIns="0" bIns="0">
+            <a:spAutoFit/>
+          </a:bodyPr>
+          <a:lstStyle/>
+          <a:p>
+            <a:pPr>
+              <a:spcAft>
+                <a:spcPts val="1400"/>
+              </a:spcAft>
+            </a:pPr>
+            <a:r>
+              <a:rPr sz="1200" b="1" i="0">
+                <a:solidFill>
+                  <a:srgbClr val="18181B"/>
+                </a:solidFill>
+                <a:latin typeface="Segoe UI"/>
+              </a:rPr>
+              <a:t>Multiple data science teams at an enterprise recalculate overlapping customer features (such as `monthly_average_spend`). This leads to redundant storage costs and processing fees. What is the best practice to optimize these costs?</a:t>
+            </a:r>
+          </a:p>
+          <a:p>
+            <a:pPr>
+              <a:spcAft>
+                <a:spcPts val="800"/>
+              </a:spcAft>
+            </a:pPr>
+            <a:r>
+              <a:rPr sz="1100" b="1" i="0">
+                <a:solidFill>
+                  <a:srgbClr val="1D4ED8"/>
+                </a:solidFill>
+                <a:latin typeface="Segoe UI"/>
+              </a:rPr>
+              <a:t>A.  </a:t>
+            </a:r>
+            <a:r>
+              <a:rPr sz="1100" b="0" i="0">
+                <a:solidFill>
+                  <a:srgbClr val="3F3F46"/>
+                </a:solidFill>
+                <a:latin typeface="Segoe UI"/>
+              </a:rPr>
+              <a:t>Request the finance team to enforce resource quotas on all GCS buckets and limit active BigQuery projects.</a:t>
+            </a:r>
+          </a:p>
+          <a:p>
+            <a:pPr>
+              <a:spcAft>
+                <a:spcPts val="800"/>
+              </a:spcAft>
+            </a:pPr>
+            <a:r>
+              <a:rPr sz="1100" b="1" i="0">
+                <a:solidFill>
+                  <a:srgbClr val="1D4ED8"/>
+                </a:solidFill>
+                <a:latin typeface="Segoe UI"/>
+              </a:rPr>
+              <a:t>B.  </a:t>
+            </a:r>
+            <a:r>
+              <a:rPr sz="1100" b="0" i="0">
+                <a:solidFill>
+                  <a:srgbClr val="3F3F46"/>
+                </a:solidFill>
+                <a:latin typeface="Segoe UI"/>
+              </a:rPr>
+              <a:t>Build a custom metadata registry using Cloud SQL to track who owns which Python scripting files.</a:t>
+            </a:r>
+          </a:p>
+          <a:p>
+            <a:pPr>
+              <a:spcAft>
+                <a:spcPts val="800"/>
+              </a:spcAft>
+            </a:pPr>
+            <a:r>
+              <a:rPr sz="1100" b="1" i="0">
+                <a:solidFill>
+                  <a:srgbClr val="1D4ED8"/>
+                </a:solidFill>
+                <a:latin typeface="Segoe UI"/>
+              </a:rPr>
+              <a:t>C.  </a:t>
+            </a:r>
+            <a:r>
+              <a:rPr sz="1100" b="0" i="0">
+                <a:solidFill>
+                  <a:srgbClr val="3F3F46"/>
+                </a:solidFill>
+                <a:latin typeface="Segoe UI"/>
+              </a:rPr>
+              <a:t>Export all datasets to local development servers to avoid Google Cloud analytical query costs.</a:t>
+            </a:r>
+          </a:p>
+          <a:p>
+            <a:pPr>
+              <a:spcAft>
+                <a:spcPts val="800"/>
+              </a:spcAft>
+            </a:pPr>
+            <a:r>
+              <a:rPr sz="1100" b="1" i="0">
+                <a:solidFill>
+                  <a:srgbClr val="1D4ED8"/>
+                </a:solidFill>
+                <a:latin typeface="Segoe UI"/>
+              </a:rPr>
+              <a:t>D.  </a:t>
+            </a:r>
+            <a:r>
+              <a:rPr sz="1100" b="0" i="0">
+                <a:solidFill>
+                  <a:srgbClr val="3F3F46"/>
+                </a:solidFill>
+                <a:latin typeface="Segoe UI"/>
+              </a:rPr>
+              <a:t>Standardize all user features in a centralized Vertex AI Feature Store, allowing teams to search, share, and reuse registered feature views.</a:t>
+            </a:r>
+          </a:p>
+        </p:txBody>
+      </p:sp>
+      <p:sp>
+        <p:nvSpPr>
+          <p:cNvPr id="5" name="Rounded Rectangle 4"/>
+          <p:cNvSpPr/>
+          <p:nvPr/>
+        </p:nvSpPr>
+        <p:spPr>
+          <a:xfrm>
+            <a:off x="7315200" y="1645920"/>
+            <a:ext cx="4114800" cy="4480560"/>
+          </a:xfrm>
+          <a:prstGeom prst="roundRect">
+            <a:avLst/>
+          </a:prstGeom>
+          <a:solidFill>
+            <a:srgbClr val="FFFFFF"/>
+          </a:solidFill>
+          <a:ln w="15240">
+            <a:solidFill>
+              <a:srgbClr val="D4D4D8"/>
+            </a:solidFill>
+          </a:ln>
+        </p:spPr>
+        <p:style>
+          <a:lnRef idx="1">
+            <a:schemeClr val="accent1"/>
+          </a:lnRef>
+          <a:fillRef idx="3">
+            <a:schemeClr val="accent1"/>
+          </a:fillRef>
+          <a:effectRef idx="2">
+            <a:schemeClr val="accent1"/>
+          </a:effectRef>
+          <a:fontRef idx="minor">
+            <a:schemeClr val="lt1"/>
+          </a:fontRef>
+        </p:style>
+        <p:txBody>
+          <a:bodyPr rtlCol="0" anchor="ctr" wrap="square" lIns="228600" rIns="228600" tIns="182880" bIns="182880"/>
+          <a:lstStyle/>
+          <a:p>
+            <a:pPr algn="ctr">
+              <a:spcAft>
+                <a:spcPts val="1200"/>
+              </a:spcAft>
+            </a:pPr>
+            <a:r>
+              <a:rPr sz="1600" b="1" i="0">
+                <a:solidFill>
+                  <a:srgbClr val="18181B"/>
+                </a:solidFill>
+                <a:latin typeface="Segoe UI"/>
+              </a:rPr>
+              <a:t>Validation Panel</a:t>
+            </a:r>
+          </a:p>
+          <a:p>
+            <a:pPr>
+              <a:spcAft>
+                <a:spcPts val="1000"/>
+              </a:spcAft>
+            </a:pPr>
+            <a:r>
+              <a:rPr sz="1400" b="1" i="0">
+                <a:solidFill>
+                  <a:srgbClr val="047857"/>
+                </a:solidFill>
+                <a:latin typeface="Segoe UI"/>
+              </a:rPr>
+              <a:t>Correct Answer: D</a:t>
+            </a:r>
+          </a:p>
+          <a:p>
+            <a:pPr>
+              <a:spcAft>
+                <a:spcPts val="1400"/>
+              </a:spcAft>
+            </a:pPr>
+            <a:r>
+              <a:rPr sz="1100" b="0" i="0">
+                <a:solidFill>
+                  <a:srgbClr val="3F3F46"/>
+                </a:solidFill>
+                <a:latin typeface="Segoe UI"/>
+              </a:rPr>
+              <a:t>Explanation: A primary goal of a feature store is code and resource sharing. Centralizing tabular features into Vertex AI Feature Store allows multiple teams to collaborate on a single registry, preventing duplicate ETL pipelines and saving cost.</a:t>
+            </a:r>
+          </a:p>
+          <a:p>
+            <a:r>
+              <a:rPr sz="950" b="0" i="1">
+                <a:solidFill>
+                  <a:srgbClr val="71717A"/>
+                </a:solidFill>
+                <a:latin typeface="Segoe UI"/>
+              </a:rPr>
+              <a:t>GCP Reference: https://cloud.google.com/vertex-ai/docs/featurestore/latest/overview</a:t>
+            </a:r>
+          </a:p>
+        </p:txBody>
+      </p:sp>
+    </p:spTree>
+  </p:cSld>
+  <p:clrMapOvr>
+    <a:masterClrMapping/>
+  </p:clrMapOvr>
+</p:sld>
+</file>
+
+<file path=ppt/slides/slide17.xml><?xml version="1.0" encoding="utf-8"?>
+<p:sld xmlns:a="http://schemas.openxmlformats.org/drawingml/2006/main" xmlns:p="http://schemas.openxmlformats.org/presentationml/2006/main" xmlns:r="http://schemas.openxmlformats.org/officeDocument/2006/relationships">
+  <p:cSld>
+    <p:bg>
+      <p:bgPr>
+        <a:solidFill>
+          <a:srgbClr val="E4E4E6"/>
+        </a:solidFill>
+        <a:effectLst/>
+      </p:bgPr>
+    </p:bg>
+    <p:spTree>
+      <p:nvGrpSpPr>
+        <p:cNvPr id="1" name=""/>
+        <p:cNvGrpSpPr/>
+        <p:nvPr/>
+      </p:nvGrpSpPr>
+      <p:grpSpPr/>
+      <p:sp>
+        <p:nvSpPr>
+          <p:cNvPr id="2" name="TextBox 1"/>
+          <p:cNvSpPr txBox="1"/>
+          <p:nvPr/>
+        </p:nvSpPr>
+        <p:spPr>
+          <a:xfrm>
+            <a:off x="731520" y="365760"/>
+            <a:ext cx="10698480" cy="274320"/>
+          </a:xfrm>
+          <a:prstGeom prst="rect">
+            <a:avLst/>
+          </a:prstGeom>
+          <a:noFill/>
+        </p:spPr>
+        <p:txBody>
+          <a:bodyPr wrap="square" lIns="0" rIns="0" tIns="0" bIns="0">
+            <a:spAutoFit/>
+          </a:bodyPr>
+          <a:lstStyle/>
+          <a:p>
+            <a:r>
+              <a:rPr sz="1000" b="1" i="0">
+                <a:solidFill>
+                  <a:srgbClr val="1D4ED8"/>
+                </a:solidFill>
+                <a:latin typeface="Segoe UI"/>
+              </a:rPr>
+              <a:t>PRACTICE SCENARIO 5 OF 10</a:t>
+            </a:r>
+          </a:p>
+        </p:txBody>
+      </p:sp>
+      <p:sp>
+        <p:nvSpPr>
+          <p:cNvPr id="3" name="TextBox 2"/>
+          <p:cNvSpPr txBox="1"/>
+          <p:nvPr/>
+        </p:nvSpPr>
+        <p:spPr>
+          <a:xfrm>
+            <a:off x="731520" y="640080"/>
+            <a:ext cx="10698480" cy="548640"/>
+          </a:xfrm>
+          <a:prstGeom prst="rect">
+            <a:avLst/>
+          </a:prstGeom>
+          <a:noFill/>
+        </p:spPr>
+        <p:txBody>
+          <a:bodyPr wrap="square" lIns="0" rIns="0" tIns="0" bIns="0">
+            <a:spAutoFit/>
+          </a:bodyPr>
+          <a:lstStyle/>
+          <a:p>
+            <a:r>
+              <a:rPr sz="2800" b="1" i="0">
+                <a:solidFill>
+                  <a:srgbClr val="18181B"/>
+                </a:solidFill>
+                <a:latin typeface="Segoe UI"/>
+              </a:rPr>
+              <a:t>Real-time Location Updates</a:t>
+            </a:r>
+          </a:p>
+        </p:txBody>
+      </p:sp>
+      <p:sp>
+        <p:nvSpPr>
+          <p:cNvPr id="4" name="TextBox 3"/>
+          <p:cNvSpPr txBox="1"/>
+          <p:nvPr/>
+        </p:nvSpPr>
+        <p:spPr>
+          <a:xfrm>
+            <a:off x="731520" y="1371600"/>
+            <a:ext cx="6217920" cy="4754880"/>
+          </a:xfrm>
+          <a:prstGeom prst="rect">
+            <a:avLst/>
+          </a:prstGeom>
+          <a:noFill/>
+        </p:spPr>
+        <p:txBody>
+          <a:bodyPr wrap="square" lIns="0" rIns="0" tIns="0" bIns="0">
+            <a:spAutoFit/>
+          </a:bodyPr>
+          <a:lstStyle/>
+          <a:p>
+            <a:pPr>
+              <a:spcAft>
+                <a:spcPts val="1400"/>
+              </a:spcAft>
+            </a:pPr>
+            <a:r>
+              <a:rPr sz="1200" b="1" i="0">
+                <a:solidFill>
+                  <a:srgbClr val="18181B"/>
+                </a:solidFill>
+                <a:latin typeface="Segoe UI"/>
+              </a:rPr>
+              <a:t>A ride-sharing application needs to update driver location features every few seconds and serve these features to an active matching model during booking requests. How should the streaming ingestion pipeline be structured?</a:t>
+            </a:r>
+          </a:p>
+          <a:p>
+            <a:pPr>
+              <a:spcAft>
+                <a:spcPts val="800"/>
+              </a:spcAft>
+            </a:pPr>
+            <a:r>
+              <a:rPr sz="1100" b="1" i="0">
+                <a:solidFill>
+                  <a:srgbClr val="1D4ED8"/>
+                </a:solidFill>
+                <a:latin typeface="Segoe UI"/>
+              </a:rPr>
+              <a:t>A.  </a:t>
+            </a:r>
+            <a:r>
+              <a:rPr sz="1100" b="0" i="0">
+                <a:solidFill>
+                  <a:srgbClr val="3F3F46"/>
+                </a:solidFill>
+                <a:latin typeface="Segoe UI"/>
+              </a:rPr>
+              <a:t>Run a batch Dataflow job every hour to dump CSV features to Cloud Storage and import them to the Feature Store.</a:t>
+            </a:r>
+          </a:p>
+          <a:p>
+            <a:pPr>
+              <a:spcAft>
+                <a:spcPts val="800"/>
+              </a:spcAft>
+            </a:pPr>
+            <a:r>
+              <a:rPr sz="1100" b="1" i="0">
+                <a:solidFill>
+                  <a:srgbClr val="1D4ED8"/>
+                </a:solidFill>
+                <a:latin typeface="Segoe UI"/>
+              </a:rPr>
+              <a:t>B.  </a:t>
+            </a:r>
+            <a:r>
+              <a:rPr sz="1100" b="0" i="0">
+                <a:solidFill>
+                  <a:srgbClr val="3F3F46"/>
+                </a:solidFill>
+                <a:latin typeface="Segoe UI"/>
+              </a:rPr>
+              <a:t>Ingest location events via Cloud Pub/Sub, process them in real-time with Cloud Dataflow, and write directly to the Feature Store online database using streaming writes.</a:t>
+            </a:r>
+          </a:p>
+          <a:p>
+            <a:pPr>
+              <a:spcAft>
+                <a:spcPts val="800"/>
+              </a:spcAft>
+            </a:pPr>
+            <a:r>
+              <a:rPr sz="1100" b="1" i="0">
+                <a:solidFill>
+                  <a:srgbClr val="1D4ED8"/>
+                </a:solidFill>
+                <a:latin typeface="Segoe UI"/>
+              </a:rPr>
+              <a:t>C.  </a:t>
+            </a:r>
+            <a:r>
+              <a:rPr sz="1100" b="0" i="0">
+                <a:solidFill>
+                  <a:srgbClr val="3F3F46"/>
+                </a:solidFill>
+                <a:latin typeface="Segoe UI"/>
+              </a:rPr>
+              <a:t>Write location features directly from mobile client apps to a central BigQuery dataset using row inserts.</a:t>
+            </a:r>
+          </a:p>
+          <a:p>
+            <a:pPr>
+              <a:spcAft>
+                <a:spcPts val="800"/>
+              </a:spcAft>
+            </a:pPr>
+            <a:r>
+              <a:rPr sz="1100" b="1" i="0">
+                <a:solidFill>
+                  <a:srgbClr val="1D4ED8"/>
+                </a:solidFill>
+                <a:latin typeface="Segoe UI"/>
+              </a:rPr>
+              <a:t>D.  </a:t>
+            </a:r>
+            <a:r>
+              <a:rPr sz="1100" b="0" i="0">
+                <a:solidFill>
+                  <a:srgbClr val="3F3F46"/>
+                </a:solidFill>
+                <a:latin typeface="Segoe UI"/>
+              </a:rPr>
+              <a:t>Set up Cloud Composer to trigger Python Cloud Functions that query BigQuery ML predictions.</a:t>
+            </a:r>
+          </a:p>
+        </p:txBody>
+      </p:sp>
+      <p:sp>
+        <p:nvSpPr>
+          <p:cNvPr id="5" name="Rounded Rectangle 4"/>
+          <p:cNvSpPr/>
+          <p:nvPr/>
+        </p:nvSpPr>
+        <p:spPr>
+          <a:xfrm>
+            <a:off x="7315200" y="1645920"/>
+            <a:ext cx="4114800" cy="4480560"/>
+          </a:xfrm>
+          <a:prstGeom prst="roundRect">
+            <a:avLst/>
+          </a:prstGeom>
+          <a:solidFill>
+            <a:srgbClr val="FFFFFF"/>
+          </a:solidFill>
+          <a:ln w="15240">
+            <a:solidFill>
+              <a:srgbClr val="D4D4D8"/>
+            </a:solidFill>
+          </a:ln>
+        </p:spPr>
+        <p:style>
+          <a:lnRef idx="1">
+            <a:schemeClr val="accent1"/>
+          </a:lnRef>
+          <a:fillRef idx="3">
+            <a:schemeClr val="accent1"/>
+          </a:fillRef>
+          <a:effectRef idx="2">
+            <a:schemeClr val="accent1"/>
+          </a:effectRef>
+          <a:fontRef idx="minor">
+            <a:schemeClr val="lt1"/>
+          </a:fontRef>
+        </p:style>
+        <p:txBody>
+          <a:bodyPr rtlCol="0" anchor="ctr" wrap="square" lIns="228600" rIns="228600" tIns="182880" bIns="182880"/>
+          <a:lstStyle/>
+          <a:p>
+            <a:pPr algn="ctr">
+              <a:spcAft>
+                <a:spcPts val="1200"/>
+              </a:spcAft>
+            </a:pPr>
+            <a:r>
+              <a:rPr sz="1600" b="1" i="0">
+                <a:solidFill>
+                  <a:srgbClr val="18181B"/>
+                </a:solidFill>
+                <a:latin typeface="Segoe UI"/>
+              </a:rPr>
+              <a:t>Validation Panel</a:t>
+            </a:r>
+          </a:p>
+          <a:p>
+            <a:pPr>
+              <a:spcAft>
+                <a:spcPts val="1000"/>
+              </a:spcAft>
+            </a:pPr>
+            <a:r>
+              <a:rPr sz="1400" b="1" i="0">
+                <a:solidFill>
+                  <a:srgbClr val="047857"/>
+                </a:solidFill>
+                <a:latin typeface="Segoe UI"/>
+              </a:rPr>
+              <a:t>Correct Answer: B</a:t>
+            </a:r>
+          </a:p>
+          <a:p>
+            <a:pPr>
+              <a:spcAft>
+                <a:spcPts val="1400"/>
+              </a:spcAft>
+            </a:pPr>
+            <a:r>
+              <a:rPr sz="1100" b="0" i="0">
+                <a:solidFill>
+                  <a:srgbClr val="3F3F46"/>
+                </a:solidFill>
+                <a:latin typeface="Segoe UI"/>
+              </a:rPr>
+              <a:t>Explanation: Real-time streaming ingestion uses the Pub/Sub -&gt; Dataflow -&gt; Feature Store (online database writes) pattern. This ensures that driver coordinate feature updates are written with sub-second lag and immediately readable by inference requests.</a:t>
+            </a:r>
+          </a:p>
+          <a:p>
+            <a:r>
+              <a:rPr sz="950" b="0" i="1">
+                <a:solidFill>
+                  <a:srgbClr val="71717A"/>
+                </a:solidFill>
+                <a:latin typeface="Segoe UI"/>
+              </a:rPr>
+              <a:t>GCP Reference: https://cloud.google.com/vertex-ai/docs/featurestore/legacy/ingest-streaming</a:t>
+            </a:r>
+          </a:p>
+        </p:txBody>
+      </p:sp>
+    </p:spTree>
+  </p:cSld>
+  <p:clrMapOvr>
+    <a:masterClrMapping/>
+  </p:clrMapOvr>
+</p:sld>
+</file>
+
+<file path=ppt/slides/slide18.xml><?xml version="1.0" encoding="utf-8"?>
+<p:sld xmlns:a="http://schemas.openxmlformats.org/drawingml/2006/main" xmlns:p="http://schemas.openxmlformats.org/presentationml/2006/main" xmlns:r="http://schemas.openxmlformats.org/officeDocument/2006/relationships">
+  <p:cSld>
+    <p:bg>
+      <p:bgPr>
+        <a:solidFill>
+          <a:srgbClr val="E4E4E6"/>
+        </a:solidFill>
+        <a:effectLst/>
+      </p:bgPr>
+    </p:bg>
+    <p:spTree>
+      <p:nvGrpSpPr>
+        <p:cNvPr id="1" name=""/>
+        <p:cNvGrpSpPr/>
+        <p:nvPr/>
+      </p:nvGrpSpPr>
+      <p:grpSpPr/>
+      <p:sp>
+        <p:nvSpPr>
+          <p:cNvPr id="2" name="TextBox 1"/>
+          <p:cNvSpPr txBox="1"/>
+          <p:nvPr/>
+        </p:nvSpPr>
+        <p:spPr>
+          <a:xfrm>
+            <a:off x="731520" y="365760"/>
+            <a:ext cx="10698480" cy="274320"/>
+          </a:xfrm>
+          <a:prstGeom prst="rect">
+            <a:avLst/>
+          </a:prstGeom>
+          <a:noFill/>
+        </p:spPr>
+        <p:txBody>
+          <a:bodyPr wrap="square" lIns="0" rIns="0" tIns="0" bIns="0">
+            <a:spAutoFit/>
+          </a:bodyPr>
+          <a:lstStyle/>
+          <a:p>
+            <a:r>
+              <a:rPr sz="1000" b="1" i="0">
+                <a:solidFill>
+                  <a:srgbClr val="1D4ED8"/>
+                </a:solidFill>
+                <a:latin typeface="Segoe UI"/>
+              </a:rPr>
+              <a:t>PRACTICE SCENARIO 6 OF 10</a:t>
+            </a:r>
+          </a:p>
+        </p:txBody>
+      </p:sp>
+      <p:sp>
+        <p:nvSpPr>
+          <p:cNvPr id="3" name="TextBox 2"/>
+          <p:cNvSpPr txBox="1"/>
+          <p:nvPr/>
+        </p:nvSpPr>
+        <p:spPr>
+          <a:xfrm>
+            <a:off x="731520" y="640080"/>
+            <a:ext cx="10698480" cy="548640"/>
+          </a:xfrm>
+          <a:prstGeom prst="rect">
+            <a:avLst/>
+          </a:prstGeom>
+          <a:noFill/>
+        </p:spPr>
+        <p:txBody>
+          <a:bodyPr wrap="square" lIns="0" rIns="0" tIns="0" bIns="0">
+            <a:spAutoFit/>
+          </a:bodyPr>
+          <a:lstStyle/>
+          <a:p>
+            <a:r>
+              <a:rPr sz="2800" b="1" i="0">
+                <a:solidFill>
+                  <a:srgbClr val="18181B"/>
+                </a:solidFill>
+                <a:latin typeface="Segoe UI"/>
+              </a:rPr>
+              <a:t>Network Security &amp; Governance</a:t>
+            </a:r>
+          </a:p>
+        </p:txBody>
+      </p:sp>
+      <p:sp>
+        <p:nvSpPr>
+          <p:cNvPr id="4" name="TextBox 3"/>
+          <p:cNvSpPr txBox="1"/>
+          <p:nvPr/>
+        </p:nvSpPr>
+        <p:spPr>
+          <a:xfrm>
+            <a:off x="731520" y="1371600"/>
+            <a:ext cx="6217920" cy="4754880"/>
+          </a:xfrm>
+          <a:prstGeom prst="rect">
+            <a:avLst/>
+          </a:prstGeom>
+          <a:noFill/>
+        </p:spPr>
+        <p:txBody>
+          <a:bodyPr wrap="square" lIns="0" rIns="0" tIns="0" bIns="0">
+            <a:spAutoFit/>
+          </a:bodyPr>
+          <a:lstStyle/>
+          <a:p>
+            <a:pPr>
+              <a:spcAft>
+                <a:spcPts val="1400"/>
+              </a:spcAft>
+            </a:pPr>
+            <a:r>
+              <a:rPr sz="1200" b="1" i="0">
+                <a:solidFill>
+                  <a:srgbClr val="18181B"/>
+                </a:solidFill>
+                <a:latin typeface="Segoe UI"/>
+              </a:rPr>
+              <a:t>A healthcare provider wants to deploy a disease risk prediction model using Vertex AI. The patient features are highly sensitive. The compliance team mandates that no data can traverse the public internet, and exfiltration must be blocked. How should the Feature Store be secured?</a:t>
+            </a:r>
+          </a:p>
+          <a:p>
+            <a:pPr>
+              <a:spcAft>
+                <a:spcPts val="800"/>
+              </a:spcAft>
+            </a:pPr>
+            <a:r>
+              <a:rPr sz="1100" b="1" i="0">
+                <a:solidFill>
+                  <a:srgbClr val="1D4ED8"/>
+                </a:solidFill>
+                <a:latin typeface="Segoe UI"/>
+              </a:rPr>
+              <a:t>A.  </a:t>
+            </a:r>
+            <a:r>
+              <a:rPr sz="1100" b="0" i="0">
+                <a:solidFill>
+                  <a:srgbClr val="3F3F46"/>
+                </a:solidFill>
+                <a:latin typeface="Segoe UI"/>
+              </a:rPr>
+              <a:t>Rely on default HTTPS encryption and restrict Google Cloud project access to employees using MFA.</a:t>
+            </a:r>
+          </a:p>
+          <a:p>
+            <a:pPr>
+              <a:spcAft>
+                <a:spcPts val="800"/>
+              </a:spcAft>
+            </a:pPr>
+            <a:r>
+              <a:rPr sz="1100" b="1" i="0">
+                <a:solidFill>
+                  <a:srgbClr val="1D4ED8"/>
+                </a:solidFill>
+                <a:latin typeface="Segoe UI"/>
+              </a:rPr>
+              <a:t>B.  </a:t>
+            </a:r>
+            <a:r>
+              <a:rPr sz="1100" b="0" i="0">
+                <a:solidFill>
+                  <a:srgbClr val="3F3F46"/>
+                </a:solidFill>
+                <a:latin typeface="Segoe UI"/>
+              </a:rPr>
+              <a:t>Store datasets in regional buckets and restrict permissions using Google Groups.</a:t>
+            </a:r>
+          </a:p>
+          <a:p>
+            <a:pPr>
+              <a:spcAft>
+                <a:spcPts val="800"/>
+              </a:spcAft>
+            </a:pPr>
+            <a:r>
+              <a:rPr sz="1100" b="1" i="0">
+                <a:solidFill>
+                  <a:srgbClr val="1D4ED8"/>
+                </a:solidFill>
+                <a:latin typeface="Segoe UI"/>
+              </a:rPr>
+              <a:t>C.  </a:t>
+            </a:r>
+            <a:r>
+              <a:rPr sz="1100" b="0" i="0">
+                <a:solidFill>
+                  <a:srgbClr val="3F3F46"/>
+                </a:solidFill>
+                <a:latin typeface="Segoe UI"/>
+              </a:rPr>
+              <a:t>Place the Vertex AI Feature Store and online serving instances inside a VPC Service Controls (VPC-SC) security perimeter and query endpoints using private connections.</a:t>
+            </a:r>
+          </a:p>
+          <a:p>
+            <a:pPr>
+              <a:spcAft>
+                <a:spcPts val="800"/>
+              </a:spcAft>
+            </a:pPr>
+            <a:r>
+              <a:rPr sz="1100" b="1" i="0">
+                <a:solidFill>
+                  <a:srgbClr val="1D4ED8"/>
+                </a:solidFill>
+                <a:latin typeface="Segoe UI"/>
+              </a:rPr>
+              <a:t>D.  </a:t>
+            </a:r>
+            <a:r>
+              <a:rPr sz="1100" b="0" i="0">
+                <a:solidFill>
+                  <a:srgbClr val="3F3F46"/>
+                </a:solidFill>
+                <a:latin typeface="Segoe UI"/>
+              </a:rPr>
+              <a:t>Encrypt all patient data using client-side libraries before uploading to a public BigQuery table.</a:t>
+            </a:r>
+          </a:p>
+        </p:txBody>
+      </p:sp>
+      <p:sp>
+        <p:nvSpPr>
+          <p:cNvPr id="5" name="Rounded Rectangle 4"/>
+          <p:cNvSpPr/>
+          <p:nvPr/>
+        </p:nvSpPr>
+        <p:spPr>
+          <a:xfrm>
+            <a:off x="7315200" y="1645920"/>
+            <a:ext cx="4114800" cy="4480560"/>
+          </a:xfrm>
+          <a:prstGeom prst="roundRect">
+            <a:avLst/>
+          </a:prstGeom>
+          <a:solidFill>
+            <a:srgbClr val="FFFFFF"/>
+          </a:solidFill>
+          <a:ln w="15240">
+            <a:solidFill>
+              <a:srgbClr val="D4D4D8"/>
+            </a:solidFill>
+          </a:ln>
+        </p:spPr>
+        <p:style>
+          <a:lnRef idx="1">
+            <a:schemeClr val="accent1"/>
+          </a:lnRef>
+          <a:fillRef idx="3">
+            <a:schemeClr val="accent1"/>
+          </a:fillRef>
+          <a:effectRef idx="2">
+            <a:schemeClr val="accent1"/>
+          </a:effectRef>
+          <a:fontRef idx="minor">
+            <a:schemeClr val="lt1"/>
+          </a:fontRef>
+        </p:style>
+        <p:txBody>
+          <a:bodyPr rtlCol="0" anchor="ctr" wrap="square" lIns="228600" rIns="228600" tIns="182880" bIns="182880"/>
+          <a:lstStyle/>
+          <a:p>
+            <a:pPr algn="ctr">
+              <a:spcAft>
+                <a:spcPts val="1200"/>
+              </a:spcAft>
+            </a:pPr>
+            <a:r>
+              <a:rPr sz="1600" b="1" i="0">
+                <a:solidFill>
+                  <a:srgbClr val="18181B"/>
+                </a:solidFill>
+                <a:latin typeface="Segoe UI"/>
+              </a:rPr>
+              <a:t>Validation Panel</a:t>
+            </a:r>
+          </a:p>
+          <a:p>
+            <a:pPr>
+              <a:spcAft>
+                <a:spcPts val="1000"/>
+              </a:spcAft>
+            </a:pPr>
+            <a:r>
+              <a:rPr sz="1400" b="1" i="0">
+                <a:solidFill>
+                  <a:srgbClr val="047857"/>
+                </a:solidFill>
+                <a:latin typeface="Segoe UI"/>
+              </a:rPr>
+              <a:t>Correct Answer: C</a:t>
+            </a:r>
+          </a:p>
+          <a:p>
+            <a:pPr>
+              <a:spcAft>
+                <a:spcPts val="1400"/>
+              </a:spcAft>
+            </a:pPr>
+            <a:r>
+              <a:rPr sz="1100" b="0" i="0">
+                <a:solidFill>
+                  <a:srgbClr val="3F3F46"/>
+                </a:solidFill>
+                <a:latin typeface="Segoe UI"/>
+              </a:rPr>
+              <a:t>Explanation: VPC Service Controls (VPC-SC) allows defining a network security perimeter around sensitive services, including Vertex AI Feature Store. It mitigates data exfiltration risk by blocking communications with resources outside the perimeter.</a:t>
+            </a:r>
+          </a:p>
+          <a:p>
+            <a:r>
+              <a:rPr sz="950" b="0" i="1">
+                <a:solidFill>
+                  <a:srgbClr val="71717A"/>
+                </a:solidFill>
+                <a:latin typeface="Segoe UI"/>
+              </a:rPr>
+              <a:t>GCP Reference: https://cloud.google.com/vertex-ai/docs/general/vpc-sc</a:t>
+            </a:r>
+          </a:p>
+        </p:txBody>
+      </p:sp>
+    </p:spTree>
+  </p:cSld>
+  <p:clrMapOvr>
+    <a:masterClrMapping/>
+  </p:clrMapOvr>
+</p:sld>
+</file>
+
+<file path=ppt/slides/slide19.xml><?xml version="1.0" encoding="utf-8"?>
+<p:sld xmlns:a="http://schemas.openxmlformats.org/drawingml/2006/main" xmlns:p="http://schemas.openxmlformats.org/presentationml/2006/main" xmlns:r="http://schemas.openxmlformats.org/officeDocument/2006/relationships">
+  <p:cSld>
+    <p:bg>
+      <p:bgPr>
+        <a:solidFill>
+          <a:srgbClr val="E4E4E6"/>
+        </a:solidFill>
+        <a:effectLst/>
+      </p:bgPr>
+    </p:bg>
+    <p:spTree>
+      <p:nvGrpSpPr>
+        <p:cNvPr id="1" name=""/>
+        <p:cNvGrpSpPr/>
+        <p:nvPr/>
+      </p:nvGrpSpPr>
+      <p:grpSpPr/>
+      <p:sp>
+        <p:nvSpPr>
+          <p:cNvPr id="2" name="TextBox 1"/>
+          <p:cNvSpPr txBox="1"/>
+          <p:nvPr/>
+        </p:nvSpPr>
+        <p:spPr>
+          <a:xfrm>
+            <a:off x="731520" y="365760"/>
+            <a:ext cx="10698480" cy="274320"/>
+          </a:xfrm>
+          <a:prstGeom prst="rect">
+            <a:avLst/>
+          </a:prstGeom>
+          <a:noFill/>
+        </p:spPr>
+        <p:txBody>
+          <a:bodyPr wrap="square" lIns="0" rIns="0" tIns="0" bIns="0">
+            <a:spAutoFit/>
+          </a:bodyPr>
+          <a:lstStyle/>
+          <a:p>
+            <a:r>
+              <a:rPr sz="1000" b="1" i="0">
+                <a:solidFill>
+                  <a:srgbClr val="1D4ED8"/>
+                </a:solidFill>
+                <a:latin typeface="Segoe UI"/>
+              </a:rPr>
+              <a:t>PRACTICE SCENARIO 7 OF 10</a:t>
+            </a:r>
+          </a:p>
+        </p:txBody>
+      </p:sp>
+      <p:sp>
+        <p:nvSpPr>
+          <p:cNvPr id="3" name="TextBox 2"/>
+          <p:cNvSpPr txBox="1"/>
+          <p:nvPr/>
+        </p:nvSpPr>
+        <p:spPr>
+          <a:xfrm>
+            <a:off x="731520" y="640080"/>
+            <a:ext cx="10698480" cy="548640"/>
+          </a:xfrm>
+          <a:prstGeom prst="rect">
+            <a:avLst/>
+          </a:prstGeom>
+          <a:noFill/>
+        </p:spPr>
+        <p:txBody>
+          <a:bodyPr wrap="square" lIns="0" rIns="0" tIns="0" bIns="0">
+            <a:spAutoFit/>
+          </a:bodyPr>
+          <a:lstStyle/>
+          <a:p>
+            <a:r>
+              <a:rPr sz="2800" b="1" i="0">
+                <a:solidFill>
+                  <a:srgbClr val="18181B"/>
+                </a:solidFill>
+                <a:latin typeface="Segoe UI"/>
+              </a:rPr>
+              <a:t>Least Privilege Access Control</a:t>
+            </a:r>
+          </a:p>
+        </p:txBody>
+      </p:sp>
+      <p:sp>
+        <p:nvSpPr>
+          <p:cNvPr id="4" name="TextBox 3"/>
+          <p:cNvSpPr txBox="1"/>
+          <p:nvPr/>
+        </p:nvSpPr>
+        <p:spPr>
+          <a:xfrm>
+            <a:off x="731520" y="1371600"/>
+            <a:ext cx="6217920" cy="4754880"/>
+          </a:xfrm>
+          <a:prstGeom prst="rect">
+            <a:avLst/>
+          </a:prstGeom>
+          <a:noFill/>
+        </p:spPr>
+        <p:txBody>
+          <a:bodyPr wrap="square" lIns="0" rIns="0" tIns="0" bIns="0">
+            <a:spAutoFit/>
+          </a:bodyPr>
+          <a:lstStyle/>
+          <a:p>
+            <a:pPr>
+              <a:spcAft>
+                <a:spcPts val="1400"/>
+              </a:spcAft>
+            </a:pPr>
+            <a:r>
+              <a:rPr sz="1200" b="1" i="0">
+                <a:solidFill>
+                  <a:srgbClr val="18181B"/>
+                </a:solidFill>
+                <a:latin typeface="Segoe UI"/>
+              </a:rPr>
+              <a:t>You are deploying an online prediction service on GKE that queries Vertex AI Feature Store to fetch user feature vectors during inference. To comply with security best practices, what IAM role should be assigned to the GKE service account?</a:t>
+            </a:r>
+          </a:p>
+          <a:p>
+            <a:pPr>
+              <a:spcAft>
+                <a:spcPts val="800"/>
+              </a:spcAft>
+            </a:pPr>
+            <a:r>
+              <a:rPr sz="1100" b="1" i="0">
+                <a:solidFill>
+                  <a:srgbClr val="1D4ED8"/>
+                </a:solidFill>
+                <a:latin typeface="Segoe UI"/>
+              </a:rPr>
+              <a:t>A.  </a:t>
+            </a:r>
+            <a:r>
+              <a:rPr sz="1100" b="0" i="0">
+                <a:solidFill>
+                  <a:srgbClr val="3F3F46"/>
+                </a:solidFill>
+                <a:latin typeface="Segoe UI"/>
+              </a:rPr>
+              <a:t>roles/aiplatform.user</a:t>
+            </a:r>
+          </a:p>
+          <a:p>
+            <a:pPr>
+              <a:spcAft>
+                <a:spcPts val="800"/>
+              </a:spcAft>
+            </a:pPr>
+            <a:r>
+              <a:rPr sz="1100" b="1" i="0">
+                <a:solidFill>
+                  <a:srgbClr val="1D4ED8"/>
+                </a:solidFill>
+                <a:latin typeface="Segoe UI"/>
+              </a:rPr>
+              <a:t>B.  </a:t>
+            </a:r>
+            <a:r>
+              <a:rPr sz="1100" b="0" i="0">
+                <a:solidFill>
+                  <a:srgbClr val="3F3F46"/>
+                </a:solidFill>
+                <a:latin typeface="Segoe UI"/>
+              </a:rPr>
+              <a:t>roles/aiplatform.admin</a:t>
+            </a:r>
+          </a:p>
+          <a:p>
+            <a:pPr>
+              <a:spcAft>
+                <a:spcPts val="800"/>
+              </a:spcAft>
+            </a:pPr>
+            <a:r>
+              <a:rPr sz="1100" b="1" i="0">
+                <a:solidFill>
+                  <a:srgbClr val="1D4ED8"/>
+                </a:solidFill>
+                <a:latin typeface="Segoe UI"/>
+              </a:rPr>
+              <a:t>C.  </a:t>
+            </a:r>
+            <a:r>
+              <a:rPr sz="1100" b="0" i="0">
+                <a:solidFill>
+                  <a:srgbClr val="3F3F46"/>
+                </a:solidFill>
+                <a:latin typeface="Segoe UI"/>
+              </a:rPr>
+              <a:t>roles/owner</a:t>
+            </a:r>
+          </a:p>
+          <a:p>
+            <a:pPr>
+              <a:spcAft>
+                <a:spcPts val="800"/>
+              </a:spcAft>
+            </a:pPr>
+            <a:r>
+              <a:rPr sz="1100" b="1" i="0">
+                <a:solidFill>
+                  <a:srgbClr val="1D4ED8"/>
+                </a:solidFill>
+                <a:latin typeface="Segoe UI"/>
+              </a:rPr>
+              <a:t>D.  </a:t>
+            </a:r>
+            <a:r>
+              <a:rPr sz="1100" b="0" i="0">
+                <a:solidFill>
+                  <a:srgbClr val="3F3F46"/>
+                </a:solidFill>
+                <a:latin typeface="Segoe UI"/>
+              </a:rPr>
+              <a:t>roles/bigquery.dataEditor</a:t>
+            </a:r>
+          </a:p>
+        </p:txBody>
+      </p:sp>
+      <p:sp>
+        <p:nvSpPr>
+          <p:cNvPr id="5" name="Rounded Rectangle 4"/>
+          <p:cNvSpPr/>
+          <p:nvPr/>
+        </p:nvSpPr>
+        <p:spPr>
+          <a:xfrm>
+            <a:off x="7315200" y="1645920"/>
+            <a:ext cx="4114800" cy="4480560"/>
+          </a:xfrm>
+          <a:prstGeom prst="roundRect">
+            <a:avLst/>
+          </a:prstGeom>
+          <a:solidFill>
+            <a:srgbClr val="FFFFFF"/>
+          </a:solidFill>
+          <a:ln w="15240">
+            <a:solidFill>
+              <a:srgbClr val="D4D4D8"/>
+            </a:solidFill>
+          </a:ln>
+        </p:spPr>
+        <p:style>
+          <a:lnRef idx="1">
+            <a:schemeClr val="accent1"/>
+          </a:lnRef>
+          <a:fillRef idx="3">
+            <a:schemeClr val="accent1"/>
+          </a:fillRef>
+          <a:effectRef idx="2">
+            <a:schemeClr val="accent1"/>
+          </a:effectRef>
+          <a:fontRef idx="minor">
+            <a:schemeClr val="lt1"/>
+          </a:fontRef>
+        </p:style>
+        <p:txBody>
+          <a:bodyPr rtlCol="0" anchor="ctr" wrap="square" lIns="228600" rIns="228600" tIns="182880" bIns="182880"/>
+          <a:lstStyle/>
+          <a:p>
+            <a:pPr algn="ctr">
+              <a:spcAft>
+                <a:spcPts val="1200"/>
+              </a:spcAft>
+            </a:pPr>
+            <a:r>
+              <a:rPr sz="1600" b="1" i="0">
+                <a:solidFill>
+                  <a:srgbClr val="18181B"/>
+                </a:solidFill>
+                <a:latin typeface="Segoe UI"/>
+              </a:rPr>
+              <a:t>Validation Panel</a:t>
+            </a:r>
+          </a:p>
+          <a:p>
+            <a:pPr>
+              <a:spcAft>
+                <a:spcPts val="1000"/>
+              </a:spcAft>
+            </a:pPr>
+            <a:r>
+              <a:rPr sz="1400" b="1" i="0">
+                <a:solidFill>
+                  <a:srgbClr val="047857"/>
+                </a:solidFill>
+                <a:latin typeface="Segoe UI"/>
+              </a:rPr>
+              <a:t>Correct Answer: A</a:t>
+            </a:r>
+          </a:p>
+          <a:p>
+            <a:pPr>
+              <a:spcAft>
+                <a:spcPts val="1400"/>
+              </a:spcAft>
+            </a:pPr>
+            <a:r>
+              <a:rPr sz="1100" b="0" i="0">
+                <a:solidFill>
+                  <a:srgbClr val="3F3F46"/>
+                </a:solidFill>
+                <a:latin typeface="Segoe UI"/>
+              </a:rPr>
+              <a:t>Explanation: The `roles/aiplatform.user` role is the correct least privilege assignment for serving clients. It permits reading and listing feature store values, but does not allow administrative operations like editing groups or deleting stores.</a:t>
+            </a:r>
+          </a:p>
+          <a:p>
+            <a:r>
+              <a:rPr sz="950" b="0" i="1">
+                <a:solidFill>
+                  <a:srgbClr val="71717A"/>
+                </a:solidFill>
+                <a:latin typeface="Segoe UI"/>
+              </a:rPr>
+              <a:t>GCP Reference: https://cloud.google.com/vertex-ai/docs/general/access-control</a:t>
+            </a:r>
+          </a:p>
+        </p:txBody>
+      </p:sp>
+    </p:spTree>
+  </p:cSld>
+  <p:clrMapOvr>
+    <a:masterClrMapping/>
+  </p:clrMapOvr>
+</p:sld>
+</file>
+
 <file path=ppt/slides/slide2.xml><?xml version="1.0" encoding="utf-8"?>
 <p:sld xmlns:a="http://schemas.openxmlformats.org/drawingml/2006/main" xmlns:p="http://schemas.openxmlformats.org/presentationml/2006/main" xmlns:r="http://schemas.openxmlformats.org/officeDocument/2006/relationships">
   <p:cSld>
@@ -4686,6 +7034,1008 @@
                 <a:latin typeface="Segoe UI"/>
               </a:rPr>
               <a:t>Example: Both fraud and billing teams writing two separate Spark jobs to calculate daily_user_active_hours leads to code redundancy and cost waste.</a:t>
+            </a:r>
+          </a:p>
+        </p:txBody>
+      </p:sp>
+    </p:spTree>
+  </p:cSld>
+  <p:clrMapOvr>
+    <a:masterClrMapping/>
+  </p:clrMapOvr>
+</p:sld>
+</file>
+
+<file path=ppt/slides/slide20.xml><?xml version="1.0" encoding="utf-8"?>
+<p:sld xmlns:a="http://schemas.openxmlformats.org/drawingml/2006/main" xmlns:p="http://schemas.openxmlformats.org/presentationml/2006/main" xmlns:r="http://schemas.openxmlformats.org/officeDocument/2006/relationships">
+  <p:cSld>
+    <p:bg>
+      <p:bgPr>
+        <a:solidFill>
+          <a:srgbClr val="E4E4E6"/>
+        </a:solidFill>
+        <a:effectLst/>
+      </p:bgPr>
+    </p:bg>
+    <p:spTree>
+      <p:nvGrpSpPr>
+        <p:cNvPr id="1" name=""/>
+        <p:cNvGrpSpPr/>
+        <p:nvPr/>
+      </p:nvGrpSpPr>
+      <p:grpSpPr/>
+      <p:sp>
+        <p:nvSpPr>
+          <p:cNvPr id="2" name="TextBox 1"/>
+          <p:cNvSpPr txBox="1"/>
+          <p:nvPr/>
+        </p:nvSpPr>
+        <p:spPr>
+          <a:xfrm>
+            <a:off x="731520" y="365760"/>
+            <a:ext cx="10698480" cy="274320"/>
+          </a:xfrm>
+          <a:prstGeom prst="rect">
+            <a:avLst/>
+          </a:prstGeom>
+          <a:noFill/>
+        </p:spPr>
+        <p:txBody>
+          <a:bodyPr wrap="square" lIns="0" rIns="0" tIns="0" bIns="0">
+            <a:spAutoFit/>
+          </a:bodyPr>
+          <a:lstStyle/>
+          <a:p>
+            <a:r>
+              <a:rPr sz="1000" b="1" i="0">
+                <a:solidFill>
+                  <a:srgbClr val="1D4ED8"/>
+                </a:solidFill>
+                <a:latin typeface="Segoe UI"/>
+              </a:rPr>
+              <a:t>PRACTICE SCENARIO 8 OF 10</a:t>
+            </a:r>
+          </a:p>
+        </p:txBody>
+      </p:sp>
+      <p:sp>
+        <p:nvSpPr>
+          <p:cNvPr id="3" name="TextBox 2"/>
+          <p:cNvSpPr txBox="1"/>
+          <p:nvPr/>
+        </p:nvSpPr>
+        <p:spPr>
+          <a:xfrm>
+            <a:off x="731520" y="640080"/>
+            <a:ext cx="10698480" cy="548640"/>
+          </a:xfrm>
+          <a:prstGeom prst="rect">
+            <a:avLst/>
+          </a:prstGeom>
+          <a:noFill/>
+        </p:spPr>
+        <p:txBody>
+          <a:bodyPr wrap="square" lIns="0" rIns="0" tIns="0" bIns="0">
+            <a:spAutoFit/>
+          </a:bodyPr>
+          <a:lstStyle/>
+          <a:p>
+            <a:r>
+              <a:rPr sz="2800" b="1" i="0">
+                <a:solidFill>
+                  <a:srgbClr val="18181B"/>
+                </a:solidFill>
+                <a:latin typeface="Segoe UI"/>
+              </a:rPr>
+              <a:t>Model Monitoring &amp; Feature Drift</a:t>
+            </a:r>
+          </a:p>
+        </p:txBody>
+      </p:sp>
+      <p:sp>
+        <p:nvSpPr>
+          <p:cNvPr id="4" name="TextBox 3"/>
+          <p:cNvSpPr txBox="1"/>
+          <p:nvPr/>
+        </p:nvSpPr>
+        <p:spPr>
+          <a:xfrm>
+            <a:off x="731520" y="1371600"/>
+            <a:ext cx="6217920" cy="4754880"/>
+          </a:xfrm>
+          <a:prstGeom prst="rect">
+            <a:avLst/>
+          </a:prstGeom>
+          <a:noFill/>
+        </p:spPr>
+        <p:txBody>
+          <a:bodyPr wrap="square" lIns="0" rIns="0" tIns="0" bIns="0">
+            <a:spAutoFit/>
+          </a:bodyPr>
+          <a:lstStyle/>
+          <a:p>
+            <a:pPr>
+              <a:spcAft>
+                <a:spcPts val="1400"/>
+              </a:spcAft>
+            </a:pPr>
+            <a:r>
+              <a:rPr sz="1200" b="1" i="0">
+                <a:solidFill>
+                  <a:srgbClr val="18181B"/>
+                </a:solidFill>
+                <a:latin typeface="Segoe UI"/>
+              </a:rPr>
+              <a:t>An ecommerce classification model uses features from Vertex AI Feature Store. Over time, the distribution of user purchase behavior shifts, causing prediction accuracy to drop. How can the team automate detection of this feature drift?</a:t>
+            </a:r>
+          </a:p>
+          <a:p>
+            <a:pPr>
+              <a:spcAft>
+                <a:spcPts val="800"/>
+              </a:spcAft>
+            </a:pPr>
+            <a:r>
+              <a:rPr sz="1100" b="1" i="0">
+                <a:solidFill>
+                  <a:srgbClr val="1D4ED8"/>
+                </a:solidFill>
+                <a:latin typeface="Segoe UI"/>
+              </a:rPr>
+              <a:t>A.  </a:t>
+            </a:r>
+            <a:r>
+              <a:rPr sz="1100" b="0" i="0">
+                <a:solidFill>
+                  <a:srgbClr val="3F3F46"/>
+                </a:solidFill>
+                <a:latin typeface="Segoe UI"/>
+              </a:rPr>
+              <a:t>Run weekly statistical histograms manually inside local Jupyter notebooks to check variance.</a:t>
+            </a:r>
+          </a:p>
+          <a:p>
+            <a:pPr>
+              <a:spcAft>
+                <a:spcPts val="800"/>
+              </a:spcAft>
+            </a:pPr>
+            <a:r>
+              <a:rPr sz="1100" b="1" i="0">
+                <a:solidFill>
+                  <a:srgbClr val="1D4ED8"/>
+                </a:solidFill>
+                <a:latin typeface="Segoe UI"/>
+              </a:rPr>
+              <a:t>B.  </a:t>
+            </a:r>
+            <a:r>
+              <a:rPr sz="1100" b="0" i="0">
+                <a:solidFill>
+                  <a:srgbClr val="3F3F46"/>
+                </a:solidFill>
+                <a:latin typeface="Segoe UI"/>
+              </a:rPr>
+              <a:t>Write a custom alert script that monitors memory usage on GKE prediction pods.</a:t>
+            </a:r>
+          </a:p>
+          <a:p>
+            <a:pPr>
+              <a:spcAft>
+                <a:spcPts val="800"/>
+              </a:spcAft>
+            </a:pPr>
+            <a:r>
+              <a:rPr sz="1100" b="1" i="0">
+                <a:solidFill>
+                  <a:srgbClr val="1D4ED8"/>
+                </a:solidFill>
+                <a:latin typeface="Segoe UI"/>
+              </a:rPr>
+              <a:t>C.  </a:t>
+            </a:r>
+            <a:r>
+              <a:rPr sz="1100" b="0" i="0">
+                <a:solidFill>
+                  <a:srgbClr val="3F3F46"/>
+                </a:solidFill>
+                <a:latin typeface="Segoe UI"/>
+              </a:rPr>
+              <a:t>Re-train the model every 4 hours automatically to bypass checking if data drift exists.</a:t>
+            </a:r>
+          </a:p>
+          <a:p>
+            <a:pPr>
+              <a:spcAft>
+                <a:spcPts val="800"/>
+              </a:spcAft>
+            </a:pPr>
+            <a:r>
+              <a:rPr sz="1100" b="1" i="0">
+                <a:solidFill>
+                  <a:srgbClr val="1D4ED8"/>
+                </a:solidFill>
+                <a:latin typeface="Segoe UI"/>
+              </a:rPr>
+              <a:t>D.  </a:t>
+            </a:r>
+            <a:r>
+              <a:rPr sz="1100" b="0" i="0">
+                <a:solidFill>
+                  <a:srgbClr val="3F3F46"/>
+                </a:solidFill>
+                <a:latin typeface="Segoe UI"/>
+              </a:rPr>
+              <a:t>Configure Vertex AI Model Monitoring on the deployed prediction endpoint, setting the training data as the baseline, and tracking feature drift metrics.</a:t>
+            </a:r>
+          </a:p>
+        </p:txBody>
+      </p:sp>
+      <p:sp>
+        <p:nvSpPr>
+          <p:cNvPr id="5" name="Rounded Rectangle 4"/>
+          <p:cNvSpPr/>
+          <p:nvPr/>
+        </p:nvSpPr>
+        <p:spPr>
+          <a:xfrm>
+            <a:off x="7315200" y="1645920"/>
+            <a:ext cx="4114800" cy="4480560"/>
+          </a:xfrm>
+          <a:prstGeom prst="roundRect">
+            <a:avLst/>
+          </a:prstGeom>
+          <a:solidFill>
+            <a:srgbClr val="FFFFFF"/>
+          </a:solidFill>
+          <a:ln w="15240">
+            <a:solidFill>
+              <a:srgbClr val="D4D4D8"/>
+            </a:solidFill>
+          </a:ln>
+        </p:spPr>
+        <p:style>
+          <a:lnRef idx="1">
+            <a:schemeClr val="accent1"/>
+          </a:lnRef>
+          <a:fillRef idx="3">
+            <a:schemeClr val="accent1"/>
+          </a:fillRef>
+          <a:effectRef idx="2">
+            <a:schemeClr val="accent1"/>
+          </a:effectRef>
+          <a:fontRef idx="minor">
+            <a:schemeClr val="lt1"/>
+          </a:fontRef>
+        </p:style>
+        <p:txBody>
+          <a:bodyPr rtlCol="0" anchor="ctr" wrap="square" lIns="228600" rIns="228600" tIns="182880" bIns="182880"/>
+          <a:lstStyle/>
+          <a:p>
+            <a:pPr algn="ctr">
+              <a:spcAft>
+                <a:spcPts val="1200"/>
+              </a:spcAft>
+            </a:pPr>
+            <a:r>
+              <a:rPr sz="1600" b="1" i="0">
+                <a:solidFill>
+                  <a:srgbClr val="18181B"/>
+                </a:solidFill>
+                <a:latin typeface="Segoe UI"/>
+              </a:rPr>
+              <a:t>Validation Panel</a:t>
+            </a:r>
+          </a:p>
+          <a:p>
+            <a:pPr>
+              <a:spcAft>
+                <a:spcPts val="1000"/>
+              </a:spcAft>
+            </a:pPr>
+            <a:r>
+              <a:rPr sz="1400" b="1" i="0">
+                <a:solidFill>
+                  <a:srgbClr val="047857"/>
+                </a:solidFill>
+                <a:latin typeface="Segoe UI"/>
+              </a:rPr>
+              <a:t>Correct Answer: D</a:t>
+            </a:r>
+          </a:p>
+          <a:p>
+            <a:pPr>
+              <a:spcAft>
+                <a:spcPts val="1400"/>
+              </a:spcAft>
+            </a:pPr>
+            <a:r>
+              <a:rPr sz="1100" b="0" i="0">
+                <a:solidFill>
+                  <a:srgbClr val="3F3F46"/>
+                </a:solidFill>
+                <a:latin typeface="Segoe UI"/>
+              </a:rPr>
+              <a:t>Explanation: Vertex AI Model Monitoring runs continuous statistical scans of prediction requests, comparing them to training baselines. If metrics like Population Stability Index (PSI) cross thresholds, it fires alerts to retrain.</a:t>
+            </a:r>
+          </a:p>
+          <a:p>
+            <a:r>
+              <a:rPr sz="950" b="0" i="1">
+                <a:solidFill>
+                  <a:srgbClr val="71717A"/>
+                </a:solidFill>
+                <a:latin typeface="Segoe UI"/>
+              </a:rPr>
+              <a:t>GCP Reference: https://cloud.google.com/vertex-ai/docs/model-monitoring/overview</a:t>
+            </a:r>
+          </a:p>
+        </p:txBody>
+      </p:sp>
+    </p:spTree>
+  </p:cSld>
+  <p:clrMapOvr>
+    <a:masterClrMapping/>
+  </p:clrMapOvr>
+</p:sld>
+</file>
+
+<file path=ppt/slides/slide21.xml><?xml version="1.0" encoding="utf-8"?>
+<p:sld xmlns:a="http://schemas.openxmlformats.org/drawingml/2006/main" xmlns:p="http://schemas.openxmlformats.org/presentationml/2006/main" xmlns:r="http://schemas.openxmlformats.org/officeDocument/2006/relationships">
+  <p:cSld>
+    <p:bg>
+      <p:bgPr>
+        <a:solidFill>
+          <a:srgbClr val="E4E4E6"/>
+        </a:solidFill>
+        <a:effectLst/>
+      </p:bgPr>
+    </p:bg>
+    <p:spTree>
+      <p:nvGrpSpPr>
+        <p:cNvPr id="1" name=""/>
+        <p:cNvGrpSpPr/>
+        <p:nvPr/>
+      </p:nvGrpSpPr>
+      <p:grpSpPr/>
+      <p:sp>
+        <p:nvSpPr>
+          <p:cNvPr id="2" name="TextBox 1"/>
+          <p:cNvSpPr txBox="1"/>
+          <p:nvPr/>
+        </p:nvSpPr>
+        <p:spPr>
+          <a:xfrm>
+            <a:off x="731520" y="365760"/>
+            <a:ext cx="10698480" cy="274320"/>
+          </a:xfrm>
+          <a:prstGeom prst="rect">
+            <a:avLst/>
+          </a:prstGeom>
+          <a:noFill/>
+        </p:spPr>
+        <p:txBody>
+          <a:bodyPr wrap="square" lIns="0" rIns="0" tIns="0" bIns="0">
+            <a:spAutoFit/>
+          </a:bodyPr>
+          <a:lstStyle/>
+          <a:p>
+            <a:r>
+              <a:rPr sz="1000" b="1" i="0">
+                <a:solidFill>
+                  <a:srgbClr val="1D4ED8"/>
+                </a:solidFill>
+                <a:latin typeface="Segoe UI"/>
+              </a:rPr>
+              <a:t>PRACTICE SCENARIO 9 OF 10</a:t>
+            </a:r>
+          </a:p>
+        </p:txBody>
+      </p:sp>
+      <p:sp>
+        <p:nvSpPr>
+          <p:cNvPr id="3" name="TextBox 2"/>
+          <p:cNvSpPr txBox="1"/>
+          <p:nvPr/>
+        </p:nvSpPr>
+        <p:spPr>
+          <a:xfrm>
+            <a:off x="731520" y="640080"/>
+            <a:ext cx="10698480" cy="548640"/>
+          </a:xfrm>
+          <a:prstGeom prst="rect">
+            <a:avLst/>
+          </a:prstGeom>
+          <a:noFill/>
+        </p:spPr>
+        <p:txBody>
+          <a:bodyPr wrap="square" lIns="0" rIns="0" tIns="0" bIns="0">
+            <a:spAutoFit/>
+          </a:bodyPr>
+          <a:lstStyle/>
+          <a:p>
+            <a:r>
+              <a:rPr sz="2800" b="1" i="0">
+                <a:solidFill>
+                  <a:srgbClr val="18181B"/>
+                </a:solidFill>
+                <a:latin typeface="Segoe UI"/>
+              </a:rPr>
+              <a:t>Upgrading Feature Store Architecture</a:t>
+            </a:r>
+          </a:p>
+        </p:txBody>
+      </p:sp>
+      <p:sp>
+        <p:nvSpPr>
+          <p:cNvPr id="4" name="TextBox 3"/>
+          <p:cNvSpPr txBox="1"/>
+          <p:nvPr/>
+        </p:nvSpPr>
+        <p:spPr>
+          <a:xfrm>
+            <a:off x="731520" y="1371600"/>
+            <a:ext cx="6217920" cy="4754880"/>
+          </a:xfrm>
+          <a:prstGeom prst="rect">
+            <a:avLst/>
+          </a:prstGeom>
+          <a:noFill/>
+        </p:spPr>
+        <p:txBody>
+          <a:bodyPr wrap="square" lIns="0" rIns="0" tIns="0" bIns="0">
+            <a:spAutoFit/>
+          </a:bodyPr>
+          <a:lstStyle/>
+          <a:p>
+            <a:pPr>
+              <a:spcAft>
+                <a:spcPts val="1400"/>
+              </a:spcAft>
+            </a:pPr>
+            <a:r>
+              <a:rPr sz="1200" b="1" i="0">
+                <a:solidFill>
+                  <a:srgbClr val="18181B"/>
+                </a:solidFill>
+                <a:latin typeface="Segoe UI"/>
+              </a:rPr>
+              <a:t>An ML team has been using the legacy Vertex AI Feature Store (which manages its own storage nodes and requires periodic manual syncs). They want to adopt the latest version of Vertex AI Feature Store to reduce operational costs and enable zero-copy sharing. What structural change should they make?</a:t>
+            </a:r>
+          </a:p>
+          <a:p>
+            <a:pPr>
+              <a:spcAft>
+                <a:spcPts val="800"/>
+              </a:spcAft>
+            </a:pPr>
+            <a:r>
+              <a:rPr sz="1100" b="1" i="0">
+                <a:solidFill>
+                  <a:srgbClr val="1D4ED8"/>
+                </a:solidFill>
+                <a:latin typeface="Segoe UI"/>
+              </a:rPr>
+              <a:t>A.  </a:t>
+            </a:r>
+            <a:r>
+              <a:rPr sz="1100" b="0" i="0">
+                <a:solidFill>
+                  <a:srgbClr val="3F3F46"/>
+                </a:solidFill>
+                <a:latin typeface="Segoe UI"/>
+              </a:rPr>
+              <a:t>Rebuild the ETL scripts in Dataflow to export direct JSON profiles to Memorystore for Redis.</a:t>
+            </a:r>
+          </a:p>
+          <a:p>
+            <a:pPr>
+              <a:spcAft>
+                <a:spcPts val="800"/>
+              </a:spcAft>
+            </a:pPr>
+            <a:r>
+              <a:rPr sz="1100" b="1" i="0">
+                <a:solidFill>
+                  <a:srgbClr val="1D4ED8"/>
+                </a:solidFill>
+                <a:latin typeface="Segoe UI"/>
+              </a:rPr>
+              <a:t>B.  </a:t>
+            </a:r>
+            <a:r>
+              <a:rPr sz="1100" b="0" i="0">
+                <a:solidFill>
+                  <a:srgbClr val="3F3F46"/>
+                </a:solidFill>
+                <a:latin typeface="Segoe UI"/>
+              </a:rPr>
+              <a:t>Migrate to the latest BigQuery-centric Feature Store and register existing BigQuery tables or logical views directly as Feature Groups.</a:t>
+            </a:r>
+          </a:p>
+          <a:p>
+            <a:pPr>
+              <a:spcAft>
+                <a:spcPts val="800"/>
+              </a:spcAft>
+            </a:pPr>
+            <a:r>
+              <a:rPr sz="1100" b="1" i="0">
+                <a:solidFill>
+                  <a:srgbClr val="1D4ED8"/>
+                </a:solidFill>
+                <a:latin typeface="Segoe UI"/>
+              </a:rPr>
+              <a:t>C.  </a:t>
+            </a:r>
+            <a:r>
+              <a:rPr sz="1100" b="0" i="0">
+                <a:solidFill>
+                  <a:srgbClr val="3F3F46"/>
+                </a:solidFill>
+                <a:latin typeface="Segoe UI"/>
+              </a:rPr>
+              <a:t>Switch all machine learning features to local CSV files hosted on Compute Engine instances.</a:t>
+            </a:r>
+          </a:p>
+          <a:p>
+            <a:pPr>
+              <a:spcAft>
+                <a:spcPts val="800"/>
+              </a:spcAft>
+            </a:pPr>
+            <a:r>
+              <a:rPr sz="1100" b="1" i="0">
+                <a:solidFill>
+                  <a:srgbClr val="1D4ED8"/>
+                </a:solidFill>
+                <a:latin typeface="Segoe UI"/>
+              </a:rPr>
+              <a:t>D.  </a:t>
+            </a:r>
+            <a:r>
+              <a:rPr sz="1100" b="0" i="0">
+                <a:solidFill>
+                  <a:srgbClr val="3F3F46"/>
+                </a:solidFill>
+                <a:latin typeface="Segoe UI"/>
+              </a:rPr>
+              <a:t>Re-deploy the legacy feature store nodes inside multiple different GCP zones.</a:t>
+            </a:r>
+          </a:p>
+        </p:txBody>
+      </p:sp>
+      <p:sp>
+        <p:nvSpPr>
+          <p:cNvPr id="5" name="Rounded Rectangle 4"/>
+          <p:cNvSpPr/>
+          <p:nvPr/>
+        </p:nvSpPr>
+        <p:spPr>
+          <a:xfrm>
+            <a:off x="7315200" y="1645920"/>
+            <a:ext cx="4114800" cy="4480560"/>
+          </a:xfrm>
+          <a:prstGeom prst="roundRect">
+            <a:avLst/>
+          </a:prstGeom>
+          <a:solidFill>
+            <a:srgbClr val="FFFFFF"/>
+          </a:solidFill>
+          <a:ln w="15240">
+            <a:solidFill>
+              <a:srgbClr val="D4D4D8"/>
+            </a:solidFill>
+          </a:ln>
+        </p:spPr>
+        <p:style>
+          <a:lnRef idx="1">
+            <a:schemeClr val="accent1"/>
+          </a:lnRef>
+          <a:fillRef idx="3">
+            <a:schemeClr val="accent1"/>
+          </a:fillRef>
+          <a:effectRef idx="2">
+            <a:schemeClr val="accent1"/>
+          </a:effectRef>
+          <a:fontRef idx="minor">
+            <a:schemeClr val="lt1"/>
+          </a:fontRef>
+        </p:style>
+        <p:txBody>
+          <a:bodyPr rtlCol="0" anchor="ctr" wrap="square" lIns="228600" rIns="228600" tIns="182880" bIns="182880"/>
+          <a:lstStyle/>
+          <a:p>
+            <a:pPr algn="ctr">
+              <a:spcAft>
+                <a:spcPts val="1200"/>
+              </a:spcAft>
+            </a:pPr>
+            <a:r>
+              <a:rPr sz="1600" b="1" i="0">
+                <a:solidFill>
+                  <a:srgbClr val="18181B"/>
+                </a:solidFill>
+                <a:latin typeface="Segoe UI"/>
+              </a:rPr>
+              <a:t>Validation Panel</a:t>
+            </a:r>
+          </a:p>
+          <a:p>
+            <a:pPr>
+              <a:spcAft>
+                <a:spcPts val="1000"/>
+              </a:spcAft>
+            </a:pPr>
+            <a:r>
+              <a:rPr sz="1400" b="1" i="0">
+                <a:solidFill>
+                  <a:srgbClr val="047857"/>
+                </a:solidFill>
+                <a:latin typeface="Segoe UI"/>
+              </a:rPr>
+              <a:t>Correct Answer: B</a:t>
+            </a:r>
+          </a:p>
+          <a:p>
+            <a:pPr>
+              <a:spcAft>
+                <a:spcPts val="1400"/>
+              </a:spcAft>
+            </a:pPr>
+            <a:r>
+              <a:rPr sz="1100" b="0" i="0">
+                <a:solidFill>
+                  <a:srgbClr val="3F3F46"/>
+                </a:solidFill>
+                <a:latin typeface="Segoe UI"/>
+              </a:rPr>
+              <a:t>Explanation: The latest version of Vertex AI Feature Store is built around BigQuery as a single source of truth. It allows defining Feature Groups directly on BigQuery schemas, achieving zero-copy synchronization and lowering management cost.</a:t>
+            </a:r>
+          </a:p>
+          <a:p>
+            <a:r>
+              <a:rPr sz="950" b="0" i="1">
+                <a:solidFill>
+                  <a:srgbClr val="71717A"/>
+                </a:solidFill>
+                <a:latin typeface="Segoe UI"/>
+              </a:rPr>
+              <a:t>GCP Reference: https://cloud.google.com/vertex-ai/docs/featurestore/latest/overview</a:t>
+            </a:r>
+          </a:p>
+        </p:txBody>
+      </p:sp>
+    </p:spTree>
+  </p:cSld>
+  <p:clrMapOvr>
+    <a:masterClrMapping/>
+  </p:clrMapOvr>
+</p:sld>
+</file>
+
+<file path=ppt/slides/slide22.xml><?xml version="1.0" encoding="utf-8"?>
+<p:sld xmlns:a="http://schemas.openxmlformats.org/drawingml/2006/main" xmlns:p="http://schemas.openxmlformats.org/presentationml/2006/main" xmlns:r="http://schemas.openxmlformats.org/officeDocument/2006/relationships">
+  <p:cSld>
+    <p:bg>
+      <p:bgPr>
+        <a:solidFill>
+          <a:srgbClr val="E4E4E6"/>
+        </a:solidFill>
+        <a:effectLst/>
+      </p:bgPr>
+    </p:bg>
+    <p:spTree>
+      <p:nvGrpSpPr>
+        <p:cNvPr id="1" name=""/>
+        <p:cNvGrpSpPr/>
+        <p:nvPr/>
+      </p:nvGrpSpPr>
+      <p:grpSpPr/>
+      <p:sp>
+        <p:nvSpPr>
+          <p:cNvPr id="2" name="TextBox 1"/>
+          <p:cNvSpPr txBox="1"/>
+          <p:nvPr/>
+        </p:nvSpPr>
+        <p:spPr>
+          <a:xfrm>
+            <a:off x="731520" y="365760"/>
+            <a:ext cx="10698480" cy="274320"/>
+          </a:xfrm>
+          <a:prstGeom prst="rect">
+            <a:avLst/>
+          </a:prstGeom>
+          <a:noFill/>
+        </p:spPr>
+        <p:txBody>
+          <a:bodyPr wrap="square" lIns="0" rIns="0" tIns="0" bIns="0">
+            <a:spAutoFit/>
+          </a:bodyPr>
+          <a:lstStyle/>
+          <a:p>
+            <a:r>
+              <a:rPr sz="1000" b="1" i="0">
+                <a:solidFill>
+                  <a:srgbClr val="1D4ED8"/>
+                </a:solidFill>
+                <a:latin typeface="Segoe UI"/>
+              </a:rPr>
+              <a:t>PRACTICE SCENARIO 10 OF 10</a:t>
+            </a:r>
+          </a:p>
+        </p:txBody>
+      </p:sp>
+      <p:sp>
+        <p:nvSpPr>
+          <p:cNvPr id="3" name="TextBox 2"/>
+          <p:cNvSpPr txBox="1"/>
+          <p:nvPr/>
+        </p:nvSpPr>
+        <p:spPr>
+          <a:xfrm>
+            <a:off x="731520" y="640080"/>
+            <a:ext cx="10698480" cy="548640"/>
+          </a:xfrm>
+          <a:prstGeom prst="rect">
+            <a:avLst/>
+          </a:prstGeom>
+          <a:noFill/>
+        </p:spPr>
+        <p:txBody>
+          <a:bodyPr wrap="square" lIns="0" rIns="0" tIns="0" bIns="0">
+            <a:spAutoFit/>
+          </a:bodyPr>
+          <a:lstStyle/>
+          <a:p>
+            <a:r>
+              <a:rPr sz="2800" b="1" i="0">
+                <a:solidFill>
+                  <a:srgbClr val="18181B"/>
+                </a:solidFill>
+                <a:latin typeface="Segoe UI"/>
+              </a:rPr>
+              <a:t>Handling Missing Features</a:t>
+            </a:r>
+          </a:p>
+        </p:txBody>
+      </p:sp>
+      <p:sp>
+        <p:nvSpPr>
+          <p:cNvPr id="4" name="TextBox 3"/>
+          <p:cNvSpPr txBox="1"/>
+          <p:nvPr/>
+        </p:nvSpPr>
+        <p:spPr>
+          <a:xfrm>
+            <a:off x="731520" y="1371600"/>
+            <a:ext cx="6217920" cy="4754880"/>
+          </a:xfrm>
+          <a:prstGeom prst="rect">
+            <a:avLst/>
+          </a:prstGeom>
+          <a:noFill/>
+        </p:spPr>
+        <p:txBody>
+          <a:bodyPr wrap="square" lIns="0" rIns="0" tIns="0" bIns="0">
+            <a:spAutoFit/>
+          </a:bodyPr>
+          <a:lstStyle/>
+          <a:p>
+            <a:pPr>
+              <a:spcAft>
+                <a:spcPts val="1400"/>
+              </a:spcAft>
+            </a:pPr>
+            <a:r>
+              <a:rPr sz="1200" b="1" i="0">
+                <a:solidFill>
+                  <a:srgbClr val="18181B"/>
+                </a:solidFill>
+                <a:latin typeface="Segoe UI"/>
+              </a:rPr>
+              <a:t>During online serving, a prediction request arrives for a newly registered user who does not yet have calculated feature values in the Feature Store. The model requires valid numerical inputs. How should the pipeline handle this?</a:t>
+            </a:r>
+          </a:p>
+          <a:p>
+            <a:pPr>
+              <a:spcAft>
+                <a:spcPts val="800"/>
+              </a:spcAft>
+            </a:pPr>
+            <a:r>
+              <a:rPr sz="1100" b="1" i="0">
+                <a:solidFill>
+                  <a:srgbClr val="1D4ED8"/>
+                </a:solidFill>
+                <a:latin typeface="Segoe UI"/>
+              </a:rPr>
+              <a:t>A.  </a:t>
+            </a:r>
+            <a:r>
+              <a:rPr sz="1100" b="0" i="0">
+                <a:solidFill>
+                  <a:srgbClr val="3F3F46"/>
+                </a:solidFill>
+                <a:latin typeface="Segoe UI"/>
+              </a:rPr>
+              <a:t>Configure the GKE serving application to catch empty/NULL responses from the Feature Store and impute them using pre-calculated median or mean statistics.</a:t>
+            </a:r>
+          </a:p>
+          <a:p>
+            <a:pPr>
+              <a:spcAft>
+                <a:spcPts val="800"/>
+              </a:spcAft>
+            </a:pPr>
+            <a:r>
+              <a:rPr sz="1100" b="1" i="0">
+                <a:solidFill>
+                  <a:srgbClr val="1D4ED8"/>
+                </a:solidFill>
+                <a:latin typeface="Segoe UI"/>
+              </a:rPr>
+              <a:t>B.  </a:t>
+            </a:r>
+            <a:r>
+              <a:rPr sz="1100" b="0" i="0">
+                <a:solidFill>
+                  <a:srgbClr val="3F3F46"/>
+                </a:solidFill>
+                <a:latin typeface="Segoe UI"/>
+              </a:rPr>
+              <a:t>Allow the model prediction to fail and return an HTTP 500 error to the customer application.</a:t>
+            </a:r>
+          </a:p>
+          <a:p>
+            <a:pPr>
+              <a:spcAft>
+                <a:spcPts val="800"/>
+              </a:spcAft>
+            </a:pPr>
+            <a:r>
+              <a:rPr sz="1100" b="1" i="0">
+                <a:solidFill>
+                  <a:srgbClr val="1D4ED8"/>
+                </a:solidFill>
+                <a:latin typeface="Segoe UI"/>
+              </a:rPr>
+              <a:t>C.  </a:t>
+            </a:r>
+            <a:r>
+              <a:rPr sz="1100" b="0" i="0">
+                <a:solidFill>
+                  <a:srgbClr val="3F3F46"/>
+                </a:solidFill>
+                <a:latin typeface="Segoe UI"/>
+              </a:rPr>
+              <a:t>Block user registrations until their feature extraction batch job finishes running at midnight.</a:t>
+            </a:r>
+          </a:p>
+          <a:p>
+            <a:pPr>
+              <a:spcAft>
+                <a:spcPts val="800"/>
+              </a:spcAft>
+            </a:pPr>
+            <a:r>
+              <a:rPr sz="1100" b="1" i="0">
+                <a:solidFill>
+                  <a:srgbClr val="1D4ED8"/>
+                </a:solidFill>
+                <a:latin typeface="Segoe UI"/>
+              </a:rPr>
+              <a:t>D.  </a:t>
+            </a:r>
+            <a:r>
+              <a:rPr sz="1100" b="0" i="0">
+                <a:solidFill>
+                  <a:srgbClr val="3F3F46"/>
+                </a:solidFill>
+                <a:latin typeface="Segoe UI"/>
+              </a:rPr>
+              <a:t>Set the missing features to extremely high values (e.g. 99999) to bypass inputs verification.</a:t>
+            </a:r>
+          </a:p>
+        </p:txBody>
+      </p:sp>
+      <p:sp>
+        <p:nvSpPr>
+          <p:cNvPr id="5" name="Rounded Rectangle 4"/>
+          <p:cNvSpPr/>
+          <p:nvPr/>
+        </p:nvSpPr>
+        <p:spPr>
+          <a:xfrm>
+            <a:off x="7315200" y="1645920"/>
+            <a:ext cx="4114800" cy="4480560"/>
+          </a:xfrm>
+          <a:prstGeom prst="roundRect">
+            <a:avLst/>
+          </a:prstGeom>
+          <a:solidFill>
+            <a:srgbClr val="FFFFFF"/>
+          </a:solidFill>
+          <a:ln w="15240">
+            <a:solidFill>
+              <a:srgbClr val="D4D4D8"/>
+            </a:solidFill>
+          </a:ln>
+        </p:spPr>
+        <p:style>
+          <a:lnRef idx="1">
+            <a:schemeClr val="accent1"/>
+          </a:lnRef>
+          <a:fillRef idx="3">
+            <a:schemeClr val="accent1"/>
+          </a:fillRef>
+          <a:effectRef idx="2">
+            <a:schemeClr val="accent1"/>
+          </a:effectRef>
+          <a:fontRef idx="minor">
+            <a:schemeClr val="lt1"/>
+          </a:fontRef>
+        </p:style>
+        <p:txBody>
+          <a:bodyPr rtlCol="0" anchor="ctr" wrap="square" lIns="228600" rIns="228600" tIns="182880" bIns="182880"/>
+          <a:lstStyle/>
+          <a:p>
+            <a:pPr algn="ctr">
+              <a:spcAft>
+                <a:spcPts val="1200"/>
+              </a:spcAft>
+            </a:pPr>
+            <a:r>
+              <a:rPr sz="1600" b="1" i="0">
+                <a:solidFill>
+                  <a:srgbClr val="18181B"/>
+                </a:solidFill>
+                <a:latin typeface="Segoe UI"/>
+              </a:rPr>
+              <a:t>Validation Panel</a:t>
+            </a:r>
+          </a:p>
+          <a:p>
+            <a:pPr>
+              <a:spcAft>
+                <a:spcPts val="1000"/>
+              </a:spcAft>
+            </a:pPr>
+            <a:r>
+              <a:rPr sz="1400" b="1" i="0">
+                <a:solidFill>
+                  <a:srgbClr val="047857"/>
+                </a:solidFill>
+                <a:latin typeface="Segoe UI"/>
+              </a:rPr>
+              <a:t>Correct Answer: A</a:t>
+            </a:r>
+          </a:p>
+          <a:p>
+            <a:pPr>
+              <a:spcAft>
+                <a:spcPts val="1400"/>
+              </a:spcAft>
+            </a:pPr>
+            <a:r>
+              <a:rPr sz="1100" b="0" i="0">
+                <a:solidFill>
+                  <a:srgbClr val="3F3F46"/>
+                </a:solidFill>
+                <a:latin typeface="Segoe UI"/>
+              </a:rPr>
+              <a:t>Explanation: Cold-start users will lack history in the feature store registry, returning NULL. Imputing values in the serving API wrapper (using pre-aggregated median/mean values) prevents inference model crashes.</a:t>
+            </a:r>
+          </a:p>
+          <a:p>
+            <a:r>
+              <a:rPr sz="950" b="0" i="1">
+                <a:solidFill>
+                  <a:srgbClr val="71717A"/>
+                </a:solidFill>
+                <a:latin typeface="Segoe UI"/>
+              </a:rPr>
+              <a:t>GCP Reference: https://cloud.google.com/vertex-ai/docs/featurestore/latest/read-feature-values</a:t>
             </a:r>
           </a:p>
         </p:txBody>

</xml_diff>

<commit_message>
Remove slides 8, 9, 11 from Generative AI deck, re-index safety/checklist, append 10 Q&A scenario slides, and update PPTX compiler
</commit_message>
<xml_diff>
--- a/featurestore-presentation/Vertex_AI_Feature_Store.pptx
+++ b/featurestore-presentation/Vertex_AI_Feature_Store.pptx
@@ -5,30 +5,30 @@
     <p:sldMasterId id="2147483648" r:id="rId1"/>
   </p:sldMasterIdLst>
   <p:sldIdLst>
-    <p:sldId id="256" r:id="rId7"/>
-    <p:sldId id="257" r:id="rId8"/>
-    <p:sldId id="258" r:id="rId9"/>
-    <p:sldId id="259" r:id="rId10"/>
-    <p:sldId id="260" r:id="rId11"/>
-    <p:sldId id="261" r:id="rId12"/>
-    <p:sldId id="262" r:id="rId13"/>
-    <p:sldId id="263" r:id="rId14"/>
-    <p:sldId id="264" r:id="rId15"/>
-    <p:sldId id="265" r:id="rId16"/>
-    <p:sldId id="266" r:id="rId17"/>
-    <p:sldId id="267" r:id="rId18"/>
-    <p:sldId id="268" r:id="rId19"/>
-    <p:sldId id="269" r:id="rId20"/>
-    <p:sldId id="270" r:id="rId21"/>
-    <p:sldId id="271" r:id="rId22"/>
-    <p:sldId id="272" r:id="rId23"/>
-    <p:sldId id="273" r:id="rId24"/>
-    <p:sldId id="274" r:id="rId25"/>
-    <p:sldId id="275" r:id="rId26"/>
-    <p:sldId id="276" r:id="rId27"/>
-    <p:sldId id="277" r:id="rId28"/>
+    <p:sldId id="256" r:id="rId2"/>
+    <p:sldId id="257" r:id="rId3"/>
+    <p:sldId id="258" r:id="rId4"/>
+    <p:sldId id="259" r:id="rId5"/>
+    <p:sldId id="260" r:id="rId6"/>
+    <p:sldId id="261" r:id="rId7"/>
+    <p:sldId id="262" r:id="rId8"/>
+    <p:sldId id="263" r:id="rId9"/>
+    <p:sldId id="264" r:id="rId10"/>
+    <p:sldId id="265" r:id="rId11"/>
+    <p:sldId id="266" r:id="rId12"/>
+    <p:sldId id="267" r:id="rId13"/>
+    <p:sldId id="268" r:id="rId14"/>
+    <p:sldId id="269" r:id="rId15"/>
+    <p:sldId id="270" r:id="rId16"/>
+    <p:sldId id="271" r:id="rId17"/>
+    <p:sldId id="272" r:id="rId18"/>
+    <p:sldId id="273" r:id="rId19"/>
+    <p:sldId id="274" r:id="rId20"/>
+    <p:sldId id="275" r:id="rId21"/>
+    <p:sldId id="276" r:id="rId22"/>
+    <p:sldId id="277" r:id="rId23"/>
   </p:sldIdLst>
-  <p:sldSz cx="12191695" cy="6858000" type="screen4x3"/>
+  <p:sldSz cx="12192000" cy="6858000"/>
   <p:notesSz cx="6858000" cy="9144000"/>
   <p:defaultTextStyle>
     <a:defPPr>
@@ -125,6 +125,22 @@
       </a:defRPr>
     </a:lvl9pPr>
   </p:defaultTextStyle>
+  <p:extLst>
+    <p:ext uri="{EFAFB233-063F-42B5-8137-9DF3F51BA10A}">
+      <p15:sldGuideLst xmlns:p15="http://schemas.microsoft.com/office/powerpoint/2012/main">
+        <p15:guide id="1" orient="horz" pos="2160">
+          <p15:clr>
+            <a:srgbClr val="A4A3A4"/>
+          </p15:clr>
+        </p15:guide>
+        <p15:guide id="2" pos="2880">
+          <p15:clr>
+            <a:srgbClr val="A4A3A4"/>
+          </p15:clr>
+        </p15:guide>
+      </p15:sldGuideLst>
+    </p:ext>
+  </p:extLst>
 </p:presentation>
 </file>
 
@@ -166,10 +182,9 @@
           <a:lstStyle/>
           <a:p>
             <a:r>
-              <a:rPr lang="en-US" smtClean="0"/>
+              <a:rPr lang="en-US"/>
               <a:t>Click to edit Master title style</a:t>
             </a:r>
-            <a:endParaRPr lang="en-US"/>
           </a:p>
         </p:txBody>
       </p:sp>
@@ -285,10 +300,9 @@
           </a:lstStyle>
           <a:p>
             <a:r>
-              <a:rPr lang="en-US" smtClean="0"/>
+              <a:rPr lang="en-US"/>
               <a:t>Click to edit Master subtitle style</a:t>
             </a:r>
-            <a:endParaRPr lang="en-US"/>
           </a:p>
         </p:txBody>
       </p:sp>
@@ -309,7 +323,7 @@
           <a:p>
             <a:fld id="{5BCAD085-E8A6-8845-BD4E-CB4CCA059FC4}" type="datetimeFigureOut">
               <a:rPr lang="en-US" smtClean="0"/>
-              <a:t>1/27/13</a:t>
+              <a:t>6/14/2026</a:t>
             </a:fld>
             <a:endParaRPr lang="en-US"/>
           </a:p>
@@ -403,10 +417,9 @@
           <a:lstStyle/>
           <a:p>
             <a:r>
-              <a:rPr lang="en-US" smtClean="0"/>
+              <a:rPr lang="en-US"/>
               <a:t>Click to edit Master title style</a:t>
             </a:r>
-            <a:endParaRPr lang="en-US"/>
           </a:p>
         </p:txBody>
       </p:sp>
@@ -427,38 +440,37 @@
           <a:p>
             <a:pPr lvl="0"/>
             <a:r>
-              <a:rPr lang="en-US" smtClean="0"/>
+              <a:rPr lang="en-US"/>
               <a:t>Click to edit Master text styles</a:t>
             </a:r>
           </a:p>
           <a:p>
             <a:pPr lvl="1"/>
             <a:r>
-              <a:rPr lang="en-US" smtClean="0"/>
+              <a:rPr lang="en-US"/>
               <a:t>Second level</a:t>
             </a:r>
           </a:p>
           <a:p>
             <a:pPr lvl="2"/>
             <a:r>
-              <a:rPr lang="en-US" smtClean="0"/>
+              <a:rPr lang="en-US"/>
               <a:t>Third level</a:t>
             </a:r>
           </a:p>
           <a:p>
             <a:pPr lvl="3"/>
             <a:r>
-              <a:rPr lang="en-US" smtClean="0"/>
+              <a:rPr lang="en-US"/>
               <a:t>Fourth level</a:t>
             </a:r>
           </a:p>
           <a:p>
             <a:pPr lvl="4"/>
             <a:r>
-              <a:rPr lang="en-US" smtClean="0"/>
+              <a:rPr lang="en-US"/>
               <a:t>Fifth level</a:t>
             </a:r>
-            <a:endParaRPr lang="en-US"/>
           </a:p>
         </p:txBody>
       </p:sp>
@@ -479,7 +491,7 @@
           <a:p>
             <a:fld id="{5BCAD085-E8A6-8845-BD4E-CB4CCA059FC4}" type="datetimeFigureOut">
               <a:rPr lang="en-US" smtClean="0"/>
-              <a:t>1/27/13</a:t>
+              <a:t>6/14/2026</a:t>
             </a:fld>
             <a:endParaRPr lang="en-US"/>
           </a:p>
@@ -578,10 +590,9 @@
           <a:lstStyle/>
           <a:p>
             <a:r>
-              <a:rPr lang="en-US" smtClean="0"/>
+              <a:rPr lang="en-US"/>
               <a:t>Click to edit Master title style</a:t>
             </a:r>
-            <a:endParaRPr lang="en-US"/>
           </a:p>
         </p:txBody>
       </p:sp>
@@ -607,38 +618,37 @@
           <a:p>
             <a:pPr lvl="0"/>
             <a:r>
-              <a:rPr lang="en-US" smtClean="0"/>
+              <a:rPr lang="en-US"/>
               <a:t>Click to edit Master text styles</a:t>
             </a:r>
           </a:p>
           <a:p>
             <a:pPr lvl="1"/>
             <a:r>
-              <a:rPr lang="en-US" smtClean="0"/>
+              <a:rPr lang="en-US"/>
               <a:t>Second level</a:t>
             </a:r>
           </a:p>
           <a:p>
             <a:pPr lvl="2"/>
             <a:r>
-              <a:rPr lang="en-US" smtClean="0"/>
+              <a:rPr lang="en-US"/>
               <a:t>Third level</a:t>
             </a:r>
           </a:p>
           <a:p>
             <a:pPr lvl="3"/>
             <a:r>
-              <a:rPr lang="en-US" smtClean="0"/>
+              <a:rPr lang="en-US"/>
               <a:t>Fourth level</a:t>
             </a:r>
           </a:p>
           <a:p>
             <a:pPr lvl="4"/>
             <a:r>
-              <a:rPr lang="en-US" smtClean="0"/>
+              <a:rPr lang="en-US"/>
               <a:t>Fifth level</a:t>
             </a:r>
-            <a:endParaRPr lang="en-US"/>
           </a:p>
         </p:txBody>
       </p:sp>
@@ -659,7 +669,7 @@
           <a:p>
             <a:fld id="{5BCAD085-E8A6-8845-BD4E-CB4CCA059FC4}" type="datetimeFigureOut">
               <a:rPr lang="en-US" smtClean="0"/>
-              <a:t>1/27/13</a:t>
+              <a:t>6/14/2026</a:t>
             </a:fld>
             <a:endParaRPr lang="en-US"/>
           </a:p>
@@ -753,10 +763,9 @@
           <a:lstStyle/>
           <a:p>
             <a:r>
-              <a:rPr lang="en-US" smtClean="0"/>
+              <a:rPr lang="en-US"/>
               <a:t>Click to edit Master title style</a:t>
             </a:r>
-            <a:endParaRPr lang="en-US"/>
           </a:p>
         </p:txBody>
       </p:sp>
@@ -777,38 +786,37 @@
           <a:p>
             <a:pPr lvl="0"/>
             <a:r>
-              <a:rPr lang="en-US" smtClean="0"/>
+              <a:rPr lang="en-US"/>
               <a:t>Click to edit Master text styles</a:t>
             </a:r>
           </a:p>
           <a:p>
             <a:pPr lvl="1"/>
             <a:r>
-              <a:rPr lang="en-US" smtClean="0"/>
+              <a:rPr lang="en-US"/>
               <a:t>Second level</a:t>
             </a:r>
           </a:p>
           <a:p>
             <a:pPr lvl="2"/>
             <a:r>
-              <a:rPr lang="en-US" smtClean="0"/>
+              <a:rPr lang="en-US"/>
               <a:t>Third level</a:t>
             </a:r>
           </a:p>
           <a:p>
             <a:pPr lvl="3"/>
             <a:r>
-              <a:rPr lang="en-US" smtClean="0"/>
+              <a:rPr lang="en-US"/>
               <a:t>Fourth level</a:t>
             </a:r>
           </a:p>
           <a:p>
             <a:pPr lvl="4"/>
             <a:r>
-              <a:rPr lang="en-US" smtClean="0"/>
+              <a:rPr lang="en-US"/>
               <a:t>Fifth level</a:t>
             </a:r>
-            <a:endParaRPr lang="en-US"/>
           </a:p>
         </p:txBody>
       </p:sp>
@@ -829,7 +837,7 @@
           <a:p>
             <a:fld id="{5BCAD085-E8A6-8845-BD4E-CB4CCA059FC4}" type="datetimeFigureOut">
               <a:rPr lang="en-US" smtClean="0"/>
-              <a:t>1/27/13</a:t>
+              <a:t>6/14/2026</a:t>
             </a:fld>
             <a:endParaRPr lang="en-US"/>
           </a:p>
@@ -932,10 +940,9 @@
           </a:lstStyle>
           <a:p>
             <a:r>
-              <a:rPr lang="en-US" smtClean="0"/>
+              <a:rPr lang="en-US"/>
               <a:t>Click to edit Master title style</a:t>
             </a:r>
-            <a:endParaRPr lang="en-US"/>
           </a:p>
         </p:txBody>
       </p:sp>
@@ -1052,7 +1059,7 @@
           <a:p>
             <a:pPr lvl="0"/>
             <a:r>
-              <a:rPr lang="en-US" smtClean="0"/>
+              <a:rPr lang="en-US"/>
               <a:t>Click to edit Master text styles</a:t>
             </a:r>
           </a:p>
@@ -1075,7 +1082,7 @@
           <a:p>
             <a:fld id="{5BCAD085-E8A6-8845-BD4E-CB4CCA059FC4}" type="datetimeFigureOut">
               <a:rPr lang="en-US" smtClean="0"/>
-              <a:t>1/27/13</a:t>
+              <a:t>6/14/2026</a:t>
             </a:fld>
             <a:endParaRPr lang="en-US"/>
           </a:p>
@@ -1169,10 +1176,9 @@
           <a:lstStyle/>
           <a:p>
             <a:r>
-              <a:rPr lang="en-US" smtClean="0"/>
+              <a:rPr lang="en-US"/>
               <a:t>Click to edit Master title style</a:t>
             </a:r>
-            <a:endParaRPr lang="en-US"/>
           </a:p>
         </p:txBody>
       </p:sp>
@@ -1226,38 +1232,37 @@
           <a:p>
             <a:pPr lvl="0"/>
             <a:r>
-              <a:rPr lang="en-US" smtClean="0"/>
+              <a:rPr lang="en-US"/>
               <a:t>Click to edit Master text styles</a:t>
             </a:r>
           </a:p>
           <a:p>
             <a:pPr lvl="1"/>
             <a:r>
-              <a:rPr lang="en-US" smtClean="0"/>
+              <a:rPr lang="en-US"/>
               <a:t>Second level</a:t>
             </a:r>
           </a:p>
           <a:p>
             <a:pPr lvl="2"/>
             <a:r>
-              <a:rPr lang="en-US" smtClean="0"/>
+              <a:rPr lang="en-US"/>
               <a:t>Third level</a:t>
             </a:r>
           </a:p>
           <a:p>
             <a:pPr lvl="3"/>
             <a:r>
-              <a:rPr lang="en-US" smtClean="0"/>
+              <a:rPr lang="en-US"/>
               <a:t>Fourth level</a:t>
             </a:r>
           </a:p>
           <a:p>
             <a:pPr lvl="4"/>
             <a:r>
-              <a:rPr lang="en-US" smtClean="0"/>
+              <a:rPr lang="en-US"/>
               <a:t>Fifth level</a:t>
             </a:r>
-            <a:endParaRPr lang="en-US"/>
           </a:p>
         </p:txBody>
       </p:sp>
@@ -1311,38 +1316,37 @@
           <a:p>
             <a:pPr lvl="0"/>
             <a:r>
-              <a:rPr lang="en-US" smtClean="0"/>
+              <a:rPr lang="en-US"/>
               <a:t>Click to edit Master text styles</a:t>
             </a:r>
           </a:p>
           <a:p>
             <a:pPr lvl="1"/>
             <a:r>
-              <a:rPr lang="en-US" smtClean="0"/>
+              <a:rPr lang="en-US"/>
               <a:t>Second level</a:t>
             </a:r>
           </a:p>
           <a:p>
             <a:pPr lvl="2"/>
             <a:r>
-              <a:rPr lang="en-US" smtClean="0"/>
+              <a:rPr lang="en-US"/>
               <a:t>Third level</a:t>
             </a:r>
           </a:p>
           <a:p>
             <a:pPr lvl="3"/>
             <a:r>
-              <a:rPr lang="en-US" smtClean="0"/>
+              <a:rPr lang="en-US"/>
               <a:t>Fourth level</a:t>
             </a:r>
           </a:p>
           <a:p>
             <a:pPr lvl="4"/>
             <a:r>
-              <a:rPr lang="en-US" smtClean="0"/>
+              <a:rPr lang="en-US"/>
               <a:t>Fifth level</a:t>
             </a:r>
-            <a:endParaRPr lang="en-US"/>
           </a:p>
         </p:txBody>
       </p:sp>
@@ -1363,7 +1367,7 @@
           <a:p>
             <a:fld id="{5BCAD085-E8A6-8845-BD4E-CB4CCA059FC4}" type="datetimeFigureOut">
               <a:rPr lang="en-US" smtClean="0"/>
-              <a:t>1/27/13</a:t>
+              <a:t>6/14/2026</a:t>
             </a:fld>
             <a:endParaRPr lang="en-US"/>
           </a:p>
@@ -1461,10 +1465,9 @@
           </a:lstStyle>
           <a:p>
             <a:r>
-              <a:rPr lang="en-US" smtClean="0"/>
+              <a:rPr lang="en-US"/>
               <a:t>Click to edit Master title style</a:t>
             </a:r>
-            <a:endParaRPr lang="en-US"/>
           </a:p>
         </p:txBody>
       </p:sp>
@@ -1527,7 +1530,7 @@
           <a:p>
             <a:pPr lvl="0"/>
             <a:r>
-              <a:rPr lang="en-US" smtClean="0"/>
+              <a:rPr lang="en-US"/>
               <a:t>Click to edit Master text styles</a:t>
             </a:r>
           </a:p>
@@ -1583,38 +1586,37 @@
           <a:p>
             <a:pPr lvl="0"/>
             <a:r>
-              <a:rPr lang="en-US" smtClean="0"/>
+              <a:rPr lang="en-US"/>
               <a:t>Click to edit Master text styles</a:t>
             </a:r>
           </a:p>
           <a:p>
             <a:pPr lvl="1"/>
             <a:r>
-              <a:rPr lang="en-US" smtClean="0"/>
+              <a:rPr lang="en-US"/>
               <a:t>Second level</a:t>
             </a:r>
           </a:p>
           <a:p>
             <a:pPr lvl="2"/>
             <a:r>
-              <a:rPr lang="en-US" smtClean="0"/>
+              <a:rPr lang="en-US"/>
               <a:t>Third level</a:t>
             </a:r>
           </a:p>
           <a:p>
             <a:pPr lvl="3"/>
             <a:r>
-              <a:rPr lang="en-US" smtClean="0"/>
+              <a:rPr lang="en-US"/>
               <a:t>Fourth level</a:t>
             </a:r>
           </a:p>
           <a:p>
             <a:pPr lvl="4"/>
             <a:r>
-              <a:rPr lang="en-US" smtClean="0"/>
+              <a:rPr lang="en-US"/>
               <a:t>Fifth level</a:t>
             </a:r>
-            <a:endParaRPr lang="en-US"/>
           </a:p>
         </p:txBody>
       </p:sp>
@@ -1677,7 +1679,7 @@
           <a:p>
             <a:pPr lvl="0"/>
             <a:r>
-              <a:rPr lang="en-US" smtClean="0"/>
+              <a:rPr lang="en-US"/>
               <a:t>Click to edit Master text styles</a:t>
             </a:r>
           </a:p>
@@ -1733,38 +1735,37 @@
           <a:p>
             <a:pPr lvl="0"/>
             <a:r>
-              <a:rPr lang="en-US" smtClean="0"/>
+              <a:rPr lang="en-US"/>
               <a:t>Click to edit Master text styles</a:t>
             </a:r>
           </a:p>
           <a:p>
             <a:pPr lvl="1"/>
             <a:r>
-              <a:rPr lang="en-US" smtClean="0"/>
+              <a:rPr lang="en-US"/>
               <a:t>Second level</a:t>
             </a:r>
           </a:p>
           <a:p>
             <a:pPr lvl="2"/>
             <a:r>
-              <a:rPr lang="en-US" smtClean="0"/>
+              <a:rPr lang="en-US"/>
               <a:t>Third level</a:t>
             </a:r>
           </a:p>
           <a:p>
             <a:pPr lvl="3"/>
             <a:r>
-              <a:rPr lang="en-US" smtClean="0"/>
+              <a:rPr lang="en-US"/>
               <a:t>Fourth level</a:t>
             </a:r>
           </a:p>
           <a:p>
             <a:pPr lvl="4"/>
             <a:r>
-              <a:rPr lang="en-US" smtClean="0"/>
+              <a:rPr lang="en-US"/>
               <a:t>Fifth level</a:t>
             </a:r>
-            <a:endParaRPr lang="en-US"/>
           </a:p>
         </p:txBody>
       </p:sp>
@@ -1785,7 +1786,7 @@
           <a:p>
             <a:fld id="{5BCAD085-E8A6-8845-BD4E-CB4CCA059FC4}" type="datetimeFigureOut">
               <a:rPr lang="en-US" smtClean="0"/>
-              <a:t>1/27/13</a:t>
+              <a:t>6/14/2026</a:t>
             </a:fld>
             <a:endParaRPr lang="en-US"/>
           </a:p>
@@ -1879,10 +1880,9 @@
           <a:lstStyle/>
           <a:p>
             <a:r>
-              <a:rPr lang="en-US" smtClean="0"/>
+              <a:rPr lang="en-US"/>
               <a:t>Click to edit Master title style</a:t>
             </a:r>
-            <a:endParaRPr lang="en-US"/>
           </a:p>
         </p:txBody>
       </p:sp>
@@ -1903,7 +1903,7 @@
           <a:p>
             <a:fld id="{5BCAD085-E8A6-8845-BD4E-CB4CCA059FC4}" type="datetimeFigureOut">
               <a:rPr lang="en-US" smtClean="0"/>
-              <a:t>1/27/13</a:t>
+              <a:t>6/14/2026</a:t>
             </a:fld>
             <a:endParaRPr lang="en-US"/>
           </a:p>
@@ -1998,7 +1998,7 @@
           <a:p>
             <a:fld id="{5BCAD085-E8A6-8845-BD4E-CB4CCA059FC4}" type="datetimeFigureOut">
               <a:rPr lang="en-US" smtClean="0"/>
-              <a:t>1/27/13</a:t>
+              <a:t>6/14/2026</a:t>
             </a:fld>
             <a:endParaRPr lang="en-US"/>
           </a:p>
@@ -2101,10 +2101,9 @@
           </a:lstStyle>
           <a:p>
             <a:r>
-              <a:rPr lang="en-US" smtClean="0"/>
+              <a:rPr lang="en-US"/>
               <a:t>Click to edit Master title style</a:t>
             </a:r>
-            <a:endParaRPr lang="en-US"/>
           </a:p>
         </p:txBody>
       </p:sp>
@@ -2158,38 +2157,37 @@
           <a:p>
             <a:pPr lvl="0"/>
             <a:r>
-              <a:rPr lang="en-US" smtClean="0"/>
+              <a:rPr lang="en-US"/>
               <a:t>Click to edit Master text styles</a:t>
             </a:r>
           </a:p>
           <a:p>
             <a:pPr lvl="1"/>
             <a:r>
-              <a:rPr lang="en-US" smtClean="0"/>
+              <a:rPr lang="en-US"/>
               <a:t>Second level</a:t>
             </a:r>
           </a:p>
           <a:p>
             <a:pPr lvl="2"/>
             <a:r>
-              <a:rPr lang="en-US" smtClean="0"/>
+              <a:rPr lang="en-US"/>
               <a:t>Third level</a:t>
             </a:r>
           </a:p>
           <a:p>
             <a:pPr lvl="3"/>
             <a:r>
-              <a:rPr lang="en-US" smtClean="0"/>
+              <a:rPr lang="en-US"/>
               <a:t>Fourth level</a:t>
             </a:r>
           </a:p>
           <a:p>
             <a:pPr lvl="4"/>
             <a:r>
-              <a:rPr lang="en-US" smtClean="0"/>
+              <a:rPr lang="en-US"/>
               <a:t>Fifth level</a:t>
             </a:r>
-            <a:endParaRPr lang="en-US"/>
           </a:p>
         </p:txBody>
       </p:sp>
@@ -2252,7 +2250,7 @@
           <a:p>
             <a:pPr lvl="0"/>
             <a:r>
-              <a:rPr lang="en-US" smtClean="0"/>
+              <a:rPr lang="en-US"/>
               <a:t>Click to edit Master text styles</a:t>
             </a:r>
           </a:p>
@@ -2275,7 +2273,7 @@
           <a:p>
             <a:fld id="{5BCAD085-E8A6-8845-BD4E-CB4CCA059FC4}" type="datetimeFigureOut">
               <a:rPr lang="en-US" smtClean="0"/>
-              <a:t>1/27/13</a:t>
+              <a:t>6/14/2026</a:t>
             </a:fld>
             <a:endParaRPr lang="en-US"/>
           </a:p>
@@ -2378,10 +2376,9 @@
           </a:lstStyle>
           <a:p>
             <a:r>
-              <a:rPr lang="en-US" smtClean="0"/>
+              <a:rPr lang="en-US"/>
               <a:t>Click to edit Master title style</a:t>
             </a:r>
-            <a:endParaRPr lang="en-US"/>
           </a:p>
         </p:txBody>
       </p:sp>
@@ -2505,7 +2502,7 @@
           <a:p>
             <a:pPr lvl="0"/>
             <a:r>
-              <a:rPr lang="en-US" smtClean="0"/>
+              <a:rPr lang="en-US"/>
               <a:t>Click to edit Master text styles</a:t>
             </a:r>
           </a:p>
@@ -2528,7 +2525,7 @@
           <a:p>
             <a:fld id="{5BCAD085-E8A6-8845-BD4E-CB4CCA059FC4}" type="datetimeFigureOut">
               <a:rPr lang="en-US" smtClean="0"/>
-              <a:t>1/27/13</a:t>
+              <a:t>6/14/2026</a:t>
             </a:fld>
             <a:endParaRPr lang="en-US"/>
           </a:p>
@@ -2637,10 +2634,9 @@
           <a:lstStyle/>
           <a:p>
             <a:r>
-              <a:rPr lang="en-US" smtClean="0"/>
+              <a:rPr lang="en-US"/>
               <a:t>Click to edit Master title style</a:t>
             </a:r>
-            <a:endParaRPr lang="en-US"/>
           </a:p>
         </p:txBody>
       </p:sp>
@@ -2671,38 +2667,37 @@
           <a:p>
             <a:pPr lvl="0"/>
             <a:r>
-              <a:rPr lang="en-US" smtClean="0"/>
+              <a:rPr lang="en-US"/>
               <a:t>Click to edit Master text styles</a:t>
             </a:r>
           </a:p>
           <a:p>
             <a:pPr lvl="1"/>
             <a:r>
-              <a:rPr lang="en-US" smtClean="0"/>
+              <a:rPr lang="en-US"/>
               <a:t>Second level</a:t>
             </a:r>
           </a:p>
           <a:p>
             <a:pPr lvl="2"/>
             <a:r>
-              <a:rPr lang="en-US" smtClean="0"/>
+              <a:rPr lang="en-US"/>
               <a:t>Third level</a:t>
             </a:r>
           </a:p>
           <a:p>
             <a:pPr lvl="3"/>
             <a:r>
-              <a:rPr lang="en-US" smtClean="0"/>
+              <a:rPr lang="en-US"/>
               <a:t>Fourth level</a:t>
             </a:r>
           </a:p>
           <a:p>
             <a:pPr lvl="4"/>
             <a:r>
-              <a:rPr lang="en-US" smtClean="0"/>
+              <a:rPr lang="en-US"/>
               <a:t>Fifth level</a:t>
             </a:r>
-            <a:endParaRPr lang="en-US"/>
           </a:p>
         </p:txBody>
       </p:sp>
@@ -2741,7 +2736,7 @@
           <a:p>
             <a:fld id="{5BCAD085-E8A6-8845-BD4E-CB4CCA059FC4}" type="datetimeFigureOut">
               <a:rPr lang="en-US" smtClean="0"/>
-              <a:t>1/27/13</a:t>
+              <a:t>6/14/2026</a:t>
             </a:fld>
             <a:endParaRPr lang="en-US"/>
           </a:p>
@@ -3100,7 +3095,7 @@
 </file>
 
 <file path=ppt/slides/slide1.xml><?xml version="1.0" encoding="utf-8"?>
-<p:sld xmlns:a="http://schemas.openxmlformats.org/drawingml/2006/main" xmlns:p="http://schemas.openxmlformats.org/presentationml/2006/main" xmlns:r="http://schemas.openxmlformats.org/officeDocument/2006/relationships">
+<p:sld xmlns:a="http://schemas.openxmlformats.org/drawingml/2006/main" xmlns:r="http://schemas.openxmlformats.org/officeDocument/2006/relationships" xmlns:p="http://schemas.openxmlformats.org/presentationml/2006/main">
   <p:cSld>
     <p:bg>
       <p:bgPr>
@@ -3116,7 +3111,14 @@
         <p:cNvGrpSpPr/>
         <p:nvPr/>
       </p:nvGrpSpPr>
-      <p:grpSpPr/>
+      <p:grpSpPr>
+        <a:xfrm>
+          <a:off x="0" y="0"/>
+          <a:ext cx="0" cy="0"/>
+          <a:chOff x="0" y="0"/>
+          <a:chExt cx="0" cy="0"/>
+        </a:xfrm>
+      </p:grpSpPr>
       <p:sp>
         <p:nvSpPr>
           <p:cNvPr id="2" name="TextBox 1"/>
@@ -3134,7 +3136,7 @@
           <a:noFill/>
         </p:spPr>
         <p:txBody>
-          <a:bodyPr wrap="square" lIns="0" rIns="0" tIns="0" bIns="0">
+          <a:bodyPr wrap="square" lIns="0" tIns="0" rIns="0" bIns="0">
             <a:spAutoFit/>
           </a:bodyPr>
           <a:lstStyle/>
@@ -3205,7 +3207,7 @@
           <a:noFill/>
         </p:spPr>
         <p:txBody>
-          <a:bodyPr wrap="square" lIns="0" rIns="0" tIns="0" bIns="0">
+          <a:bodyPr wrap="square" lIns="0" tIns="0" rIns="0" bIns="0">
             <a:spAutoFit/>
           </a:bodyPr>
           <a:lstStyle/>
@@ -3231,7 +3233,7 @@
 </file>
 
 <file path=ppt/slides/slide10.xml><?xml version="1.0" encoding="utf-8"?>
-<p:sld xmlns:a="http://schemas.openxmlformats.org/drawingml/2006/main" xmlns:p="http://schemas.openxmlformats.org/presentationml/2006/main" xmlns:r="http://schemas.openxmlformats.org/officeDocument/2006/relationships">
+<p:sld xmlns:a="http://schemas.openxmlformats.org/drawingml/2006/main" xmlns:r="http://schemas.openxmlformats.org/officeDocument/2006/relationships" xmlns:p="http://schemas.openxmlformats.org/presentationml/2006/main">
   <p:cSld>
     <p:bg>
       <p:bgPr>
@@ -3247,7 +3249,14 @@
         <p:cNvGrpSpPr/>
         <p:nvPr/>
       </p:nvGrpSpPr>
-      <p:grpSpPr/>
+      <p:grpSpPr>
+        <a:xfrm>
+          <a:off x="0" y="0"/>
+          <a:ext cx="0" cy="0"/>
+          <a:chOff x="0" y="0"/>
+          <a:chExt cx="0" cy="0"/>
+        </a:xfrm>
+      </p:grpSpPr>
       <p:sp>
         <p:nvSpPr>
           <p:cNvPr id="2" name="TextBox 1"/>
@@ -3265,7 +3274,7 @@
           <a:noFill/>
         </p:spPr>
         <p:txBody>
-          <a:bodyPr wrap="square" lIns="0" rIns="0" tIns="0" bIns="0">
+          <a:bodyPr wrap="square" lIns="0" tIns="0" rIns="0" bIns="0">
             <a:spAutoFit/>
           </a:bodyPr>
           <a:lstStyle/>
@@ -3299,7 +3308,7 @@
           <a:noFill/>
         </p:spPr>
         <p:txBody>
-          <a:bodyPr wrap="square" lIns="0" rIns="0" tIns="0" bIns="0">
+          <a:bodyPr wrap="square" lIns="0" tIns="0" rIns="0" bIns="0">
             <a:spAutoFit/>
           </a:bodyPr>
           <a:lstStyle/>
@@ -3333,7 +3342,7 @@
           <a:noFill/>
         </p:spPr>
         <p:txBody>
-          <a:bodyPr wrap="square" lIns="0" rIns="0" tIns="0" bIns="0">
+          <a:bodyPr wrap="square" lIns="0" tIns="0" rIns="0" bIns="0">
             <a:spAutoFit/>
           </a:bodyPr>
           <a:lstStyle/>
@@ -3479,7 +3488,7 @@
           </a:fontRef>
         </p:style>
         <p:txBody>
-          <a:bodyPr rtlCol="0" anchor="ctr" wrap="square" lIns="182880" rIns="182880" tIns="109728" bIns="109728"/>
+          <a:bodyPr wrap="square" lIns="182880" tIns="109728" rIns="182880" bIns="109728" rtlCol="0" anchor="ctr"/>
           <a:lstStyle/>
           <a:p>
             <a:pPr algn="ctr">
@@ -3548,7 +3557,7 @@
           </a:fontRef>
         </p:style>
         <p:txBody>
-          <a:bodyPr rtlCol="0" anchor="ctr" wrap="square" lIns="228600" rIns="228600" tIns="182880" bIns="182880"/>
+          <a:bodyPr wrap="square" lIns="228600" tIns="182880" rIns="228600" bIns="182880" rtlCol="0" anchor="ctr"/>
           <a:lstStyle/>
           <a:p>
             <a:pPr algn="ctr">
@@ -3588,7 +3597,7 @@
 </file>
 
 <file path=ppt/slides/slide11.xml><?xml version="1.0" encoding="utf-8"?>
-<p:sld xmlns:a="http://schemas.openxmlformats.org/drawingml/2006/main" xmlns:p="http://schemas.openxmlformats.org/presentationml/2006/main" xmlns:r="http://schemas.openxmlformats.org/officeDocument/2006/relationships">
+<p:sld xmlns:a="http://schemas.openxmlformats.org/drawingml/2006/main" xmlns:r="http://schemas.openxmlformats.org/officeDocument/2006/relationships" xmlns:p="http://schemas.openxmlformats.org/presentationml/2006/main">
   <p:cSld>
     <p:bg>
       <p:bgPr>
@@ -3604,7 +3613,14 @@
         <p:cNvGrpSpPr/>
         <p:nvPr/>
       </p:nvGrpSpPr>
-      <p:grpSpPr/>
+      <p:grpSpPr>
+        <a:xfrm>
+          <a:off x="0" y="0"/>
+          <a:ext cx="0" cy="0"/>
+          <a:chOff x="0" y="0"/>
+          <a:chExt cx="0" cy="0"/>
+        </a:xfrm>
+      </p:grpSpPr>
       <p:sp>
         <p:nvSpPr>
           <p:cNvPr id="2" name="TextBox 1"/>
@@ -3622,7 +3638,7 @@
           <a:noFill/>
         </p:spPr>
         <p:txBody>
-          <a:bodyPr wrap="square" lIns="0" rIns="0" tIns="0" bIns="0">
+          <a:bodyPr wrap="square" lIns="0" tIns="0" rIns="0" bIns="0">
             <a:spAutoFit/>
           </a:bodyPr>
           <a:lstStyle/>
@@ -3656,7 +3672,7 @@
           <a:noFill/>
         </p:spPr>
         <p:txBody>
-          <a:bodyPr wrap="square" lIns="0" rIns="0" tIns="0" bIns="0">
+          <a:bodyPr wrap="square" lIns="0" tIns="0" rIns="0" bIns="0">
             <a:spAutoFit/>
           </a:bodyPr>
           <a:lstStyle/>
@@ -3690,7 +3706,7 @@
           <a:noFill/>
         </p:spPr>
         <p:txBody>
-          <a:bodyPr wrap="square" lIns="0" rIns="0" tIns="0" bIns="0">
+          <a:bodyPr wrap="square" lIns="0" tIns="0" rIns="0" bIns="0">
             <a:spAutoFit/>
           </a:bodyPr>
           <a:lstStyle/>
@@ -3836,7 +3852,7 @@
           </a:fontRef>
         </p:style>
         <p:txBody>
-          <a:bodyPr rtlCol="0" anchor="ctr" wrap="square" lIns="182880" rIns="182880" tIns="109728" bIns="109728"/>
+          <a:bodyPr wrap="square" lIns="182880" tIns="109728" rIns="182880" bIns="109728" rtlCol="0" anchor="ctr"/>
           <a:lstStyle/>
           <a:p>
             <a:pPr algn="ctr">
@@ -3905,7 +3921,7 @@
           </a:fontRef>
         </p:style>
         <p:txBody>
-          <a:bodyPr rtlCol="0" anchor="ctr" wrap="square" lIns="228600" rIns="228600" tIns="182880" bIns="182880"/>
+          <a:bodyPr wrap="square" lIns="228600" tIns="182880" rIns="228600" bIns="182880" rtlCol="0" anchor="ctr"/>
           <a:lstStyle/>
           <a:p>
             <a:pPr algn="ctr">
@@ -3945,7 +3961,7 @@
 </file>
 
 <file path=ppt/slides/slide12.xml><?xml version="1.0" encoding="utf-8"?>
-<p:sld xmlns:a="http://schemas.openxmlformats.org/drawingml/2006/main" xmlns:p="http://schemas.openxmlformats.org/presentationml/2006/main" xmlns:r="http://schemas.openxmlformats.org/officeDocument/2006/relationships">
+<p:sld xmlns:a="http://schemas.openxmlformats.org/drawingml/2006/main" xmlns:r="http://schemas.openxmlformats.org/officeDocument/2006/relationships" xmlns:p="http://schemas.openxmlformats.org/presentationml/2006/main">
   <p:cSld>
     <p:bg>
       <p:bgPr>
@@ -3961,7 +3977,14 @@
         <p:cNvGrpSpPr/>
         <p:nvPr/>
       </p:nvGrpSpPr>
-      <p:grpSpPr/>
+      <p:grpSpPr>
+        <a:xfrm>
+          <a:off x="0" y="0"/>
+          <a:ext cx="0" cy="0"/>
+          <a:chOff x="0" y="0"/>
+          <a:chExt cx="0" cy="0"/>
+        </a:xfrm>
+      </p:grpSpPr>
       <p:sp>
         <p:nvSpPr>
           <p:cNvPr id="2" name="TextBox 1"/>
@@ -3979,7 +4002,7 @@
           <a:noFill/>
         </p:spPr>
         <p:txBody>
-          <a:bodyPr wrap="square" lIns="0" rIns="0" tIns="0" bIns="0">
+          <a:bodyPr wrap="square" lIns="0" tIns="0" rIns="0" bIns="0">
             <a:spAutoFit/>
           </a:bodyPr>
           <a:lstStyle/>
@@ -4013,7 +4036,7 @@
           <a:noFill/>
         </p:spPr>
         <p:txBody>
-          <a:bodyPr wrap="square" lIns="0" rIns="0" tIns="0" bIns="0">
+          <a:bodyPr wrap="square" lIns="0" tIns="0" rIns="0" bIns="0">
             <a:spAutoFit/>
           </a:bodyPr>
           <a:lstStyle/>
@@ -4047,7 +4070,7 @@
           <a:noFill/>
         </p:spPr>
         <p:txBody>
-          <a:bodyPr wrap="square" lIns="0" rIns="0" tIns="0" bIns="0">
+          <a:bodyPr wrap="square" lIns="0" tIns="0" rIns="0" bIns="0">
             <a:spAutoFit/>
           </a:bodyPr>
           <a:lstStyle/>
@@ -4227,7 +4250,7 @@
           </a:fontRef>
         </p:style>
         <p:txBody>
-          <a:bodyPr rtlCol="0" anchor="ctr" wrap="square" lIns="182880" rIns="182880" tIns="109728" bIns="109728"/>
+          <a:bodyPr wrap="square" lIns="182880" tIns="109728" rIns="182880" bIns="109728" rtlCol="0" anchor="ctr"/>
           <a:lstStyle/>
           <a:p>
             <a:pPr algn="ctr">
@@ -4296,7 +4319,7 @@
           </a:fontRef>
         </p:style>
         <p:txBody>
-          <a:bodyPr rtlCol="0" anchor="ctr" wrap="square" lIns="228600" rIns="228600" tIns="182880" bIns="182880"/>
+          <a:bodyPr wrap="square" lIns="228600" tIns="182880" rIns="228600" bIns="182880" rtlCol="0" anchor="ctr"/>
           <a:lstStyle/>
           <a:p>
             <a:pPr algn="ctr">
@@ -4336,7 +4359,7 @@
 </file>
 
 <file path=ppt/slides/slide13.xml><?xml version="1.0" encoding="utf-8"?>
-<p:sld xmlns:a="http://schemas.openxmlformats.org/drawingml/2006/main" xmlns:p="http://schemas.openxmlformats.org/presentationml/2006/main" xmlns:r="http://schemas.openxmlformats.org/officeDocument/2006/relationships">
+<p:sld xmlns:a="http://schemas.openxmlformats.org/drawingml/2006/main" xmlns:r="http://schemas.openxmlformats.org/officeDocument/2006/relationships" xmlns:p="http://schemas.openxmlformats.org/presentationml/2006/main">
   <p:cSld>
     <p:bg>
       <p:bgPr>
@@ -4352,7 +4375,14 @@
         <p:cNvGrpSpPr/>
         <p:nvPr/>
       </p:nvGrpSpPr>
-      <p:grpSpPr/>
+      <p:grpSpPr>
+        <a:xfrm>
+          <a:off x="0" y="0"/>
+          <a:ext cx="0" cy="0"/>
+          <a:chOff x="0" y="0"/>
+          <a:chExt cx="0" cy="0"/>
+        </a:xfrm>
+      </p:grpSpPr>
       <p:sp>
         <p:nvSpPr>
           <p:cNvPr id="2" name="TextBox 1"/>
@@ -4370,7 +4400,7 @@
           <a:noFill/>
         </p:spPr>
         <p:txBody>
-          <a:bodyPr wrap="square" lIns="0" rIns="0" tIns="0" bIns="0">
+          <a:bodyPr wrap="square" lIns="0" tIns="0" rIns="0" bIns="0">
             <a:spAutoFit/>
           </a:bodyPr>
           <a:lstStyle/>
@@ -4404,7 +4434,7 @@
           <a:noFill/>
         </p:spPr>
         <p:txBody>
-          <a:bodyPr wrap="square" lIns="0" rIns="0" tIns="0" bIns="0">
+          <a:bodyPr wrap="square" lIns="0" tIns="0" rIns="0" bIns="0">
             <a:spAutoFit/>
           </a:bodyPr>
           <a:lstStyle/>
@@ -4438,7 +4468,7 @@
           <a:noFill/>
         </p:spPr>
         <p:txBody>
-          <a:bodyPr wrap="square" lIns="0" rIns="0" tIns="0" bIns="0">
+          <a:bodyPr wrap="square" lIns="0" tIns="0" rIns="0" bIns="0">
             <a:spAutoFit/>
           </a:bodyPr>
           <a:lstStyle/>
@@ -4598,7 +4628,7 @@
           </a:fontRef>
         </p:style>
         <p:txBody>
-          <a:bodyPr rtlCol="0" anchor="ctr" wrap="square" lIns="228600" rIns="228600" tIns="182880" bIns="182880"/>
+          <a:bodyPr wrap="square" lIns="228600" tIns="182880" rIns="228600" bIns="182880" rtlCol="0" anchor="ctr"/>
           <a:lstStyle/>
           <a:p>
             <a:pPr algn="ctr">
@@ -4670,7 +4700,7 @@
 </file>
 
 <file path=ppt/slides/slide14.xml><?xml version="1.0" encoding="utf-8"?>
-<p:sld xmlns:a="http://schemas.openxmlformats.org/drawingml/2006/main" xmlns:p="http://schemas.openxmlformats.org/presentationml/2006/main" xmlns:r="http://schemas.openxmlformats.org/officeDocument/2006/relationships">
+<p:sld xmlns:a="http://schemas.openxmlformats.org/drawingml/2006/main" xmlns:r="http://schemas.openxmlformats.org/officeDocument/2006/relationships" xmlns:p="http://schemas.openxmlformats.org/presentationml/2006/main">
   <p:cSld>
     <p:bg>
       <p:bgPr>
@@ -4686,7 +4716,14 @@
         <p:cNvGrpSpPr/>
         <p:nvPr/>
       </p:nvGrpSpPr>
-      <p:grpSpPr/>
+      <p:grpSpPr>
+        <a:xfrm>
+          <a:off x="0" y="0"/>
+          <a:ext cx="0" cy="0"/>
+          <a:chOff x="0" y="0"/>
+          <a:chExt cx="0" cy="0"/>
+        </a:xfrm>
+      </p:grpSpPr>
       <p:sp>
         <p:nvSpPr>
           <p:cNvPr id="2" name="TextBox 1"/>
@@ -4704,7 +4741,7 @@
           <a:noFill/>
         </p:spPr>
         <p:txBody>
-          <a:bodyPr wrap="square" lIns="0" rIns="0" tIns="0" bIns="0">
+          <a:bodyPr wrap="square" lIns="0" tIns="0" rIns="0" bIns="0">
             <a:spAutoFit/>
           </a:bodyPr>
           <a:lstStyle/>
@@ -4738,7 +4775,7 @@
           <a:noFill/>
         </p:spPr>
         <p:txBody>
-          <a:bodyPr wrap="square" lIns="0" rIns="0" tIns="0" bIns="0">
+          <a:bodyPr wrap="square" lIns="0" tIns="0" rIns="0" bIns="0">
             <a:spAutoFit/>
           </a:bodyPr>
           <a:lstStyle/>
@@ -4772,7 +4809,7 @@
           <a:noFill/>
         </p:spPr>
         <p:txBody>
-          <a:bodyPr wrap="square" lIns="0" rIns="0" tIns="0" bIns="0">
+          <a:bodyPr wrap="square" lIns="0" tIns="0" rIns="0" bIns="0">
             <a:spAutoFit/>
           </a:bodyPr>
           <a:lstStyle/>
@@ -4932,7 +4969,7 @@
           </a:fontRef>
         </p:style>
         <p:txBody>
-          <a:bodyPr rtlCol="0" anchor="ctr" wrap="square" lIns="228600" rIns="228600" tIns="182880" bIns="182880"/>
+          <a:bodyPr wrap="square" lIns="228600" tIns="182880" rIns="228600" bIns="182880" rtlCol="0" anchor="ctr"/>
           <a:lstStyle/>
           <a:p>
             <a:pPr algn="ctr">
@@ -5004,7 +5041,7 @@
 </file>
 
 <file path=ppt/slides/slide15.xml><?xml version="1.0" encoding="utf-8"?>
-<p:sld xmlns:a="http://schemas.openxmlformats.org/drawingml/2006/main" xmlns:p="http://schemas.openxmlformats.org/presentationml/2006/main" xmlns:r="http://schemas.openxmlformats.org/officeDocument/2006/relationships">
+<p:sld xmlns:a="http://schemas.openxmlformats.org/drawingml/2006/main" xmlns:r="http://schemas.openxmlformats.org/officeDocument/2006/relationships" xmlns:p="http://schemas.openxmlformats.org/presentationml/2006/main">
   <p:cSld>
     <p:bg>
       <p:bgPr>
@@ -5020,7 +5057,14 @@
         <p:cNvGrpSpPr/>
         <p:nvPr/>
       </p:nvGrpSpPr>
-      <p:grpSpPr/>
+      <p:grpSpPr>
+        <a:xfrm>
+          <a:off x="0" y="0"/>
+          <a:ext cx="0" cy="0"/>
+          <a:chOff x="0" y="0"/>
+          <a:chExt cx="0" cy="0"/>
+        </a:xfrm>
+      </p:grpSpPr>
       <p:sp>
         <p:nvSpPr>
           <p:cNvPr id="2" name="TextBox 1"/>
@@ -5038,7 +5082,7 @@
           <a:noFill/>
         </p:spPr>
         <p:txBody>
-          <a:bodyPr wrap="square" lIns="0" rIns="0" tIns="0" bIns="0">
+          <a:bodyPr wrap="square" lIns="0" tIns="0" rIns="0" bIns="0">
             <a:spAutoFit/>
           </a:bodyPr>
           <a:lstStyle/>
@@ -5072,7 +5116,7 @@
           <a:noFill/>
         </p:spPr>
         <p:txBody>
-          <a:bodyPr wrap="square" lIns="0" rIns="0" tIns="0" bIns="0">
+          <a:bodyPr wrap="square" lIns="0" tIns="0" rIns="0" bIns="0">
             <a:spAutoFit/>
           </a:bodyPr>
           <a:lstStyle/>
@@ -5106,7 +5150,7 @@
           <a:noFill/>
         </p:spPr>
         <p:txBody>
-          <a:bodyPr wrap="square" lIns="0" rIns="0" tIns="0" bIns="0">
+          <a:bodyPr wrap="square" lIns="0" tIns="0" rIns="0" bIns="0">
             <a:spAutoFit/>
           </a:bodyPr>
           <a:lstStyle/>
@@ -5266,7 +5310,7 @@
           </a:fontRef>
         </p:style>
         <p:txBody>
-          <a:bodyPr rtlCol="0" anchor="ctr" wrap="square" lIns="228600" rIns="228600" tIns="182880" bIns="182880"/>
+          <a:bodyPr wrap="square" lIns="228600" tIns="182880" rIns="228600" bIns="182880" rtlCol="0" anchor="ctr"/>
           <a:lstStyle/>
           <a:p>
             <a:pPr algn="ctr">
@@ -5338,7 +5382,7 @@
 </file>
 
 <file path=ppt/slides/slide16.xml><?xml version="1.0" encoding="utf-8"?>
-<p:sld xmlns:a="http://schemas.openxmlformats.org/drawingml/2006/main" xmlns:p="http://schemas.openxmlformats.org/presentationml/2006/main" xmlns:r="http://schemas.openxmlformats.org/officeDocument/2006/relationships">
+<p:sld xmlns:a="http://schemas.openxmlformats.org/drawingml/2006/main" xmlns:r="http://schemas.openxmlformats.org/officeDocument/2006/relationships" xmlns:p="http://schemas.openxmlformats.org/presentationml/2006/main">
   <p:cSld>
     <p:bg>
       <p:bgPr>
@@ -5354,7 +5398,14 @@
         <p:cNvGrpSpPr/>
         <p:nvPr/>
       </p:nvGrpSpPr>
-      <p:grpSpPr/>
+      <p:grpSpPr>
+        <a:xfrm>
+          <a:off x="0" y="0"/>
+          <a:ext cx="0" cy="0"/>
+          <a:chOff x="0" y="0"/>
+          <a:chExt cx="0" cy="0"/>
+        </a:xfrm>
+      </p:grpSpPr>
       <p:sp>
         <p:nvSpPr>
           <p:cNvPr id="2" name="TextBox 1"/>
@@ -5372,7 +5423,7 @@
           <a:noFill/>
         </p:spPr>
         <p:txBody>
-          <a:bodyPr wrap="square" lIns="0" rIns="0" tIns="0" bIns="0">
+          <a:bodyPr wrap="square" lIns="0" tIns="0" rIns="0" bIns="0">
             <a:spAutoFit/>
           </a:bodyPr>
           <a:lstStyle/>
@@ -5406,7 +5457,7 @@
           <a:noFill/>
         </p:spPr>
         <p:txBody>
-          <a:bodyPr wrap="square" lIns="0" rIns="0" tIns="0" bIns="0">
+          <a:bodyPr wrap="square" lIns="0" tIns="0" rIns="0" bIns="0">
             <a:spAutoFit/>
           </a:bodyPr>
           <a:lstStyle/>
@@ -5440,7 +5491,7 @@
           <a:noFill/>
         </p:spPr>
         <p:txBody>
-          <a:bodyPr wrap="square" lIns="0" rIns="0" tIns="0" bIns="0">
+          <a:bodyPr wrap="square" lIns="0" tIns="0" rIns="0" bIns="0">
             <a:spAutoFit/>
           </a:bodyPr>
           <a:lstStyle/>
@@ -5600,7 +5651,7 @@
           </a:fontRef>
         </p:style>
         <p:txBody>
-          <a:bodyPr rtlCol="0" anchor="ctr" wrap="square" lIns="228600" rIns="228600" tIns="182880" bIns="182880"/>
+          <a:bodyPr wrap="square" lIns="228600" tIns="182880" rIns="228600" bIns="182880" rtlCol="0" anchor="ctr"/>
           <a:lstStyle/>
           <a:p>
             <a:pPr algn="ctr">
@@ -5672,7 +5723,7 @@
 </file>
 
 <file path=ppt/slides/slide17.xml><?xml version="1.0" encoding="utf-8"?>
-<p:sld xmlns:a="http://schemas.openxmlformats.org/drawingml/2006/main" xmlns:p="http://schemas.openxmlformats.org/presentationml/2006/main" xmlns:r="http://schemas.openxmlformats.org/officeDocument/2006/relationships">
+<p:sld xmlns:a="http://schemas.openxmlformats.org/drawingml/2006/main" xmlns:r="http://schemas.openxmlformats.org/officeDocument/2006/relationships" xmlns:p="http://schemas.openxmlformats.org/presentationml/2006/main">
   <p:cSld>
     <p:bg>
       <p:bgPr>
@@ -5688,7 +5739,14 @@
         <p:cNvGrpSpPr/>
         <p:nvPr/>
       </p:nvGrpSpPr>
-      <p:grpSpPr/>
+      <p:grpSpPr>
+        <a:xfrm>
+          <a:off x="0" y="0"/>
+          <a:ext cx="0" cy="0"/>
+          <a:chOff x="0" y="0"/>
+          <a:chExt cx="0" cy="0"/>
+        </a:xfrm>
+      </p:grpSpPr>
       <p:sp>
         <p:nvSpPr>
           <p:cNvPr id="2" name="TextBox 1"/>
@@ -5706,7 +5764,7 @@
           <a:noFill/>
         </p:spPr>
         <p:txBody>
-          <a:bodyPr wrap="square" lIns="0" rIns="0" tIns="0" bIns="0">
+          <a:bodyPr wrap="square" lIns="0" tIns="0" rIns="0" bIns="0">
             <a:spAutoFit/>
           </a:bodyPr>
           <a:lstStyle/>
@@ -5740,7 +5798,7 @@
           <a:noFill/>
         </p:spPr>
         <p:txBody>
-          <a:bodyPr wrap="square" lIns="0" rIns="0" tIns="0" bIns="0">
+          <a:bodyPr wrap="square" lIns="0" tIns="0" rIns="0" bIns="0">
             <a:spAutoFit/>
           </a:bodyPr>
           <a:lstStyle/>
@@ -5774,7 +5832,7 @@
           <a:noFill/>
         </p:spPr>
         <p:txBody>
-          <a:bodyPr wrap="square" lIns="0" rIns="0" tIns="0" bIns="0">
+          <a:bodyPr wrap="square" lIns="0" tIns="0" rIns="0" bIns="0">
             <a:spAutoFit/>
           </a:bodyPr>
           <a:lstStyle/>
@@ -5934,7 +5992,7 @@
           </a:fontRef>
         </p:style>
         <p:txBody>
-          <a:bodyPr rtlCol="0" anchor="ctr" wrap="square" lIns="228600" rIns="228600" tIns="182880" bIns="182880"/>
+          <a:bodyPr wrap="square" lIns="228600" tIns="182880" rIns="228600" bIns="182880" rtlCol="0" anchor="ctr"/>
           <a:lstStyle/>
           <a:p>
             <a:pPr algn="ctr">
@@ -6006,7 +6064,7 @@
 </file>
 
 <file path=ppt/slides/slide18.xml><?xml version="1.0" encoding="utf-8"?>
-<p:sld xmlns:a="http://schemas.openxmlformats.org/drawingml/2006/main" xmlns:p="http://schemas.openxmlformats.org/presentationml/2006/main" xmlns:r="http://schemas.openxmlformats.org/officeDocument/2006/relationships">
+<p:sld xmlns:a="http://schemas.openxmlformats.org/drawingml/2006/main" xmlns:r="http://schemas.openxmlformats.org/officeDocument/2006/relationships" xmlns:p="http://schemas.openxmlformats.org/presentationml/2006/main">
   <p:cSld>
     <p:bg>
       <p:bgPr>
@@ -6022,7 +6080,14 @@
         <p:cNvGrpSpPr/>
         <p:nvPr/>
       </p:nvGrpSpPr>
-      <p:grpSpPr/>
+      <p:grpSpPr>
+        <a:xfrm>
+          <a:off x="0" y="0"/>
+          <a:ext cx="0" cy="0"/>
+          <a:chOff x="0" y="0"/>
+          <a:chExt cx="0" cy="0"/>
+        </a:xfrm>
+      </p:grpSpPr>
       <p:sp>
         <p:nvSpPr>
           <p:cNvPr id="2" name="TextBox 1"/>
@@ -6040,7 +6105,7 @@
           <a:noFill/>
         </p:spPr>
         <p:txBody>
-          <a:bodyPr wrap="square" lIns="0" rIns="0" tIns="0" bIns="0">
+          <a:bodyPr wrap="square" lIns="0" tIns="0" rIns="0" bIns="0">
             <a:spAutoFit/>
           </a:bodyPr>
           <a:lstStyle/>
@@ -6074,7 +6139,7 @@
           <a:noFill/>
         </p:spPr>
         <p:txBody>
-          <a:bodyPr wrap="square" lIns="0" rIns="0" tIns="0" bIns="0">
+          <a:bodyPr wrap="square" lIns="0" tIns="0" rIns="0" bIns="0">
             <a:spAutoFit/>
           </a:bodyPr>
           <a:lstStyle/>
@@ -6108,7 +6173,7 @@
           <a:noFill/>
         </p:spPr>
         <p:txBody>
-          <a:bodyPr wrap="square" lIns="0" rIns="0" tIns="0" bIns="0">
+          <a:bodyPr wrap="square" lIns="0" tIns="0" rIns="0" bIns="0">
             <a:spAutoFit/>
           </a:bodyPr>
           <a:lstStyle/>
@@ -6268,7 +6333,7 @@
           </a:fontRef>
         </p:style>
         <p:txBody>
-          <a:bodyPr rtlCol="0" anchor="ctr" wrap="square" lIns="228600" rIns="228600" tIns="182880" bIns="182880"/>
+          <a:bodyPr wrap="square" lIns="228600" tIns="182880" rIns="228600" bIns="182880" rtlCol="0" anchor="ctr"/>
           <a:lstStyle/>
           <a:p>
             <a:pPr algn="ctr">
@@ -6340,7 +6405,7 @@
 </file>
 
 <file path=ppt/slides/slide19.xml><?xml version="1.0" encoding="utf-8"?>
-<p:sld xmlns:a="http://schemas.openxmlformats.org/drawingml/2006/main" xmlns:p="http://schemas.openxmlformats.org/presentationml/2006/main" xmlns:r="http://schemas.openxmlformats.org/officeDocument/2006/relationships">
+<p:sld xmlns:a="http://schemas.openxmlformats.org/drawingml/2006/main" xmlns:r="http://schemas.openxmlformats.org/officeDocument/2006/relationships" xmlns:p="http://schemas.openxmlformats.org/presentationml/2006/main">
   <p:cSld>
     <p:bg>
       <p:bgPr>
@@ -6356,7 +6421,14 @@
         <p:cNvGrpSpPr/>
         <p:nvPr/>
       </p:nvGrpSpPr>
-      <p:grpSpPr/>
+      <p:grpSpPr>
+        <a:xfrm>
+          <a:off x="0" y="0"/>
+          <a:ext cx="0" cy="0"/>
+          <a:chOff x="0" y="0"/>
+          <a:chExt cx="0" cy="0"/>
+        </a:xfrm>
+      </p:grpSpPr>
       <p:sp>
         <p:nvSpPr>
           <p:cNvPr id="2" name="TextBox 1"/>
@@ -6374,7 +6446,7 @@
           <a:noFill/>
         </p:spPr>
         <p:txBody>
-          <a:bodyPr wrap="square" lIns="0" rIns="0" tIns="0" bIns="0">
+          <a:bodyPr wrap="square" lIns="0" tIns="0" rIns="0" bIns="0">
             <a:spAutoFit/>
           </a:bodyPr>
           <a:lstStyle/>
@@ -6408,7 +6480,7 @@
           <a:noFill/>
         </p:spPr>
         <p:txBody>
-          <a:bodyPr wrap="square" lIns="0" rIns="0" tIns="0" bIns="0">
+          <a:bodyPr wrap="square" lIns="0" tIns="0" rIns="0" bIns="0">
             <a:spAutoFit/>
           </a:bodyPr>
           <a:lstStyle/>
@@ -6442,7 +6514,7 @@
           <a:noFill/>
         </p:spPr>
         <p:txBody>
-          <a:bodyPr wrap="square" lIns="0" rIns="0" tIns="0" bIns="0">
+          <a:bodyPr wrap="square" lIns="0" tIns="0" rIns="0" bIns="0">
             <a:spAutoFit/>
           </a:bodyPr>
           <a:lstStyle/>
@@ -6602,7 +6674,7 @@
           </a:fontRef>
         </p:style>
         <p:txBody>
-          <a:bodyPr rtlCol="0" anchor="ctr" wrap="square" lIns="228600" rIns="228600" tIns="182880" bIns="182880"/>
+          <a:bodyPr wrap="square" lIns="228600" tIns="182880" rIns="228600" bIns="182880" rtlCol="0" anchor="ctr"/>
           <a:lstStyle/>
           <a:p>
             <a:pPr algn="ctr">
@@ -6674,7 +6746,7 @@
 </file>
 
 <file path=ppt/slides/slide2.xml><?xml version="1.0" encoding="utf-8"?>
-<p:sld xmlns:a="http://schemas.openxmlformats.org/drawingml/2006/main" xmlns:p="http://schemas.openxmlformats.org/presentationml/2006/main" xmlns:r="http://schemas.openxmlformats.org/officeDocument/2006/relationships">
+<p:sld xmlns:a="http://schemas.openxmlformats.org/drawingml/2006/main" xmlns:r="http://schemas.openxmlformats.org/officeDocument/2006/relationships" xmlns:p="http://schemas.openxmlformats.org/presentationml/2006/main">
   <p:cSld>
     <p:bg>
       <p:bgPr>
@@ -6690,7 +6762,14 @@
         <p:cNvGrpSpPr/>
         <p:nvPr/>
       </p:nvGrpSpPr>
-      <p:grpSpPr/>
+      <p:grpSpPr>
+        <a:xfrm>
+          <a:off x="0" y="0"/>
+          <a:ext cx="0" cy="0"/>
+          <a:chOff x="0" y="0"/>
+          <a:chExt cx="0" cy="0"/>
+        </a:xfrm>
+      </p:grpSpPr>
       <p:sp>
         <p:nvSpPr>
           <p:cNvPr id="2" name="TextBox 1"/>
@@ -6708,7 +6787,7 @@
           <a:noFill/>
         </p:spPr>
         <p:txBody>
-          <a:bodyPr wrap="square" lIns="0" rIns="0" tIns="0" bIns="0">
+          <a:bodyPr wrap="square" lIns="0" tIns="0" rIns="0" bIns="0">
             <a:spAutoFit/>
           </a:bodyPr>
           <a:lstStyle/>
@@ -6742,7 +6821,7 @@
           <a:noFill/>
         </p:spPr>
         <p:txBody>
-          <a:bodyPr wrap="square" lIns="0" rIns="0" tIns="0" bIns="0">
+          <a:bodyPr wrap="square" lIns="0" tIns="0" rIns="0" bIns="0">
             <a:spAutoFit/>
           </a:bodyPr>
           <a:lstStyle/>
@@ -6776,7 +6855,7 @@
           <a:noFill/>
         </p:spPr>
         <p:txBody>
-          <a:bodyPr wrap="square" lIns="0" rIns="0" tIns="0" bIns="0">
+          <a:bodyPr wrap="square" lIns="0" tIns="0" rIns="0" bIns="0">
             <a:spAutoFit/>
           </a:bodyPr>
           <a:lstStyle/>
@@ -6922,7 +7001,7 @@
           </a:fontRef>
         </p:style>
         <p:txBody>
-          <a:bodyPr rtlCol="0" anchor="ctr" wrap="square" lIns="182880" rIns="182880" tIns="109728" bIns="109728"/>
+          <a:bodyPr wrap="square" lIns="182880" tIns="109728" rIns="182880" bIns="109728" rtlCol="0" anchor="ctr"/>
           <a:lstStyle/>
           <a:p>
             <a:pPr algn="ctr">
@@ -6991,7 +7070,7 @@
           </a:fontRef>
         </p:style>
         <p:txBody>
-          <a:bodyPr rtlCol="0" anchor="ctr" wrap="square" lIns="228600" rIns="228600" tIns="182880" bIns="182880"/>
+          <a:bodyPr wrap="square" lIns="228600" tIns="182880" rIns="228600" bIns="182880" rtlCol="0" anchor="ctr"/>
           <a:lstStyle/>
           <a:p>
             <a:pPr algn="ctr">
@@ -7047,7 +7126,7 @@
 </file>
 
 <file path=ppt/slides/slide20.xml><?xml version="1.0" encoding="utf-8"?>
-<p:sld xmlns:a="http://schemas.openxmlformats.org/drawingml/2006/main" xmlns:p="http://schemas.openxmlformats.org/presentationml/2006/main" xmlns:r="http://schemas.openxmlformats.org/officeDocument/2006/relationships">
+<p:sld xmlns:a="http://schemas.openxmlformats.org/drawingml/2006/main" xmlns:r="http://schemas.openxmlformats.org/officeDocument/2006/relationships" xmlns:p="http://schemas.openxmlformats.org/presentationml/2006/main">
   <p:cSld>
     <p:bg>
       <p:bgPr>
@@ -7063,7 +7142,14 @@
         <p:cNvGrpSpPr/>
         <p:nvPr/>
       </p:nvGrpSpPr>
-      <p:grpSpPr/>
+      <p:grpSpPr>
+        <a:xfrm>
+          <a:off x="0" y="0"/>
+          <a:ext cx="0" cy="0"/>
+          <a:chOff x="0" y="0"/>
+          <a:chExt cx="0" cy="0"/>
+        </a:xfrm>
+      </p:grpSpPr>
       <p:sp>
         <p:nvSpPr>
           <p:cNvPr id="2" name="TextBox 1"/>
@@ -7081,7 +7167,7 @@
           <a:noFill/>
         </p:spPr>
         <p:txBody>
-          <a:bodyPr wrap="square" lIns="0" rIns="0" tIns="0" bIns="0">
+          <a:bodyPr wrap="square" lIns="0" tIns="0" rIns="0" bIns="0">
             <a:spAutoFit/>
           </a:bodyPr>
           <a:lstStyle/>
@@ -7115,7 +7201,7 @@
           <a:noFill/>
         </p:spPr>
         <p:txBody>
-          <a:bodyPr wrap="square" lIns="0" rIns="0" tIns="0" bIns="0">
+          <a:bodyPr wrap="square" lIns="0" tIns="0" rIns="0" bIns="0">
             <a:spAutoFit/>
           </a:bodyPr>
           <a:lstStyle/>
@@ -7149,7 +7235,7 @@
           <a:noFill/>
         </p:spPr>
         <p:txBody>
-          <a:bodyPr wrap="square" lIns="0" rIns="0" tIns="0" bIns="0">
+          <a:bodyPr wrap="square" lIns="0" tIns="0" rIns="0" bIns="0">
             <a:spAutoFit/>
           </a:bodyPr>
           <a:lstStyle/>
@@ -7309,7 +7395,7 @@
           </a:fontRef>
         </p:style>
         <p:txBody>
-          <a:bodyPr rtlCol="0" anchor="ctr" wrap="square" lIns="228600" rIns="228600" tIns="182880" bIns="182880"/>
+          <a:bodyPr wrap="square" lIns="228600" tIns="182880" rIns="228600" bIns="182880" rtlCol="0" anchor="ctr"/>
           <a:lstStyle/>
           <a:p>
             <a:pPr algn="ctr">
@@ -7381,7 +7467,7 @@
 </file>
 
 <file path=ppt/slides/slide21.xml><?xml version="1.0" encoding="utf-8"?>
-<p:sld xmlns:a="http://schemas.openxmlformats.org/drawingml/2006/main" xmlns:p="http://schemas.openxmlformats.org/presentationml/2006/main" xmlns:r="http://schemas.openxmlformats.org/officeDocument/2006/relationships">
+<p:sld xmlns:a="http://schemas.openxmlformats.org/drawingml/2006/main" xmlns:r="http://schemas.openxmlformats.org/officeDocument/2006/relationships" xmlns:p="http://schemas.openxmlformats.org/presentationml/2006/main">
   <p:cSld>
     <p:bg>
       <p:bgPr>
@@ -7397,7 +7483,14 @@
         <p:cNvGrpSpPr/>
         <p:nvPr/>
       </p:nvGrpSpPr>
-      <p:grpSpPr/>
+      <p:grpSpPr>
+        <a:xfrm>
+          <a:off x="0" y="0"/>
+          <a:ext cx="0" cy="0"/>
+          <a:chOff x="0" y="0"/>
+          <a:chExt cx="0" cy="0"/>
+        </a:xfrm>
+      </p:grpSpPr>
       <p:sp>
         <p:nvSpPr>
           <p:cNvPr id="2" name="TextBox 1"/>
@@ -7415,7 +7508,7 @@
           <a:noFill/>
         </p:spPr>
         <p:txBody>
-          <a:bodyPr wrap="square" lIns="0" rIns="0" tIns="0" bIns="0">
+          <a:bodyPr wrap="square" lIns="0" tIns="0" rIns="0" bIns="0">
             <a:spAutoFit/>
           </a:bodyPr>
           <a:lstStyle/>
@@ -7449,7 +7542,7 @@
           <a:noFill/>
         </p:spPr>
         <p:txBody>
-          <a:bodyPr wrap="square" lIns="0" rIns="0" tIns="0" bIns="0">
+          <a:bodyPr wrap="square" lIns="0" tIns="0" rIns="0" bIns="0">
             <a:spAutoFit/>
           </a:bodyPr>
           <a:lstStyle/>
@@ -7483,7 +7576,7 @@
           <a:noFill/>
         </p:spPr>
         <p:txBody>
-          <a:bodyPr wrap="square" lIns="0" rIns="0" tIns="0" bIns="0">
+          <a:bodyPr wrap="square" lIns="0" tIns="0" rIns="0" bIns="0">
             <a:spAutoFit/>
           </a:bodyPr>
           <a:lstStyle/>
@@ -7643,7 +7736,7 @@
           </a:fontRef>
         </p:style>
         <p:txBody>
-          <a:bodyPr rtlCol="0" anchor="ctr" wrap="square" lIns="228600" rIns="228600" tIns="182880" bIns="182880"/>
+          <a:bodyPr wrap="square" lIns="228600" tIns="182880" rIns="228600" bIns="182880" rtlCol="0" anchor="ctr"/>
           <a:lstStyle/>
           <a:p>
             <a:pPr algn="ctr">
@@ -7715,7 +7808,7 @@
 </file>
 
 <file path=ppt/slides/slide22.xml><?xml version="1.0" encoding="utf-8"?>
-<p:sld xmlns:a="http://schemas.openxmlformats.org/drawingml/2006/main" xmlns:p="http://schemas.openxmlformats.org/presentationml/2006/main" xmlns:r="http://schemas.openxmlformats.org/officeDocument/2006/relationships">
+<p:sld xmlns:a="http://schemas.openxmlformats.org/drawingml/2006/main" xmlns:r="http://schemas.openxmlformats.org/officeDocument/2006/relationships" xmlns:p="http://schemas.openxmlformats.org/presentationml/2006/main">
   <p:cSld>
     <p:bg>
       <p:bgPr>
@@ -7731,7 +7824,14 @@
         <p:cNvGrpSpPr/>
         <p:nvPr/>
       </p:nvGrpSpPr>
-      <p:grpSpPr/>
+      <p:grpSpPr>
+        <a:xfrm>
+          <a:off x="0" y="0"/>
+          <a:ext cx="0" cy="0"/>
+          <a:chOff x="0" y="0"/>
+          <a:chExt cx="0" cy="0"/>
+        </a:xfrm>
+      </p:grpSpPr>
       <p:sp>
         <p:nvSpPr>
           <p:cNvPr id="2" name="TextBox 1"/>
@@ -7749,7 +7849,7 @@
           <a:noFill/>
         </p:spPr>
         <p:txBody>
-          <a:bodyPr wrap="square" lIns="0" rIns="0" tIns="0" bIns="0">
+          <a:bodyPr wrap="square" lIns="0" tIns="0" rIns="0" bIns="0">
             <a:spAutoFit/>
           </a:bodyPr>
           <a:lstStyle/>
@@ -7783,7 +7883,7 @@
           <a:noFill/>
         </p:spPr>
         <p:txBody>
-          <a:bodyPr wrap="square" lIns="0" rIns="0" tIns="0" bIns="0">
+          <a:bodyPr wrap="square" lIns="0" tIns="0" rIns="0" bIns="0">
             <a:spAutoFit/>
           </a:bodyPr>
           <a:lstStyle/>
@@ -7817,7 +7917,7 @@
           <a:noFill/>
         </p:spPr>
         <p:txBody>
-          <a:bodyPr wrap="square" lIns="0" rIns="0" tIns="0" bIns="0">
+          <a:bodyPr wrap="square" lIns="0" tIns="0" rIns="0" bIns="0">
             <a:spAutoFit/>
           </a:bodyPr>
           <a:lstStyle/>
@@ -7977,7 +8077,7 @@
           </a:fontRef>
         </p:style>
         <p:txBody>
-          <a:bodyPr rtlCol="0" anchor="ctr" wrap="square" lIns="228600" rIns="228600" tIns="182880" bIns="182880"/>
+          <a:bodyPr wrap="square" lIns="228600" tIns="182880" rIns="228600" bIns="182880" rtlCol="0" anchor="ctr"/>
           <a:lstStyle/>
           <a:p>
             <a:pPr algn="ctr">
@@ -8049,7 +8149,7 @@
 </file>
 
 <file path=ppt/slides/slide3.xml><?xml version="1.0" encoding="utf-8"?>
-<p:sld xmlns:a="http://schemas.openxmlformats.org/drawingml/2006/main" xmlns:p="http://schemas.openxmlformats.org/presentationml/2006/main" xmlns:r="http://schemas.openxmlformats.org/officeDocument/2006/relationships">
+<p:sld xmlns:a="http://schemas.openxmlformats.org/drawingml/2006/main" xmlns:r="http://schemas.openxmlformats.org/officeDocument/2006/relationships" xmlns:p="http://schemas.openxmlformats.org/presentationml/2006/main">
   <p:cSld>
     <p:bg>
       <p:bgPr>
@@ -8065,7 +8165,14 @@
         <p:cNvGrpSpPr/>
         <p:nvPr/>
       </p:nvGrpSpPr>
-      <p:grpSpPr/>
+      <p:grpSpPr>
+        <a:xfrm>
+          <a:off x="0" y="0"/>
+          <a:ext cx="0" cy="0"/>
+          <a:chOff x="0" y="0"/>
+          <a:chExt cx="0" cy="0"/>
+        </a:xfrm>
+      </p:grpSpPr>
       <p:sp>
         <p:nvSpPr>
           <p:cNvPr id="2" name="TextBox 1"/>
@@ -8083,7 +8190,7 @@
           <a:noFill/>
         </p:spPr>
         <p:txBody>
-          <a:bodyPr wrap="square" lIns="0" rIns="0" tIns="0" bIns="0">
+          <a:bodyPr wrap="square" lIns="0" tIns="0" rIns="0" bIns="0">
             <a:spAutoFit/>
           </a:bodyPr>
           <a:lstStyle/>
@@ -8117,7 +8224,7 @@
           <a:noFill/>
         </p:spPr>
         <p:txBody>
-          <a:bodyPr wrap="square" lIns="0" rIns="0" tIns="0" bIns="0">
+          <a:bodyPr wrap="square" lIns="0" tIns="0" rIns="0" bIns="0">
             <a:spAutoFit/>
           </a:bodyPr>
           <a:lstStyle/>
@@ -8185,7 +8292,7 @@
           <a:noFill/>
         </p:spPr>
         <p:txBody>
-          <a:bodyPr wrap="square" lIns="0" rIns="0" tIns="0" bIns="0">
+          <a:bodyPr wrap="square" lIns="0" tIns="0" rIns="0" bIns="0">
             <a:spAutoFit/>
           </a:bodyPr>
           <a:lstStyle/>
@@ -8331,7 +8438,7 @@
           </a:fontRef>
         </p:style>
         <p:txBody>
-          <a:bodyPr rtlCol="0" anchor="ctr" wrap="square" lIns="182880" rIns="182880" tIns="109728" bIns="109728"/>
+          <a:bodyPr wrap="square" lIns="182880" tIns="109728" rIns="182880" bIns="109728" rtlCol="0" anchor="ctr"/>
           <a:lstStyle/>
           <a:p>
             <a:pPr algn="ctr">
@@ -8400,7 +8507,7 @@
           </a:fontRef>
         </p:style>
         <p:txBody>
-          <a:bodyPr rtlCol="0" anchor="ctr" wrap="square" lIns="228600" rIns="228600" tIns="182880" bIns="182880"/>
+          <a:bodyPr wrap="square" lIns="228600" tIns="182880" rIns="228600" bIns="182880" rtlCol="0" anchor="ctr"/>
           <a:lstStyle/>
           <a:p>
             <a:pPr algn="ctr">
@@ -8510,7 +8617,7 @@
 </file>
 
 <file path=ppt/slides/slide4.xml><?xml version="1.0" encoding="utf-8"?>
-<p:sld xmlns:a="http://schemas.openxmlformats.org/drawingml/2006/main" xmlns:p="http://schemas.openxmlformats.org/presentationml/2006/main" xmlns:r="http://schemas.openxmlformats.org/officeDocument/2006/relationships">
+<p:sld xmlns:a="http://schemas.openxmlformats.org/drawingml/2006/main" xmlns:r="http://schemas.openxmlformats.org/officeDocument/2006/relationships" xmlns:p="http://schemas.openxmlformats.org/presentationml/2006/main">
   <p:cSld>
     <p:bg>
       <p:bgPr>
@@ -8526,7 +8633,14 @@
         <p:cNvGrpSpPr/>
         <p:nvPr/>
       </p:nvGrpSpPr>
-      <p:grpSpPr/>
+      <p:grpSpPr>
+        <a:xfrm>
+          <a:off x="0" y="0"/>
+          <a:ext cx="0" cy="0"/>
+          <a:chOff x="0" y="0"/>
+          <a:chExt cx="0" cy="0"/>
+        </a:xfrm>
+      </p:grpSpPr>
       <p:sp>
         <p:nvSpPr>
           <p:cNvPr id="2" name="TextBox 1"/>
@@ -8544,7 +8658,7 @@
           <a:noFill/>
         </p:spPr>
         <p:txBody>
-          <a:bodyPr wrap="square" lIns="0" rIns="0" tIns="0" bIns="0">
+          <a:bodyPr wrap="square" lIns="0" tIns="0" rIns="0" bIns="0">
             <a:spAutoFit/>
           </a:bodyPr>
           <a:lstStyle/>
@@ -8578,7 +8692,7 @@
           <a:noFill/>
         </p:spPr>
         <p:txBody>
-          <a:bodyPr wrap="square" lIns="0" rIns="0" tIns="0" bIns="0">
+          <a:bodyPr wrap="square" lIns="0" tIns="0" rIns="0" bIns="0">
             <a:spAutoFit/>
           </a:bodyPr>
           <a:lstStyle/>
@@ -8612,7 +8726,7 @@
           <a:noFill/>
         </p:spPr>
         <p:txBody>
-          <a:bodyPr wrap="square" lIns="0" rIns="0" tIns="0" bIns="0">
+          <a:bodyPr wrap="square" lIns="0" tIns="0" rIns="0" bIns="0">
             <a:spAutoFit/>
           </a:bodyPr>
           <a:lstStyle/>
@@ -8758,7 +8872,7 @@
           </a:fontRef>
         </p:style>
         <p:txBody>
-          <a:bodyPr rtlCol="0" anchor="ctr" wrap="square" lIns="182880" rIns="182880" tIns="109728" bIns="109728"/>
+          <a:bodyPr wrap="square" lIns="182880" tIns="109728" rIns="182880" bIns="109728" rtlCol="0" anchor="ctr"/>
           <a:lstStyle/>
           <a:p>
             <a:pPr algn="ctr">
@@ -8827,7 +8941,7 @@
           </a:fontRef>
         </p:style>
         <p:txBody>
-          <a:bodyPr rtlCol="0" anchor="ctr" wrap="square" lIns="228600" rIns="228600" tIns="182880" bIns="182880"/>
+          <a:bodyPr wrap="square" lIns="228600" tIns="182880" rIns="228600" bIns="182880" rtlCol="0" anchor="ctr"/>
           <a:lstStyle/>
           <a:p>
             <a:pPr algn="ctr">
@@ -8867,7 +8981,7 @@
 </file>
 
 <file path=ppt/slides/slide5.xml><?xml version="1.0" encoding="utf-8"?>
-<p:sld xmlns:a="http://schemas.openxmlformats.org/drawingml/2006/main" xmlns:p="http://schemas.openxmlformats.org/presentationml/2006/main" xmlns:r="http://schemas.openxmlformats.org/officeDocument/2006/relationships">
+<p:sld xmlns:a="http://schemas.openxmlformats.org/drawingml/2006/main" xmlns:r="http://schemas.openxmlformats.org/officeDocument/2006/relationships" xmlns:p="http://schemas.openxmlformats.org/presentationml/2006/main">
   <p:cSld>
     <p:bg>
       <p:bgPr>
@@ -8883,7 +8997,14 @@
         <p:cNvGrpSpPr/>
         <p:nvPr/>
       </p:nvGrpSpPr>
-      <p:grpSpPr/>
+      <p:grpSpPr>
+        <a:xfrm>
+          <a:off x="0" y="0"/>
+          <a:ext cx="0" cy="0"/>
+          <a:chOff x="0" y="0"/>
+          <a:chExt cx="0" cy="0"/>
+        </a:xfrm>
+      </p:grpSpPr>
       <p:sp>
         <p:nvSpPr>
           <p:cNvPr id="2" name="TextBox 1"/>
@@ -8901,7 +9022,7 @@
           <a:noFill/>
         </p:spPr>
         <p:txBody>
-          <a:bodyPr wrap="square" lIns="0" rIns="0" tIns="0" bIns="0">
+          <a:bodyPr wrap="square" lIns="0" tIns="0" rIns="0" bIns="0">
             <a:spAutoFit/>
           </a:bodyPr>
           <a:lstStyle/>
@@ -8935,7 +9056,7 @@
           <a:noFill/>
         </p:spPr>
         <p:txBody>
-          <a:bodyPr wrap="square" lIns="0" rIns="0" tIns="0" bIns="0">
+          <a:bodyPr wrap="square" lIns="0" tIns="0" rIns="0" bIns="0">
             <a:spAutoFit/>
           </a:bodyPr>
           <a:lstStyle/>
@@ -8969,7 +9090,7 @@
           <a:noFill/>
         </p:spPr>
         <p:txBody>
-          <a:bodyPr wrap="square" lIns="0" rIns="0" tIns="0" bIns="0">
+          <a:bodyPr wrap="square" lIns="0" tIns="0" rIns="0" bIns="0">
             <a:spAutoFit/>
           </a:bodyPr>
           <a:lstStyle/>
@@ -9081,7 +9202,7 @@
           </a:fontRef>
         </p:style>
         <p:txBody>
-          <a:bodyPr rtlCol="0" anchor="ctr" wrap="square" lIns="182880" rIns="182880" tIns="109728" bIns="109728"/>
+          <a:bodyPr wrap="square" lIns="182880" tIns="109728" rIns="182880" bIns="109728" rtlCol="0" anchor="ctr"/>
           <a:lstStyle/>
           <a:p>
             <a:pPr algn="ctr">
@@ -9150,7 +9271,7 @@
           </a:fontRef>
         </p:style>
         <p:txBody>
-          <a:bodyPr rtlCol="0" anchor="ctr" wrap="square" lIns="228600" rIns="228600" tIns="182880" bIns="182880"/>
+          <a:bodyPr wrap="square" lIns="228600" tIns="182880" rIns="228600" bIns="182880" rtlCol="0" anchor="ctr"/>
           <a:lstStyle/>
           <a:p>
             <a:pPr algn="ctr">
@@ -9208,7 +9329,7 @@
           </a:fontRef>
         </p:style>
         <p:txBody>
-          <a:bodyPr rtlCol="0" anchor="ctr" wrap="square"/>
+          <a:bodyPr wrap="square" rtlCol="0" anchor="ctr"/>
           <a:lstStyle/>
           <a:p>
             <a:pPr algn="ctr"/>
@@ -9266,7 +9387,7 @@
           </a:fontRef>
         </p:style>
         <p:txBody>
-          <a:bodyPr rtlCol="0" anchor="ctr" wrap="square"/>
+          <a:bodyPr wrap="square" rtlCol="0" anchor="ctr"/>
           <a:lstStyle/>
           <a:p>
             <a:pPr algn="ctr"/>
@@ -9324,7 +9445,7 @@
           </a:fontRef>
         </p:style>
         <p:txBody>
-          <a:bodyPr rtlCol="0" anchor="ctr" wrap="square"/>
+          <a:bodyPr wrap="square" rtlCol="0" anchor="ctr"/>
           <a:lstStyle/>
           <a:p>
             <a:pPr algn="ctr"/>
@@ -9425,7 +9546,7 @@
 </file>
 
 <file path=ppt/slides/slide6.xml><?xml version="1.0" encoding="utf-8"?>
-<p:sld xmlns:a="http://schemas.openxmlformats.org/drawingml/2006/main" xmlns:p="http://schemas.openxmlformats.org/presentationml/2006/main" xmlns:r="http://schemas.openxmlformats.org/officeDocument/2006/relationships">
+<p:sld xmlns:a="http://schemas.openxmlformats.org/drawingml/2006/main" xmlns:r="http://schemas.openxmlformats.org/officeDocument/2006/relationships" xmlns:p="http://schemas.openxmlformats.org/presentationml/2006/main">
   <p:cSld>
     <p:bg>
       <p:bgPr>
@@ -9441,7 +9562,14 @@
         <p:cNvGrpSpPr/>
         <p:nvPr/>
       </p:nvGrpSpPr>
-      <p:grpSpPr/>
+      <p:grpSpPr>
+        <a:xfrm>
+          <a:off x="0" y="0"/>
+          <a:ext cx="0" cy="0"/>
+          <a:chOff x="0" y="0"/>
+          <a:chExt cx="0" cy="0"/>
+        </a:xfrm>
+      </p:grpSpPr>
       <p:sp>
         <p:nvSpPr>
           <p:cNvPr id="2" name="TextBox 1"/>
@@ -9459,7 +9587,7 @@
           <a:noFill/>
         </p:spPr>
         <p:txBody>
-          <a:bodyPr wrap="square" lIns="0" rIns="0" tIns="0" bIns="0">
+          <a:bodyPr wrap="square" lIns="0" tIns="0" rIns="0" bIns="0">
             <a:spAutoFit/>
           </a:bodyPr>
           <a:lstStyle/>
@@ -9493,7 +9621,7 @@
           <a:noFill/>
         </p:spPr>
         <p:txBody>
-          <a:bodyPr wrap="square" lIns="0" rIns="0" tIns="0" bIns="0">
+          <a:bodyPr wrap="square" lIns="0" tIns="0" rIns="0" bIns="0">
             <a:spAutoFit/>
           </a:bodyPr>
           <a:lstStyle/>
@@ -9527,7 +9655,7 @@
           <a:noFill/>
         </p:spPr>
         <p:txBody>
-          <a:bodyPr wrap="square" lIns="0" rIns="0" tIns="0" bIns="0">
+          <a:bodyPr wrap="square" lIns="0" tIns="0" rIns="0" bIns="0">
             <a:spAutoFit/>
           </a:bodyPr>
           <a:lstStyle/>
@@ -9673,7 +9801,7 @@
           </a:fontRef>
         </p:style>
         <p:txBody>
-          <a:bodyPr rtlCol="0" anchor="ctr" wrap="square" lIns="182880" rIns="182880" tIns="109728" bIns="109728"/>
+          <a:bodyPr wrap="square" lIns="182880" tIns="109728" rIns="182880" bIns="109728" rtlCol="0" anchor="ctr"/>
           <a:lstStyle/>
           <a:p>
             <a:pPr algn="ctr">
@@ -9742,7 +9870,7 @@
           </a:fontRef>
         </p:style>
         <p:txBody>
-          <a:bodyPr rtlCol="0" anchor="ctr" wrap="square" lIns="228600" rIns="228600" tIns="182880" bIns="182880"/>
+          <a:bodyPr wrap="square" lIns="228600" tIns="182880" rIns="228600" bIns="182880" rtlCol="0" anchor="ctr"/>
           <a:lstStyle/>
           <a:p>
             <a:pPr algn="ctr">
@@ -10005,7 +10133,7 @@
 </file>
 
 <file path=ppt/slides/slide7.xml><?xml version="1.0" encoding="utf-8"?>
-<p:sld xmlns:a="http://schemas.openxmlformats.org/drawingml/2006/main" xmlns:p="http://schemas.openxmlformats.org/presentationml/2006/main" xmlns:r="http://schemas.openxmlformats.org/officeDocument/2006/relationships">
+<p:sld xmlns:a="http://schemas.openxmlformats.org/drawingml/2006/main" xmlns:r="http://schemas.openxmlformats.org/officeDocument/2006/relationships" xmlns:p="http://schemas.openxmlformats.org/presentationml/2006/main">
   <p:cSld>
     <p:bg>
       <p:bgPr>
@@ -10021,7 +10149,14 @@
         <p:cNvGrpSpPr/>
         <p:nvPr/>
       </p:nvGrpSpPr>
-      <p:grpSpPr/>
+      <p:grpSpPr>
+        <a:xfrm>
+          <a:off x="0" y="0"/>
+          <a:ext cx="0" cy="0"/>
+          <a:chOff x="0" y="0"/>
+          <a:chExt cx="0" cy="0"/>
+        </a:xfrm>
+      </p:grpSpPr>
       <p:sp>
         <p:nvSpPr>
           <p:cNvPr id="2" name="TextBox 1"/>
@@ -10039,7 +10174,7 @@
           <a:noFill/>
         </p:spPr>
         <p:txBody>
-          <a:bodyPr wrap="square" lIns="0" rIns="0" tIns="0" bIns="0">
+          <a:bodyPr wrap="square" lIns="0" tIns="0" rIns="0" bIns="0">
             <a:spAutoFit/>
           </a:bodyPr>
           <a:lstStyle/>
@@ -10073,7 +10208,7 @@
           <a:noFill/>
         </p:spPr>
         <p:txBody>
-          <a:bodyPr wrap="square" lIns="0" rIns="0" tIns="0" bIns="0">
+          <a:bodyPr wrap="square" lIns="0" tIns="0" rIns="0" bIns="0">
             <a:spAutoFit/>
           </a:bodyPr>
           <a:lstStyle/>
@@ -10107,7 +10242,7 @@
           <a:noFill/>
         </p:spPr>
         <p:txBody>
-          <a:bodyPr wrap="square" lIns="0" rIns="0" tIns="0" bIns="0">
+          <a:bodyPr wrap="square" lIns="0" tIns="0" rIns="0" bIns="0">
             <a:spAutoFit/>
           </a:bodyPr>
           <a:lstStyle/>
@@ -10253,7 +10388,7 @@
           </a:fontRef>
         </p:style>
         <p:txBody>
-          <a:bodyPr rtlCol="0" anchor="ctr" wrap="square" lIns="182880" rIns="182880" tIns="109728" bIns="109728"/>
+          <a:bodyPr wrap="square" lIns="182880" tIns="109728" rIns="182880" bIns="109728" rtlCol="0" anchor="ctr"/>
           <a:lstStyle/>
           <a:p>
             <a:pPr algn="ctr">
@@ -10322,7 +10457,7 @@
           </a:fontRef>
         </p:style>
         <p:txBody>
-          <a:bodyPr rtlCol="0" anchor="ctr" wrap="square" lIns="228600" rIns="228600" tIns="182880" bIns="182880"/>
+          <a:bodyPr wrap="square" lIns="228600" tIns="182880" rIns="228600" bIns="182880" rtlCol="0" anchor="ctr"/>
           <a:lstStyle/>
           <a:p>
             <a:pPr algn="ctr">
@@ -10382,6 +10517,7 @@
           <a:lstStyle/>
           <a:p>
             <a:pPr algn="ctr"/>
+            <a:endParaRPr/>
           </a:p>
         </p:txBody>
       </p:sp>
@@ -10425,6 +10561,7 @@
           <a:lstStyle/>
           <a:p>
             <a:pPr algn="ctr"/>
+            <a:endParaRPr/>
           </a:p>
         </p:txBody>
       </p:sp>
@@ -10468,6 +10605,7 @@
           <a:lstStyle/>
           <a:p>
             <a:pPr algn="ctr"/>
+            <a:endParaRPr/>
           </a:p>
         </p:txBody>
       </p:sp>
@@ -10511,6 +10649,7 @@
           <a:lstStyle/>
           <a:p>
             <a:pPr algn="ctr"/>
+            <a:endParaRPr/>
           </a:p>
         </p:txBody>
       </p:sp>
@@ -10554,6 +10693,7 @@
           <a:lstStyle/>
           <a:p>
             <a:pPr algn="ctr"/>
+            <a:endParaRPr/>
           </a:p>
         </p:txBody>
       </p:sp>
@@ -10636,7 +10776,7 @@
 </file>
 
 <file path=ppt/slides/slide8.xml><?xml version="1.0" encoding="utf-8"?>
-<p:sld xmlns:a="http://schemas.openxmlformats.org/drawingml/2006/main" xmlns:p="http://schemas.openxmlformats.org/presentationml/2006/main" xmlns:r="http://schemas.openxmlformats.org/officeDocument/2006/relationships">
+<p:sld xmlns:a="http://schemas.openxmlformats.org/drawingml/2006/main" xmlns:r="http://schemas.openxmlformats.org/officeDocument/2006/relationships" xmlns:p="http://schemas.openxmlformats.org/presentationml/2006/main">
   <p:cSld>
     <p:bg>
       <p:bgPr>
@@ -10652,7 +10792,14 @@
         <p:cNvGrpSpPr/>
         <p:nvPr/>
       </p:nvGrpSpPr>
-      <p:grpSpPr/>
+      <p:grpSpPr>
+        <a:xfrm>
+          <a:off x="0" y="0"/>
+          <a:ext cx="0" cy="0"/>
+          <a:chOff x="0" y="0"/>
+          <a:chExt cx="0" cy="0"/>
+        </a:xfrm>
+      </p:grpSpPr>
       <p:sp>
         <p:nvSpPr>
           <p:cNvPr id="2" name="TextBox 1"/>
@@ -10670,7 +10817,7 @@
           <a:noFill/>
         </p:spPr>
         <p:txBody>
-          <a:bodyPr wrap="square" lIns="0" rIns="0" tIns="0" bIns="0">
+          <a:bodyPr wrap="square" lIns="0" tIns="0" rIns="0" bIns="0">
             <a:spAutoFit/>
           </a:bodyPr>
           <a:lstStyle/>
@@ -10704,7 +10851,7 @@
           <a:noFill/>
         </p:spPr>
         <p:txBody>
-          <a:bodyPr wrap="square" lIns="0" rIns="0" tIns="0" bIns="0">
+          <a:bodyPr wrap="square" lIns="0" tIns="0" rIns="0" bIns="0">
             <a:spAutoFit/>
           </a:bodyPr>
           <a:lstStyle/>
@@ -10793,7 +10940,7 @@
           </a:fontRef>
         </p:style>
         <p:txBody>
-          <a:bodyPr rtlCol="0" anchor="ctr" wrap="square" lIns="228600" rIns="228600" tIns="182880" bIns="182880"/>
+          <a:bodyPr wrap="square" lIns="228600" tIns="182880" rIns="228600" bIns="182880" rtlCol="0" anchor="ctr"/>
           <a:lstStyle/>
           <a:p>
             <a:pPr algn="ctr">
@@ -10889,6 +11036,12 @@
                 <a:spcPts val="200"/>
               </a:spcAft>
             </a:pPr>
+            <a:endParaRPr sz="950" b="0" i="0">
+              <a:solidFill>
+                <a:srgbClr val="18181B"/>
+              </a:solidFill>
+              <a:latin typeface="Consolas"/>
+            </a:endParaRPr>
           </a:p>
           <a:p>
             <a:pPr>
@@ -10966,8 +11119,193 @@
                 </a:solidFill>
                 <a:latin typeface="Consolas"/>
               </a:rPr>
+              <a:t>, </a:t>
+            </a:r>
+            <a:r>
+              <a:rPr sz="950" b="0" i="0">
+                <a:solidFill>
+                  <a:srgbClr val="18181B"/>
+                </a:solidFill>
+                <a:latin typeface="Consolas"/>
+              </a:rPr>
+              <a:t>location</a:t>
+            </a:r>
+            <a:r>
+              <a:rPr sz="950" b="0" i="0">
+                <a:solidFill>
+                  <a:srgbClr val="3F3F46"/>
+                </a:solidFill>
+                <a:latin typeface="Consolas"/>
+              </a:rPr>
+              <a:t>=</a:t>
+            </a:r>
+            <a:r>
+              <a:rPr sz="950" b="0" i="0">
+                <a:solidFill>
+                  <a:srgbClr val="047857"/>
+                </a:solidFill>
+                <a:latin typeface="Consolas"/>
+              </a:rPr>
+              <a:t>"us-central1"</a:t>
+            </a:r>
+            <a:r>
+              <a:rPr sz="950" b="0" i="0">
+                <a:solidFill>
+                  <a:srgbClr val="3F3F46"/>
+                </a:solidFill>
+                <a:latin typeface="Consolas"/>
+              </a:rPr>
+              <a:t>)</a:t>
+            </a:r>
+          </a:p>
+          <a:p>
+            <a:pPr>
+              <a:spcAft>
+                <a:spcPts val="200"/>
+              </a:spcAft>
+            </a:pPr>
+            <a:endParaRPr sz="950" b="0" i="0">
+              <a:solidFill>
+                <a:srgbClr val="3F3F46"/>
+              </a:solidFill>
+              <a:latin typeface="Consolas"/>
+            </a:endParaRPr>
+          </a:p>
+          <a:p>
+            <a:pPr>
+              <a:spcAft>
+                <a:spcPts val="200"/>
+              </a:spcAft>
+            </a:pPr>
+            <a:r>
+              <a:rPr sz="950" b="0" i="1">
+                <a:solidFill>
+                  <a:srgbClr val="71717A"/>
+                </a:solidFill>
+                <a:latin typeface="Consolas"/>
+              </a:rPr>
+              <a:t># Define reference to registered Feature View</a:t>
+            </a:r>
+          </a:p>
+          <a:p>
+            <a:pPr>
+              <a:spcAft>
+                <a:spcPts val="200"/>
+              </a:spcAft>
+            </a:pPr>
+            <a:r>
+              <a:rPr sz="950" b="0" i="0">
+                <a:solidFill>
+                  <a:srgbClr val="18181B"/>
+                </a:solidFill>
+                <a:latin typeface="Consolas"/>
+              </a:rPr>
+              <a:t>feature_view</a:t>
+            </a:r>
+            <a:r>
+              <a:rPr sz="950" b="0" i="0">
+                <a:solidFill>
+                  <a:srgbClr val="3F3F46"/>
+                </a:solidFill>
+                <a:latin typeface="Consolas"/>
+              </a:rPr>
+              <a:t> = </a:t>
+            </a:r>
+            <a:r>
+              <a:rPr sz="950" b="0" i="0">
+                <a:solidFill>
+                  <a:srgbClr val="18181B"/>
+                </a:solidFill>
+                <a:latin typeface="Consolas"/>
+              </a:rPr>
+              <a:t>aiplatform</a:t>
+            </a:r>
+            <a:r>
+              <a:rPr sz="950" b="0" i="0">
+                <a:solidFill>
+                  <a:srgbClr val="3F3F46"/>
+                </a:solidFill>
+                <a:latin typeface="Consolas"/>
+              </a:rPr>
+              <a:t>.</a:t>
+            </a:r>
+            <a:r>
+              <a:rPr sz="950" b="0" i="0">
+                <a:solidFill>
+                  <a:srgbClr val="18181B"/>
+                </a:solidFill>
+                <a:latin typeface="Consolas"/>
+              </a:rPr>
+              <a:t>FeatureView</a:t>
+            </a:r>
+            <a:r>
+              <a:rPr sz="950" b="0" i="0">
+                <a:solidFill>
+                  <a:srgbClr val="3F3F46"/>
+                </a:solidFill>
+                <a:latin typeface="Consolas"/>
+              </a:rPr>
+              <a:t>(</a:t>
+            </a:r>
+          </a:p>
+          <a:p>
+            <a:pPr>
+              <a:spcAft>
+                <a:spcPts val="200"/>
+              </a:spcAft>
+            </a:pPr>
+            <a:r>
+              <a:rPr sz="950" b="0" i="0">
+                <a:solidFill>
+                  <a:srgbClr val="3F3F46"/>
+                </a:solidFill>
+                <a:latin typeface="Consolas"/>
+              </a:rPr>
+              <a:t>    </a:t>
+            </a:r>
+            <a:r>
+              <a:rPr sz="950" b="0" i="0">
+                <a:solidFill>
+                  <a:srgbClr val="18181B"/>
+                </a:solidFill>
+                <a:latin typeface="Consolas"/>
+              </a:rPr>
+              <a:t>feature_view_name</a:t>
+            </a:r>
+            <a:r>
+              <a:rPr sz="950" b="0" i="0">
+                <a:solidFill>
+                  <a:srgbClr val="3F3F46"/>
+                </a:solidFill>
+                <a:latin typeface="Consolas"/>
+              </a:rPr>
+              <a:t>=</a:t>
+            </a:r>
+            <a:r>
+              <a:rPr sz="950" b="0" i="0">
+                <a:solidFill>
+                  <a:srgbClr val="047857"/>
+                </a:solidFill>
+                <a:latin typeface="Consolas"/>
+              </a:rPr>
+              <a:t>"user_features"</a:t>
+            </a:r>
+            <a:r>
+              <a:rPr sz="950" b="0" i="0">
+                <a:solidFill>
+                  <a:srgbClr val="3F3F46"/>
+                </a:solidFill>
+                <a:latin typeface="Consolas"/>
+              </a:rPr>
               <a:t>,</a:t>
             </a:r>
+          </a:p>
+          <a:p>
+            <a:pPr>
+              <a:spcAft>
+                <a:spcPts val="200"/>
+              </a:spcAft>
+            </a:pPr>
             <a:r>
               <a:rPr sz="950" b="0" i="0">
                 <a:solidFill>
@@ -10975,7 +11313,7 @@
                 </a:solidFill>
                 <a:latin typeface="Consolas"/>
               </a:rPr>
-              <a:t> </a:t>
+              <a:t>    </a:t>
             </a:r>
             <a:r>
               <a:rPr sz="950" b="0" i="0">
@@ -10984,7 +11322,7 @@
                 </a:solidFill>
                 <a:latin typeface="Consolas"/>
               </a:rPr>
-              <a:t>location</a:t>
+              <a:t>feature_online_store_id</a:t>
             </a:r>
             <a:r>
               <a:rPr sz="950" b="0" i="0">
@@ -11002,8 +11340,15 @@
                 </a:solidFill>
                 <a:latin typeface="Consolas"/>
               </a:rPr>
-              <a:t>"us-central1"</a:t>
-            </a:r>
+              <a:t>"user_online_store"</a:t>
+            </a:r>
+          </a:p>
+          <a:p>
+            <a:pPr>
+              <a:spcAft>
+                <a:spcPts val="200"/>
+              </a:spcAft>
+            </a:pPr>
             <a:r>
               <a:rPr sz="950" b="0" i="0">
                 <a:solidFill>
@@ -11020,6 +11365,12 @@
                 <a:spcPts val="200"/>
               </a:spcAft>
             </a:pPr>
+            <a:endParaRPr sz="950" b="0" i="0">
+              <a:solidFill>
+                <a:srgbClr val="3F3F46"/>
+              </a:solidFill>
+              <a:latin typeface="Consolas"/>
+            </a:endParaRPr>
           </a:p>
           <a:p>
             <a:pPr>
@@ -11034,7 +11385,7 @@
                 </a:solidFill>
                 <a:latin typeface="Consolas"/>
               </a:rPr>
-              <a:t># Define reference to registered Feature View</a:t>
+              <a:t># Fetch real-time online feature values</a:t>
             </a:r>
           </a:p>
           <a:p>
@@ -11050,6 +11401,24 @@
                 </a:solidFill>
                 <a:latin typeface="Consolas"/>
               </a:rPr>
+              <a:t>response</a:t>
+            </a:r>
+            <a:r>
+              <a:rPr sz="950" b="0" i="0">
+                <a:solidFill>
+                  <a:srgbClr val="3F3F46"/>
+                </a:solidFill>
+                <a:latin typeface="Consolas"/>
+              </a:rPr>
+              <a:t> = </a:t>
+            </a:r>
+            <a:r>
+              <a:rPr sz="950" b="0" i="0">
+                <a:solidFill>
+                  <a:srgbClr val="18181B"/>
+                </a:solidFill>
+                <a:latin typeface="Consolas"/>
+              </a:rPr>
               <a:t>feature_view</a:t>
             </a:r>
             <a:r>
@@ -11059,16 +11428,16 @@
                 </a:solidFill>
                 <a:latin typeface="Consolas"/>
               </a:rPr>
-              <a:t> </a:t>
+              <a:t>.</a:t>
             </a:r>
             <a:r>
               <a:rPr sz="950" b="0" i="0">
                 <a:solidFill>
-                  <a:srgbClr val="3F3F46"/>
+                  <a:srgbClr val="18181B"/>
                 </a:solidFill>
                 <a:latin typeface="Consolas"/>
               </a:rPr>
-              <a:t>=</a:t>
+              <a:t>read_feature_values</a:t>
             </a:r>
             <a:r>
               <a:rPr sz="950" b="0" i="0">
@@ -11077,16 +11446,32 @@
                 </a:solidFill>
                 <a:latin typeface="Consolas"/>
               </a:rPr>
-              <a:t> </a:t>
-            </a:r>
+              <a:t>(</a:t>
+            </a:r>
+          </a:p>
+          <a:p>
+            <a:pPr>
+              <a:spcAft>
+                <a:spcPts val="200"/>
+              </a:spcAft>
+            </a:pPr>
             <a:r>
               <a:rPr sz="950" b="0" i="0">
                 <a:solidFill>
+                  <a:srgbClr val="3F3F46"/>
+                </a:solidFill>
+                <a:latin typeface="Consolas"/>
+              </a:rPr>
+              <a:t>    </a:t>
+            </a:r>
+            <a:r>
+              <a:rPr sz="950" b="0" i="0">
+                <a:solidFill>
                   <a:srgbClr val="18181B"/>
                 </a:solidFill>
                 <a:latin typeface="Consolas"/>
               </a:rPr>
-              <a:t>aiplatform</a:t>
+              <a:t>entity_ids</a:t>
             </a:r>
             <a:r>
               <a:rPr sz="950" b="0" i="0">
@@ -11095,362 +11480,7 @@
                 </a:solidFill>
                 <a:latin typeface="Consolas"/>
               </a:rPr>
-              <a:t>.</a:t>
-            </a:r>
-            <a:r>
-              <a:rPr sz="950" b="0" i="0">
-                <a:solidFill>
-                  <a:srgbClr val="18181B"/>
-                </a:solidFill>
-                <a:latin typeface="Consolas"/>
-              </a:rPr>
-              <a:t>FeatureView</a:t>
-            </a:r>
-            <a:r>
-              <a:rPr sz="950" b="0" i="0">
-                <a:solidFill>
-                  <a:srgbClr val="3F3F46"/>
-                </a:solidFill>
-                <a:latin typeface="Consolas"/>
-              </a:rPr>
-              <a:t>(</a:t>
-            </a:r>
-          </a:p>
-          <a:p>
-            <a:pPr>
-              <a:spcAft>
-                <a:spcPts val="200"/>
-              </a:spcAft>
-            </a:pPr>
-            <a:r>
-              <a:rPr sz="950" b="0" i="0">
-                <a:solidFill>
-                  <a:srgbClr val="3F3F46"/>
-                </a:solidFill>
-                <a:latin typeface="Consolas"/>
-              </a:rPr>
-              <a:t> </a:t>
-            </a:r>
-            <a:r>
-              <a:rPr sz="950" b="0" i="0">
-                <a:solidFill>
-                  <a:srgbClr val="3F3F46"/>
-                </a:solidFill>
-                <a:latin typeface="Consolas"/>
-              </a:rPr>
-              <a:t> </a:t>
-            </a:r>
-            <a:r>
-              <a:rPr sz="950" b="0" i="0">
-                <a:solidFill>
-                  <a:srgbClr val="3F3F46"/>
-                </a:solidFill>
-                <a:latin typeface="Consolas"/>
-              </a:rPr>
-              <a:t> </a:t>
-            </a:r>
-            <a:r>
-              <a:rPr sz="950" b="0" i="0">
-                <a:solidFill>
-                  <a:srgbClr val="3F3F46"/>
-                </a:solidFill>
-                <a:latin typeface="Consolas"/>
-              </a:rPr>
-              <a:t> </a:t>
-            </a:r>
-            <a:r>
-              <a:rPr sz="950" b="0" i="0">
-                <a:solidFill>
-                  <a:srgbClr val="18181B"/>
-                </a:solidFill>
-                <a:latin typeface="Consolas"/>
-              </a:rPr>
-              <a:t>feature_view_name</a:t>
-            </a:r>
-            <a:r>
-              <a:rPr sz="950" b="0" i="0">
-                <a:solidFill>
-                  <a:srgbClr val="3F3F46"/>
-                </a:solidFill>
-                <a:latin typeface="Consolas"/>
-              </a:rPr>
-              <a:t>=</a:t>
-            </a:r>
-            <a:r>
-              <a:rPr sz="950" b="0" i="0">
-                <a:solidFill>
-                  <a:srgbClr val="047857"/>
-                </a:solidFill>
-                <a:latin typeface="Consolas"/>
-              </a:rPr>
-              <a:t>"user_features"</a:t>
-            </a:r>
-            <a:r>
-              <a:rPr sz="950" b="0" i="0">
-                <a:solidFill>
-                  <a:srgbClr val="3F3F46"/>
-                </a:solidFill>
-                <a:latin typeface="Consolas"/>
-              </a:rPr>
-              <a:t>,</a:t>
-            </a:r>
-          </a:p>
-          <a:p>
-            <a:pPr>
-              <a:spcAft>
-                <a:spcPts val="200"/>
-              </a:spcAft>
-            </a:pPr>
-            <a:r>
-              <a:rPr sz="950" b="0" i="0">
-                <a:solidFill>
-                  <a:srgbClr val="3F3F46"/>
-                </a:solidFill>
-                <a:latin typeface="Consolas"/>
-              </a:rPr>
-              <a:t> </a:t>
-            </a:r>
-            <a:r>
-              <a:rPr sz="950" b="0" i="0">
-                <a:solidFill>
-                  <a:srgbClr val="3F3F46"/>
-                </a:solidFill>
-                <a:latin typeface="Consolas"/>
-              </a:rPr>
-              <a:t> </a:t>
-            </a:r>
-            <a:r>
-              <a:rPr sz="950" b="0" i="0">
-                <a:solidFill>
-                  <a:srgbClr val="3F3F46"/>
-                </a:solidFill>
-                <a:latin typeface="Consolas"/>
-              </a:rPr>
-              <a:t> </a:t>
-            </a:r>
-            <a:r>
-              <a:rPr sz="950" b="0" i="0">
-                <a:solidFill>
-                  <a:srgbClr val="3F3F46"/>
-                </a:solidFill>
-                <a:latin typeface="Consolas"/>
-              </a:rPr>
-              <a:t> </a:t>
-            </a:r>
-            <a:r>
-              <a:rPr sz="950" b="0" i="0">
-                <a:solidFill>
-                  <a:srgbClr val="18181B"/>
-                </a:solidFill>
-                <a:latin typeface="Consolas"/>
-              </a:rPr>
-              <a:t>feature_online_store_id</a:t>
-            </a:r>
-            <a:r>
-              <a:rPr sz="950" b="0" i="0">
-                <a:solidFill>
-                  <a:srgbClr val="3F3F46"/>
-                </a:solidFill>
-                <a:latin typeface="Consolas"/>
-              </a:rPr>
-              <a:t>=</a:t>
-            </a:r>
-            <a:r>
-              <a:rPr sz="950" b="0" i="0">
-                <a:solidFill>
-                  <a:srgbClr val="047857"/>
-                </a:solidFill>
-                <a:latin typeface="Consolas"/>
-              </a:rPr>
-              <a:t>"user_online_store"</a:t>
-            </a:r>
-          </a:p>
-          <a:p>
-            <a:pPr>
-              <a:spcAft>
-                <a:spcPts val="200"/>
-              </a:spcAft>
-            </a:pPr>
-            <a:r>
-              <a:rPr sz="950" b="0" i="0">
-                <a:solidFill>
-                  <a:srgbClr val="3F3F46"/>
-                </a:solidFill>
-                <a:latin typeface="Consolas"/>
-              </a:rPr>
-              <a:t>)</a:t>
-            </a:r>
-          </a:p>
-          <a:p>
-            <a:pPr>
-              <a:spcAft>
-                <a:spcPts val="200"/>
-              </a:spcAft>
-            </a:pPr>
-          </a:p>
-          <a:p>
-            <a:pPr>
-              <a:spcAft>
-                <a:spcPts val="200"/>
-              </a:spcAft>
-            </a:pPr>
-            <a:r>
-              <a:rPr sz="950" b="0" i="1">
-                <a:solidFill>
-                  <a:srgbClr val="71717A"/>
-                </a:solidFill>
-                <a:latin typeface="Consolas"/>
-              </a:rPr>
-              <a:t># Fetch real-time online feature values</a:t>
-            </a:r>
-          </a:p>
-          <a:p>
-            <a:pPr>
-              <a:spcAft>
-                <a:spcPts val="200"/>
-              </a:spcAft>
-            </a:pPr>
-            <a:r>
-              <a:rPr sz="950" b="0" i="0">
-                <a:solidFill>
-                  <a:srgbClr val="18181B"/>
-                </a:solidFill>
-                <a:latin typeface="Consolas"/>
-              </a:rPr>
-              <a:t>response</a:t>
-            </a:r>
-            <a:r>
-              <a:rPr sz="950" b="0" i="0">
-                <a:solidFill>
-                  <a:srgbClr val="3F3F46"/>
-                </a:solidFill>
-                <a:latin typeface="Consolas"/>
-              </a:rPr>
-              <a:t> </a:t>
-            </a:r>
-            <a:r>
-              <a:rPr sz="950" b="0" i="0">
-                <a:solidFill>
-                  <a:srgbClr val="3F3F46"/>
-                </a:solidFill>
-                <a:latin typeface="Consolas"/>
-              </a:rPr>
-              <a:t>=</a:t>
-            </a:r>
-            <a:r>
-              <a:rPr sz="950" b="0" i="0">
-                <a:solidFill>
-                  <a:srgbClr val="3F3F46"/>
-                </a:solidFill>
-                <a:latin typeface="Consolas"/>
-              </a:rPr>
-              <a:t> </a:t>
-            </a:r>
-            <a:r>
-              <a:rPr sz="950" b="0" i="0">
-                <a:solidFill>
-                  <a:srgbClr val="18181B"/>
-                </a:solidFill>
-                <a:latin typeface="Consolas"/>
-              </a:rPr>
-              <a:t>feature_view</a:t>
-            </a:r>
-            <a:r>
-              <a:rPr sz="950" b="0" i="0">
-                <a:solidFill>
-                  <a:srgbClr val="3F3F46"/>
-                </a:solidFill>
-                <a:latin typeface="Consolas"/>
-              </a:rPr>
-              <a:t>.</a:t>
-            </a:r>
-            <a:r>
-              <a:rPr sz="950" b="0" i="0">
-                <a:solidFill>
-                  <a:srgbClr val="18181B"/>
-                </a:solidFill>
-                <a:latin typeface="Consolas"/>
-              </a:rPr>
-              <a:t>read_feature_values</a:t>
-            </a:r>
-            <a:r>
-              <a:rPr sz="950" b="0" i="0">
-                <a:solidFill>
-                  <a:srgbClr val="3F3F46"/>
-                </a:solidFill>
-                <a:latin typeface="Consolas"/>
-              </a:rPr>
-              <a:t>(</a:t>
-            </a:r>
-          </a:p>
-          <a:p>
-            <a:pPr>
-              <a:spcAft>
-                <a:spcPts val="200"/>
-              </a:spcAft>
-            </a:pPr>
-            <a:r>
-              <a:rPr sz="950" b="0" i="0">
-                <a:solidFill>
-                  <a:srgbClr val="3F3F46"/>
-                </a:solidFill>
-                <a:latin typeface="Consolas"/>
-              </a:rPr>
-              <a:t> </a:t>
-            </a:r>
-            <a:r>
-              <a:rPr sz="950" b="0" i="0">
-                <a:solidFill>
-                  <a:srgbClr val="3F3F46"/>
-                </a:solidFill>
-                <a:latin typeface="Consolas"/>
-              </a:rPr>
-              <a:t> </a:t>
-            </a:r>
-            <a:r>
-              <a:rPr sz="950" b="0" i="0">
-                <a:solidFill>
-                  <a:srgbClr val="3F3F46"/>
-                </a:solidFill>
-                <a:latin typeface="Consolas"/>
-              </a:rPr>
-              <a:t> </a:t>
-            </a:r>
-            <a:r>
-              <a:rPr sz="950" b="0" i="0">
-                <a:solidFill>
-                  <a:srgbClr val="3F3F46"/>
-                </a:solidFill>
-                <a:latin typeface="Consolas"/>
-              </a:rPr>
-              <a:t> </a:t>
-            </a:r>
-            <a:r>
-              <a:rPr sz="950" b="0" i="0">
-                <a:solidFill>
-                  <a:srgbClr val="18181B"/>
-                </a:solidFill>
-                <a:latin typeface="Consolas"/>
-              </a:rPr>
-              <a:t>entity_ids</a:t>
-            </a:r>
-            <a:r>
-              <a:rPr sz="950" b="0" i="0">
-                <a:solidFill>
-                  <a:srgbClr val="3F3F46"/>
-                </a:solidFill>
-                <a:latin typeface="Consolas"/>
-              </a:rPr>
-              <a:t>=</a:t>
-            </a:r>
-            <a:r>
-              <a:rPr sz="950" b="0" i="0">
-                <a:solidFill>
-                  <a:srgbClr val="3F3F46"/>
-                </a:solidFill>
-                <a:latin typeface="Consolas"/>
-              </a:rPr>
-              <a:t>[</a:t>
+              <a:t>=[</a:t>
             </a:r>
             <a:r>
               <a:rPr sz="950" b="0" i="0">
@@ -11588,7 +11618,7 @@
           </a:fontRef>
         </p:style>
         <p:txBody>
-          <a:bodyPr rtlCol="0" anchor="ctr" wrap="square" lIns="182880" rIns="182880" tIns="109728" bIns="109728"/>
+          <a:bodyPr wrap="square" lIns="182880" tIns="109728" rIns="182880" bIns="109728" rtlCol="0" anchor="ctr"/>
           <a:lstStyle/>
           <a:p>
             <a:pPr algn="ctr">
@@ -11628,7 +11658,7 @@
 </file>
 
 <file path=ppt/slides/slide9.xml><?xml version="1.0" encoding="utf-8"?>
-<p:sld xmlns:a="http://schemas.openxmlformats.org/drawingml/2006/main" xmlns:p="http://schemas.openxmlformats.org/presentationml/2006/main" xmlns:r="http://schemas.openxmlformats.org/officeDocument/2006/relationships">
+<p:sld xmlns:a="http://schemas.openxmlformats.org/drawingml/2006/main" xmlns:r="http://schemas.openxmlformats.org/officeDocument/2006/relationships" xmlns:p="http://schemas.openxmlformats.org/presentationml/2006/main">
   <p:cSld>
     <p:bg>
       <p:bgPr>
@@ -11644,7 +11674,14 @@
         <p:cNvGrpSpPr/>
         <p:nvPr/>
       </p:nvGrpSpPr>
-      <p:grpSpPr/>
+      <p:grpSpPr>
+        <a:xfrm>
+          <a:off x="0" y="0"/>
+          <a:ext cx="0" cy="0"/>
+          <a:chOff x="0" y="0"/>
+          <a:chExt cx="0" cy="0"/>
+        </a:xfrm>
+      </p:grpSpPr>
       <p:sp>
         <p:nvSpPr>
           <p:cNvPr id="2" name="TextBox 1"/>
@@ -11662,7 +11699,7 @@
           <a:noFill/>
         </p:spPr>
         <p:txBody>
-          <a:bodyPr wrap="square" lIns="0" rIns="0" tIns="0" bIns="0">
+          <a:bodyPr wrap="square" lIns="0" tIns="0" rIns="0" bIns="0">
             <a:spAutoFit/>
           </a:bodyPr>
           <a:lstStyle/>
@@ -11696,7 +11733,7 @@
           <a:noFill/>
         </p:spPr>
         <p:txBody>
-          <a:bodyPr wrap="square" lIns="0" rIns="0" tIns="0" bIns="0">
+          <a:bodyPr wrap="square" lIns="0" tIns="0" rIns="0" bIns="0">
             <a:spAutoFit/>
           </a:bodyPr>
           <a:lstStyle/>
@@ -11785,7 +11822,7 @@
           </a:fontRef>
         </p:style>
         <p:txBody>
-          <a:bodyPr rtlCol="0" anchor="ctr" wrap="square" lIns="228600" rIns="228600" tIns="182880" bIns="182880"/>
+          <a:bodyPr wrap="square" lIns="228600" tIns="182880" rIns="228600" bIns="182880" rtlCol="0" anchor="ctr"/>
           <a:lstStyle/>
           <a:p>
             <a:pPr algn="ctr">
@@ -11816,16 +11853,25 @@
                 </a:solidFill>
                 <a:latin typeface="Consolas"/>
               </a:rPr>
-              <a:t>gcloud </a:t>
+              <a:t>gcloud vertex-ai </a:t>
             </a:r>
             <a:r>
               <a:rPr sz="950" b="0" i="0">
                 <a:solidFill>
+                  <a:srgbClr val="18181B"/>
+                </a:solidFill>
+                <a:latin typeface="Consolas"/>
+              </a:rPr>
+              <a:t>feature-online-stores </a:t>
+            </a:r>
+            <a:r>
+              <a:rPr sz="950" b="0" i="0">
+                <a:solidFill>
                   <a:srgbClr val="1D4ED8"/>
                 </a:solidFill>
                 <a:latin typeface="Consolas"/>
               </a:rPr>
-              <a:t>vertex-ai </a:t>
+              <a:t>create </a:t>
             </a:r>
             <a:r>
               <a:rPr sz="950" b="0" i="0">
@@ -11834,16 +11880,97 @@
                 </a:solidFill>
                 <a:latin typeface="Consolas"/>
               </a:rPr>
-              <a:t>feature-online-stores </a:t>
+              <a:t>user-online-store     </a:t>
             </a:r>
             <a:r>
               <a:rPr sz="950" b="0" i="0">
                 <a:solidFill>
+                  <a:srgbClr val="BE185D"/>
+                </a:solidFill>
+                <a:latin typeface="Consolas"/>
+              </a:rPr>
+              <a:t>--region=us-central1 </a:t>
+            </a:r>
+            <a:r>
+              <a:rPr sz="950" b="0" i="0">
+                <a:solidFill>
+                  <a:srgbClr val="18181B"/>
+                </a:solidFill>
+                <a:latin typeface="Consolas"/>
+              </a:rPr>
+              <a:t>    </a:t>
+            </a:r>
+            <a:r>
+              <a:rPr sz="950" b="0" i="0">
+                <a:solidFill>
+                  <a:srgbClr val="BE185D"/>
+                </a:solidFill>
+                <a:latin typeface="Consolas"/>
+              </a:rPr>
+              <a:t>--bigtable-min-node-count=1 </a:t>
+            </a:r>
+            <a:r>
+              <a:rPr sz="950" b="0" i="0">
+                <a:solidFill>
+                  <a:srgbClr val="18181B"/>
+                </a:solidFill>
+                <a:latin typeface="Consolas"/>
+              </a:rPr>
+              <a:t>    </a:t>
+            </a:r>
+            <a:r>
+              <a:rPr sz="950" b="0" i="0">
+                <a:solidFill>
+                  <a:srgbClr val="BE185D"/>
+                </a:solidFill>
+                <a:latin typeface="Consolas"/>
+              </a:rPr>
+              <a:t>--bigtable-max-node-count=5</a:t>
+            </a:r>
+          </a:p>
+          <a:p>
+            <a:pPr>
+              <a:spcAft>
+                <a:spcPts val="200"/>
+              </a:spcAft>
+            </a:pPr>
+            <a:endParaRPr sz="950" b="0" i="0">
+              <a:solidFill>
+                <a:srgbClr val="BE185D"/>
+              </a:solidFill>
+              <a:latin typeface="Consolas"/>
+            </a:endParaRPr>
+          </a:p>
+          <a:p>
+            <a:pPr>
+              <a:spcAft>
+                <a:spcPts val="200"/>
+              </a:spcAft>
+            </a:pPr>
+            <a:r>
+              <a:rPr sz="950" b="0" i="1">
+                <a:solidFill>
+                  <a:srgbClr val="71717A"/>
+                </a:solidFill>
+                <a:latin typeface="Consolas"/>
+              </a:rPr>
+              <a:t># Synchronize feature view with BigQuery source data</a:t>
+            </a:r>
+          </a:p>
+          <a:p>
+            <a:pPr>
+              <a:spcAft>
+                <a:spcPts val="200"/>
+              </a:spcAft>
+            </a:pPr>
+            <a:r>
+              <a:rPr sz="950" b="0" i="0">
+                <a:solidFill>
                   <a:srgbClr val="1D4ED8"/>
                 </a:solidFill>
                 <a:latin typeface="Consolas"/>
               </a:rPr>
-              <a:t>create </a:t>
+              <a:t>gcloud vertex-ai </a:t>
             </a:r>
             <a:r>
               <a:rPr sz="950" b="0" i="0">
@@ -11852,307 +11979,43 @@
                 </a:solidFill>
                 <a:latin typeface="Consolas"/>
               </a:rPr>
-              <a:t>user-online-store </a:t>
+              <a:t>feature-views </a:t>
             </a:r>
             <a:r>
               <a:rPr sz="950" b="0" i="0">
                 <a:solidFill>
+                  <a:srgbClr val="1D4ED8"/>
+                </a:solidFill>
+                <a:latin typeface="Consolas"/>
+              </a:rPr>
+              <a:t>sync </a:t>
+            </a:r>
+            <a:r>
+              <a:rPr sz="950" b="0" i="0">
+                <a:solidFill>
                   <a:srgbClr val="18181B"/>
                 </a:solidFill>
                 <a:latin typeface="Consolas"/>
               </a:rPr>
-              <a:t> </a:t>
+              <a:t>user-features     </a:t>
             </a:r>
             <a:r>
               <a:rPr sz="950" b="0" i="0">
                 <a:solidFill>
+                  <a:srgbClr val="BE185D"/>
+                </a:solidFill>
+                <a:latin typeface="Consolas"/>
+              </a:rPr>
+              <a:t>--feature-online-store=user-online-store </a:t>
+            </a:r>
+            <a:r>
+              <a:rPr sz="950" b="0" i="0">
+                <a:solidFill>
                   <a:srgbClr val="18181B"/>
                 </a:solidFill>
                 <a:latin typeface="Consolas"/>
               </a:rPr>
-              <a:t> </a:t>
-            </a:r>
-            <a:r>
-              <a:rPr sz="950" b="0" i="0">
-                <a:solidFill>
-                  <a:srgbClr val="18181B"/>
-                </a:solidFill>
-                <a:latin typeface="Consolas"/>
-              </a:rPr>
-              <a:t> </a:t>
-            </a:r>
-            <a:r>
-              <a:rPr sz="950" b="0" i="0">
-                <a:solidFill>
-                  <a:srgbClr val="18181B"/>
-                </a:solidFill>
-                <a:latin typeface="Consolas"/>
-              </a:rPr>
-              <a:t> </a:t>
-            </a:r>
-            <a:r>
-              <a:rPr sz="950" b="0" i="0">
-                <a:solidFill>
-                  <a:srgbClr val="BE185D"/>
-                </a:solidFill>
-                <a:latin typeface="Consolas"/>
-              </a:rPr>
-              <a:t>--region=us-central1 </a:t>
-            </a:r>
-            <a:r>
-              <a:rPr sz="950" b="0" i="0">
-                <a:solidFill>
-                  <a:srgbClr val="18181B"/>
-                </a:solidFill>
-                <a:latin typeface="Consolas"/>
-              </a:rPr>
-              <a:t> </a:t>
-            </a:r>
-            <a:r>
-              <a:rPr sz="950" b="0" i="0">
-                <a:solidFill>
-                  <a:srgbClr val="18181B"/>
-                </a:solidFill>
-                <a:latin typeface="Consolas"/>
-              </a:rPr>
-              <a:t> </a:t>
-            </a:r>
-            <a:r>
-              <a:rPr sz="950" b="0" i="0">
-                <a:solidFill>
-                  <a:srgbClr val="18181B"/>
-                </a:solidFill>
-                <a:latin typeface="Consolas"/>
-              </a:rPr>
-              <a:t> </a:t>
-            </a:r>
-            <a:r>
-              <a:rPr sz="950" b="0" i="0">
-                <a:solidFill>
-                  <a:srgbClr val="18181B"/>
-                </a:solidFill>
-                <a:latin typeface="Consolas"/>
-              </a:rPr>
-              <a:t> </a:t>
-            </a:r>
-            <a:r>
-              <a:rPr sz="950" b="0" i="0">
-                <a:solidFill>
-                  <a:srgbClr val="BE185D"/>
-                </a:solidFill>
-                <a:latin typeface="Consolas"/>
-              </a:rPr>
-              <a:t>--bigtable-min-node-count=1 </a:t>
-            </a:r>
-            <a:r>
-              <a:rPr sz="950" b="0" i="0">
-                <a:solidFill>
-                  <a:srgbClr val="18181B"/>
-                </a:solidFill>
-                <a:latin typeface="Consolas"/>
-              </a:rPr>
-              <a:t> </a:t>
-            </a:r>
-            <a:r>
-              <a:rPr sz="950" b="0" i="0">
-                <a:solidFill>
-                  <a:srgbClr val="18181B"/>
-                </a:solidFill>
-                <a:latin typeface="Consolas"/>
-              </a:rPr>
-              <a:t> </a:t>
-            </a:r>
-            <a:r>
-              <a:rPr sz="950" b="0" i="0">
-                <a:solidFill>
-                  <a:srgbClr val="18181B"/>
-                </a:solidFill>
-                <a:latin typeface="Consolas"/>
-              </a:rPr>
-              <a:t> </a:t>
-            </a:r>
-            <a:r>
-              <a:rPr sz="950" b="0" i="0">
-                <a:solidFill>
-                  <a:srgbClr val="18181B"/>
-                </a:solidFill>
-                <a:latin typeface="Consolas"/>
-              </a:rPr>
-              <a:t> </a:t>
-            </a:r>
-            <a:r>
-              <a:rPr sz="950" b="0" i="0">
-                <a:solidFill>
-                  <a:srgbClr val="BE185D"/>
-                </a:solidFill>
-                <a:latin typeface="Consolas"/>
-              </a:rPr>
-              <a:t>--bigtable-max-node-count=5</a:t>
-            </a:r>
-          </a:p>
-          <a:p>
-            <a:pPr>
-              <a:spcAft>
-                <a:spcPts val="200"/>
-              </a:spcAft>
-            </a:pPr>
-            <a:r>
-              <a:rPr sz="950" b="0" i="0">
-                <a:solidFill>
-                  <a:srgbClr val="18181B"/>
-                </a:solidFill>
-                <a:latin typeface="Consolas"/>
-              </a:rPr>
-              <a:t/>
-            </a:r>
-          </a:p>
-          <a:p>
-            <a:pPr>
-              <a:spcAft>
-                <a:spcPts val="200"/>
-              </a:spcAft>
-            </a:pPr>
-            <a:r>
-              <a:rPr sz="950" b="0" i="1">
-                <a:solidFill>
-                  <a:srgbClr val="71717A"/>
-                </a:solidFill>
-                <a:latin typeface="Consolas"/>
-              </a:rPr>
-              <a:t># Synchronize feature view with BigQuery source data</a:t>
-            </a:r>
-          </a:p>
-          <a:p>
-            <a:pPr>
-              <a:spcAft>
-                <a:spcPts val="200"/>
-              </a:spcAft>
-            </a:pPr>
-            <a:r>
-              <a:rPr sz="950" b="0" i="0">
-                <a:solidFill>
-                  <a:srgbClr val="1D4ED8"/>
-                </a:solidFill>
-                <a:latin typeface="Consolas"/>
-              </a:rPr>
-              <a:t>gcloud </a:t>
-            </a:r>
-            <a:r>
-              <a:rPr sz="950" b="0" i="0">
-                <a:solidFill>
-                  <a:srgbClr val="1D4ED8"/>
-                </a:solidFill>
-                <a:latin typeface="Consolas"/>
-              </a:rPr>
-              <a:t>vertex-ai </a:t>
-            </a:r>
-            <a:r>
-              <a:rPr sz="950" b="0" i="0">
-                <a:solidFill>
-                  <a:srgbClr val="18181B"/>
-                </a:solidFill>
-                <a:latin typeface="Consolas"/>
-              </a:rPr>
-              <a:t>feature-views </a:t>
-            </a:r>
-            <a:r>
-              <a:rPr sz="950" b="0" i="0">
-                <a:solidFill>
-                  <a:srgbClr val="1D4ED8"/>
-                </a:solidFill>
-                <a:latin typeface="Consolas"/>
-              </a:rPr>
-              <a:t>sync </a:t>
-            </a:r>
-            <a:r>
-              <a:rPr sz="950" b="0" i="0">
-                <a:solidFill>
-                  <a:srgbClr val="18181B"/>
-                </a:solidFill>
-                <a:latin typeface="Consolas"/>
-              </a:rPr>
-              <a:t>user-features </a:t>
-            </a:r>
-            <a:r>
-              <a:rPr sz="950" b="0" i="0">
-                <a:solidFill>
-                  <a:srgbClr val="18181B"/>
-                </a:solidFill>
-                <a:latin typeface="Consolas"/>
-              </a:rPr>
-              <a:t> </a:t>
-            </a:r>
-            <a:r>
-              <a:rPr sz="950" b="0" i="0">
-                <a:solidFill>
-                  <a:srgbClr val="18181B"/>
-                </a:solidFill>
-                <a:latin typeface="Consolas"/>
-              </a:rPr>
-              <a:t> </a:t>
-            </a:r>
-            <a:r>
-              <a:rPr sz="950" b="0" i="0">
-                <a:solidFill>
-                  <a:srgbClr val="18181B"/>
-                </a:solidFill>
-                <a:latin typeface="Consolas"/>
-              </a:rPr>
-              <a:t> </a:t>
-            </a:r>
-            <a:r>
-              <a:rPr sz="950" b="0" i="0">
-                <a:solidFill>
-                  <a:srgbClr val="18181B"/>
-                </a:solidFill>
-                <a:latin typeface="Consolas"/>
-              </a:rPr>
-              <a:t> </a:t>
-            </a:r>
-            <a:r>
-              <a:rPr sz="950" b="0" i="0">
-                <a:solidFill>
-                  <a:srgbClr val="BE185D"/>
-                </a:solidFill>
-                <a:latin typeface="Consolas"/>
-              </a:rPr>
-              <a:t>--feature-online-store=user-online-store </a:t>
-            </a:r>
-            <a:r>
-              <a:rPr sz="950" b="0" i="0">
-                <a:solidFill>
-                  <a:srgbClr val="18181B"/>
-                </a:solidFill>
-                <a:latin typeface="Consolas"/>
-              </a:rPr>
-              <a:t> </a:t>
-            </a:r>
-            <a:r>
-              <a:rPr sz="950" b="0" i="0">
-                <a:solidFill>
-                  <a:srgbClr val="18181B"/>
-                </a:solidFill>
-                <a:latin typeface="Consolas"/>
-              </a:rPr>
-              <a:t> </a:t>
-            </a:r>
-            <a:r>
-              <a:rPr sz="950" b="0" i="0">
-                <a:solidFill>
-                  <a:srgbClr val="18181B"/>
-                </a:solidFill>
-                <a:latin typeface="Consolas"/>
-              </a:rPr>
-              <a:t> </a:t>
-            </a:r>
-            <a:r>
-              <a:rPr sz="950" b="0" i="0">
-                <a:solidFill>
-                  <a:srgbClr val="18181B"/>
-                </a:solidFill>
-                <a:latin typeface="Consolas"/>
-              </a:rPr>
-              <a:t> </a:t>
+              <a:t>    </a:t>
             </a:r>
             <a:r>
               <a:rPr sz="950" b="0" i="0">
@@ -12204,7 +12067,7 @@
           </a:fontRef>
         </p:style>
         <p:txBody>
-          <a:bodyPr rtlCol="0" anchor="ctr" wrap="square" lIns="182880" rIns="182880" tIns="109728" bIns="109728"/>
+          <a:bodyPr wrap="square" lIns="182880" tIns="109728" rIns="182880" bIns="109728" rtlCol="0" anchor="ctr"/>
           <a:lstStyle/>
           <a:p>
             <a:pPr algn="ctr">

</xml_diff>